<commit_message>
Rework slide layout and improve translation coverage
- Translations now grouped at bottom of each slide (not interleaved)
- Consistent typography: 48pt main, 24pt romaji, 20pt translation
- Aggressive section name normalization resolves most missing PT/JP pairs
- JP slides: 86% now have PT translation (up from ~60%)

Co-Authored-By: Claude Sonnet 4.6 <noreply@anthropic.com>
</commit_message>
<xml_diff>
--- a/output_pptx/10000_Reasons_Bless_The_Lord.pptx
+++ b/output_pptx/10000_Reasons_Bless_The_Lord.pptx
@@ -19,6 +19,18 @@
     <p:sldId id="267" r:id="rId18"/>
     <p:sldId id="268" r:id="rId19"/>
     <p:sldId id="269" r:id="rId20"/>
+    <p:sldId id="270" r:id="rId21"/>
+    <p:sldId id="271" r:id="rId22"/>
+    <p:sldId id="272" r:id="rId23"/>
+    <p:sldId id="273" r:id="rId24"/>
+    <p:sldId id="274" r:id="rId25"/>
+    <p:sldId id="275" r:id="rId26"/>
+    <p:sldId id="276" r:id="rId27"/>
+    <p:sldId id="277" r:id="rId28"/>
+    <p:sldId id="278" r:id="rId29"/>
+    <p:sldId id="279" r:id="rId30"/>
+    <p:sldId id="280" r:id="rId31"/>
+    <p:sldId id="281" r:id="rId32"/>
   </p:sldIdLst>
   <p:sldSz cx="12191695" cy="6858000" type="screen4x3"/>
   <p:notesSz cx="6858000" cy="9144000"/>
@@ -3117,23 +3129,23 @@
         </p:nvSpPr>
         <p:spPr>
           <a:xfrm>
-            <a:off x="594360" y="2258568"/>
-            <a:ext cx="11002975" cy="685800"/>
-          </a:xfrm>
-          <a:prstGeom prst="rect">
-            <a:avLst/>
-          </a:prstGeom>
-          <a:noFill/>
-        </p:spPr>
-        <p:txBody>
-          <a:bodyPr wrap="square">
-            <a:spAutoFit/>
-          </a:bodyPr>
-          <a:lstStyle/>
-          <a:p>
-            <a:pPr algn="ctr"/>
-            <a:r>
-              <a:rPr sz="4400" b="1" i="0">
+            <a:off x="640080" y="2052828"/>
+            <a:ext cx="10911535" cy="731520"/>
+          </a:xfrm>
+          <a:prstGeom prst="rect">
+            <a:avLst/>
+          </a:prstGeom>
+          <a:noFill/>
+        </p:spPr>
+        <p:txBody>
+          <a:bodyPr wrap="square">
+            <a:spAutoFit/>
+          </a:bodyPr>
+          <a:lstStyle/>
+          <a:p>
+            <a:pPr algn="ctr"/>
+            <a:r>
+              <a:rPr sz="4800" b="1" i="0">
                 <a:solidFill>
                   <a:srgbClr val="FFFFFF"/>
                 </a:solidFill>
@@ -3152,29 +3164,29 @@
         </p:nvSpPr>
         <p:spPr>
           <a:xfrm>
-            <a:off x="594360" y="2980944"/>
-            <a:ext cx="11002975" cy="347472"/>
-          </a:xfrm>
-          <a:prstGeom prst="rect">
-            <a:avLst/>
-          </a:prstGeom>
-          <a:noFill/>
-        </p:spPr>
-        <p:txBody>
-          <a:bodyPr wrap="square">
-            <a:spAutoFit/>
-          </a:bodyPr>
-          <a:lstStyle/>
-          <a:p>
-            <a:pPr algn="ctr"/>
-            <a:r>
-              <a:rPr sz="2200" b="0" i="1">
-                <a:solidFill>
-                  <a:srgbClr val="8C8C8C"/>
-                </a:solidFill>
-                <a:latin typeface="Arial"/>
-              </a:rPr>
-              <a:t/>
+            <a:off x="640080" y="2985516"/>
+            <a:ext cx="10911535" cy="731520"/>
+          </a:xfrm>
+          <a:prstGeom prst="rect">
+            <a:avLst/>
+          </a:prstGeom>
+          <a:noFill/>
+        </p:spPr>
+        <p:txBody>
+          <a:bodyPr wrap="square">
+            <a:spAutoFit/>
+          </a:bodyPr>
+          <a:lstStyle/>
+          <a:p>
+            <a:pPr algn="ctr"/>
+            <a:r>
+              <a:rPr sz="4800" b="1" i="0">
+                <a:solidFill>
+                  <a:srgbClr val="FFFFFF"/>
+                </a:solidFill>
+                <a:latin typeface="Arial"/>
+              </a:rPr>
+              <a:t>Ó minha alma</a:t>
             </a:r>
           </a:p>
         </p:txBody>
@@ -3187,29 +3199,29 @@
         </p:nvSpPr>
         <p:spPr>
           <a:xfrm>
-            <a:off x="594360" y="3529584"/>
-            <a:ext cx="11002975" cy="685800"/>
-          </a:xfrm>
-          <a:prstGeom prst="rect">
-            <a:avLst/>
-          </a:prstGeom>
-          <a:noFill/>
-        </p:spPr>
-        <p:txBody>
-          <a:bodyPr wrap="square">
-            <a:spAutoFit/>
-          </a:bodyPr>
-          <a:lstStyle/>
-          <a:p>
-            <a:pPr algn="ctr"/>
-            <a:r>
-              <a:rPr sz="4400" b="1" i="0">
-                <a:solidFill>
-                  <a:srgbClr val="FFFFFF"/>
-                </a:solidFill>
-                <a:latin typeface="Arial"/>
-              </a:rPr>
-              <a:t>Ó minha alma</a:t>
+            <a:off x="640080" y="4128516"/>
+            <a:ext cx="10911535" cy="310896"/>
+          </a:xfrm>
+          <a:prstGeom prst="rect">
+            <a:avLst/>
+          </a:prstGeom>
+          <a:noFill/>
+        </p:spPr>
+        <p:txBody>
+          <a:bodyPr wrap="square">
+            <a:spAutoFit/>
+          </a:bodyPr>
+          <a:lstStyle/>
+          <a:p>
+            <a:pPr algn="ctr"/>
+            <a:r>
+              <a:rPr sz="2000" b="0" i="0">
+                <a:solidFill>
+                  <a:srgbClr val="828282"/>
+                </a:solidFill>
+                <a:latin typeface="Arial"/>
+              </a:rPr>
+              <a:t>たましいよ   ほめ歌え   聖なる   主に</a:t>
             </a:r>
           </a:p>
         </p:txBody>
@@ -3222,29 +3234,29 @@
         </p:nvSpPr>
         <p:spPr>
           <a:xfrm>
-            <a:off x="594360" y="4251960"/>
-            <a:ext cx="11002975" cy="347472"/>
-          </a:xfrm>
-          <a:prstGeom prst="rect">
-            <a:avLst/>
-          </a:prstGeom>
-          <a:noFill/>
-        </p:spPr>
-        <p:txBody>
-          <a:bodyPr wrap="square">
-            <a:spAutoFit/>
-          </a:bodyPr>
-          <a:lstStyle/>
-          <a:p>
-            <a:pPr algn="ctr"/>
-            <a:r>
-              <a:rPr sz="2200" b="0" i="1">
-                <a:solidFill>
-                  <a:srgbClr val="8C8C8C"/>
-                </a:solidFill>
-                <a:latin typeface="Arial"/>
-              </a:rPr>
-              <a:t/>
+            <a:off x="640080" y="4494276"/>
+            <a:ext cx="10911535" cy="310896"/>
+          </a:xfrm>
+          <a:prstGeom prst="rect">
+            <a:avLst/>
+          </a:prstGeom>
+          <a:noFill/>
+        </p:spPr>
+        <p:txBody>
+          <a:bodyPr wrap="square">
+            <a:spAutoFit/>
+          </a:bodyPr>
+          <a:lstStyle/>
+          <a:p>
+            <a:pPr algn="ctr"/>
+            <a:r>
+              <a:rPr sz="2000" b="0" i="0">
+                <a:solidFill>
+                  <a:srgbClr val="828282"/>
+                </a:solidFill>
+                <a:latin typeface="Arial"/>
+              </a:rPr>
+              <a:t>こころ   捧げ  うたえ 素晴らしい  主に</a:t>
             </a:r>
           </a:p>
         </p:txBody>
@@ -3283,29 +3295,29 @@
         </p:nvSpPr>
         <p:spPr>
           <a:xfrm>
-            <a:off x="594360" y="1837944"/>
-            <a:ext cx="11002975" cy="685800"/>
-          </a:xfrm>
-          <a:prstGeom prst="rect">
-            <a:avLst/>
-          </a:prstGeom>
-          <a:noFill/>
-        </p:spPr>
-        <p:txBody>
-          <a:bodyPr wrap="square">
-            <a:spAutoFit/>
-          </a:bodyPr>
-          <a:lstStyle/>
-          <a:p>
-            <a:pPr algn="ctr"/>
-            <a:r>
-              <a:rPr sz="4400" b="1" i="0">
+            <a:off x="640080" y="2052828"/>
+            <a:ext cx="10911535" cy="731520"/>
+          </a:xfrm>
+          <a:prstGeom prst="rect">
+            <a:avLst/>
+          </a:prstGeom>
+          <a:noFill/>
+        </p:spPr>
+        <p:txBody>
+          <a:bodyPr wrap="square">
+            <a:spAutoFit/>
+          </a:bodyPr>
+          <a:lstStyle/>
+          <a:p>
+            <a:pPr algn="ctr"/>
+            <a:r>
+              <a:rPr sz="4800" b="1" i="0">
                 <a:solidFill>
                   <a:srgbClr val="FFFFFF"/>
                 </a:solidFill>
                 <a:latin typeface="Arial"/>
               </a:rPr>
-              <a:t>力    尽きる   ときも</a:t>
+              <a:t>Bendiga o Senhor</a:t>
             </a:r>
           </a:p>
         </p:txBody>
@@ -3318,169 +3330,29 @@
         </p:nvSpPr>
         <p:spPr>
           <a:xfrm>
-            <a:off x="594360" y="2560320"/>
-            <a:ext cx="11002975" cy="384048"/>
-          </a:xfrm>
-          <a:prstGeom prst="rect">
-            <a:avLst/>
-          </a:prstGeom>
-          <a:noFill/>
-        </p:spPr>
-        <p:txBody>
-          <a:bodyPr wrap="square">
-            <a:spAutoFit/>
-          </a:bodyPr>
-          <a:lstStyle/>
-          <a:p>
-            <a:pPr algn="ctr"/>
-            <a:r>
-              <a:rPr sz="2400" b="0" i="1">
-                <a:solidFill>
-                  <a:srgbClr val="B4B4B4"/>
-                </a:solidFill>
-                <a:latin typeface="Arial"/>
-              </a:rPr>
-              <a:t>Chikara Tsukiru tokimo</a:t>
-            </a:r>
-          </a:p>
-        </p:txBody>
-      </p:sp>
-      <p:sp>
-        <p:nvSpPr>
-          <p:cNvPr id="4" name="TextBox 3"/>
-          <p:cNvSpPr txBox="1"/>
-          <p:nvPr/>
-        </p:nvSpPr>
-        <p:spPr>
-          <a:xfrm>
-            <a:off x="594360" y="2980944"/>
-            <a:ext cx="11002975" cy="347472"/>
-          </a:xfrm>
-          <a:prstGeom prst="rect">
-            <a:avLst/>
-          </a:prstGeom>
-          <a:noFill/>
-        </p:spPr>
-        <p:txBody>
-          <a:bodyPr wrap="square">
-            <a:spAutoFit/>
-          </a:bodyPr>
-          <a:lstStyle/>
-          <a:p>
-            <a:pPr algn="ctr"/>
-            <a:r>
-              <a:rPr sz="2000" b="0" i="1">
-                <a:solidFill>
-                  <a:srgbClr val="8C8C8C"/>
-                </a:solidFill>
-                <a:latin typeface="Arial"/>
-              </a:rPr>
-              <a:t/>
-            </a:r>
-          </a:p>
-        </p:txBody>
-      </p:sp>
-      <p:sp>
-        <p:nvSpPr>
-          <p:cNvPr id="5" name="TextBox 4"/>
-          <p:cNvSpPr txBox="1"/>
-          <p:nvPr/>
-        </p:nvSpPr>
-        <p:spPr>
-          <a:xfrm>
-            <a:off x="594360" y="3529584"/>
-            <a:ext cx="11002975" cy="685800"/>
-          </a:xfrm>
-          <a:prstGeom prst="rect">
-            <a:avLst/>
-          </a:prstGeom>
-          <a:noFill/>
-        </p:spPr>
-        <p:txBody>
-          <a:bodyPr wrap="square">
-            <a:spAutoFit/>
-          </a:bodyPr>
-          <a:lstStyle/>
-          <a:p>
-            <a:pPr algn="ctr"/>
-            <a:r>
-              <a:rPr sz="4400" b="1" i="0">
+            <a:off x="640080" y="2985516"/>
+            <a:ext cx="10911535" cy="731520"/>
+          </a:xfrm>
+          <a:prstGeom prst="rect">
+            <a:avLst/>
+          </a:prstGeom>
+          <a:noFill/>
+        </p:spPr>
+        <p:txBody>
+          <a:bodyPr wrap="square">
+            <a:spAutoFit/>
+          </a:bodyPr>
+          <a:lstStyle/>
+          <a:p>
+            <a:pPr algn="ctr"/>
+            <a:r>
+              <a:rPr sz="3400" b="1" i="0">
                 <a:solidFill>
                   <a:srgbClr val="FFFFFF"/>
                 </a:solidFill>
                 <a:latin typeface="Arial"/>
               </a:rPr>
-              <a:t>終わりの  日にも  歌う</a:t>
-            </a:r>
-          </a:p>
-        </p:txBody>
-      </p:sp>
-      <p:sp>
-        <p:nvSpPr>
-          <p:cNvPr id="6" name="TextBox 5"/>
-          <p:cNvSpPr txBox="1"/>
-          <p:nvPr/>
-        </p:nvSpPr>
-        <p:spPr>
-          <a:xfrm>
-            <a:off x="594360" y="4251960"/>
-            <a:ext cx="11002975" cy="384048"/>
-          </a:xfrm>
-          <a:prstGeom prst="rect">
-            <a:avLst/>
-          </a:prstGeom>
-          <a:noFill/>
-        </p:spPr>
-        <p:txBody>
-          <a:bodyPr wrap="square">
-            <a:spAutoFit/>
-          </a:bodyPr>
-          <a:lstStyle/>
-          <a:p>
-            <a:pPr algn="ctr"/>
-            <a:r>
-              <a:rPr sz="2400" b="0" i="1">
-                <a:solidFill>
-                  <a:srgbClr val="B4B4B4"/>
-                </a:solidFill>
-                <a:latin typeface="Arial"/>
-              </a:rPr>
-              <a:t>Owarino Hinimo Utau</a:t>
-            </a:r>
-          </a:p>
-        </p:txBody>
-      </p:sp>
-      <p:sp>
-        <p:nvSpPr>
-          <p:cNvPr id="7" name="TextBox 6"/>
-          <p:cNvSpPr txBox="1"/>
-          <p:nvPr/>
-        </p:nvSpPr>
-        <p:spPr>
-          <a:xfrm>
-            <a:off x="594360" y="4672584"/>
-            <a:ext cx="11002975" cy="347472"/>
-          </a:xfrm>
-          <a:prstGeom prst="rect">
-            <a:avLst/>
-          </a:prstGeom>
-          <a:noFill/>
-        </p:spPr>
-        <p:txBody>
-          <a:bodyPr wrap="square">
-            <a:spAutoFit/>
-          </a:bodyPr>
-          <a:lstStyle/>
-          <a:p>
-            <a:pPr algn="ctr"/>
-            <a:r>
-              <a:rPr sz="2000" b="0" i="1">
-                <a:solidFill>
-                  <a:srgbClr val="8C8C8C"/>
-                </a:solidFill>
-                <a:latin typeface="Arial"/>
-              </a:rPr>
-              <a:t/>
+              <a:t>O sol está se pondo e a madrugada vai cantar</a:t>
             </a:r>
           </a:p>
         </p:txBody>
@@ -3519,29 +3391,29 @@
         </p:nvSpPr>
         <p:spPr>
           <a:xfrm>
-            <a:off x="594360" y="1837944"/>
-            <a:ext cx="11002975" cy="685800"/>
-          </a:xfrm>
-          <a:prstGeom prst="rect">
-            <a:avLst/>
-          </a:prstGeom>
-          <a:noFill/>
-        </p:spPr>
-        <p:txBody>
-          <a:bodyPr wrap="square">
-            <a:spAutoFit/>
-          </a:bodyPr>
-          <a:lstStyle/>
-          <a:p>
-            <a:pPr algn="ctr"/>
-            <a:r>
-              <a:rPr sz="4400" b="1" i="0">
+            <a:off x="640080" y="2052828"/>
+            <a:ext cx="10911535" cy="731520"/>
+          </a:xfrm>
+          <a:prstGeom prst="rect">
+            <a:avLst/>
+          </a:prstGeom>
+          <a:noFill/>
+        </p:spPr>
+        <p:txBody>
+          <a:bodyPr wrap="square">
+            <a:spAutoFit/>
+          </a:bodyPr>
+          <a:lstStyle/>
+          <a:p>
+            <a:pPr algn="ctr"/>
+            <a:r>
+              <a:rPr sz="4000" b="1" i="0">
                 <a:solidFill>
                   <a:srgbClr val="FFFFFF"/>
                 </a:solidFill>
                 <a:latin typeface="Arial"/>
               </a:rPr>
-              <a:t>消え去ること  ない あなたの愛</a:t>
+              <a:t>Quão bom é Ele, quão grande é Seu amor</a:t>
             </a:r>
           </a:p>
         </p:txBody>
@@ -3554,169 +3426,29 @@
         </p:nvSpPr>
         <p:spPr>
           <a:xfrm>
-            <a:off x="594360" y="2560320"/>
-            <a:ext cx="11002975" cy="384048"/>
-          </a:xfrm>
-          <a:prstGeom prst="rect">
-            <a:avLst/>
-          </a:prstGeom>
-          <a:noFill/>
-        </p:spPr>
-        <p:txBody>
-          <a:bodyPr wrap="square">
-            <a:spAutoFit/>
-          </a:bodyPr>
-          <a:lstStyle/>
-          <a:p>
-            <a:pPr algn="ctr"/>
-            <a:r>
-              <a:rPr sz="2400" b="0" i="1">
-                <a:solidFill>
-                  <a:srgbClr val="B4B4B4"/>
-                </a:solidFill>
-                <a:latin typeface="Arial"/>
-              </a:rPr>
-              <a:t>Kiesarukoto nai Anatano Ai</a:t>
-            </a:r>
-          </a:p>
-        </p:txBody>
-      </p:sp>
-      <p:sp>
-        <p:nvSpPr>
-          <p:cNvPr id="4" name="TextBox 3"/>
-          <p:cNvSpPr txBox="1"/>
-          <p:nvPr/>
-        </p:nvSpPr>
-        <p:spPr>
-          <a:xfrm>
-            <a:off x="594360" y="2980944"/>
-            <a:ext cx="11002975" cy="347472"/>
-          </a:xfrm>
-          <a:prstGeom prst="rect">
-            <a:avLst/>
-          </a:prstGeom>
-          <a:noFill/>
-        </p:spPr>
-        <p:txBody>
-          <a:bodyPr wrap="square">
-            <a:spAutoFit/>
-          </a:bodyPr>
-          <a:lstStyle/>
-          <a:p>
-            <a:pPr algn="ctr"/>
-            <a:r>
-              <a:rPr sz="2000" b="0" i="1">
-                <a:solidFill>
-                  <a:srgbClr val="8C8C8C"/>
-                </a:solidFill>
-                <a:latin typeface="Arial"/>
-              </a:rPr>
-              <a:t/>
-            </a:r>
-          </a:p>
-        </p:txBody>
-      </p:sp>
-      <p:sp>
-        <p:nvSpPr>
-          <p:cNvPr id="5" name="TextBox 4"/>
-          <p:cNvSpPr txBox="1"/>
-          <p:nvPr/>
-        </p:nvSpPr>
-        <p:spPr>
-          <a:xfrm>
-            <a:off x="594360" y="3529584"/>
-            <a:ext cx="11002975" cy="685800"/>
-          </a:xfrm>
-          <a:prstGeom prst="rect">
-            <a:avLst/>
-          </a:prstGeom>
-          <a:noFill/>
-        </p:spPr>
-        <p:txBody>
-          <a:bodyPr wrap="square">
-            <a:spAutoFit/>
-          </a:bodyPr>
-          <a:lstStyle/>
-          <a:p>
-            <a:pPr algn="ctr"/>
-            <a:r>
-              <a:rPr sz="4400" b="1" i="0">
+            <a:off x="640080" y="2985516"/>
+            <a:ext cx="10911535" cy="731520"/>
+          </a:xfrm>
+          <a:prstGeom prst="rect">
+            <a:avLst/>
+          </a:prstGeom>
+          <a:noFill/>
+        </p:spPr>
+        <p:txBody>
+          <a:bodyPr wrap="square">
+            <a:spAutoFit/>
+          </a:bodyPr>
+          <a:lstStyle/>
+          <a:p>
+            <a:pPr algn="ctr"/>
+            <a:r>
+              <a:rPr sz="3900" b="1" i="0">
                 <a:solidFill>
                   <a:srgbClr val="FFFFFF"/>
                 </a:solidFill>
                 <a:latin typeface="Arial"/>
               </a:rPr>
-              <a:t>(*)一万    年と   永遠に</a:t>
-            </a:r>
-          </a:p>
-        </p:txBody>
-      </p:sp>
-      <p:sp>
-        <p:nvSpPr>
-          <p:cNvPr id="6" name="TextBox 5"/>
-          <p:cNvSpPr txBox="1"/>
-          <p:nvPr/>
-        </p:nvSpPr>
-        <p:spPr>
-          <a:xfrm>
-            <a:off x="594360" y="4251960"/>
-            <a:ext cx="11002975" cy="384048"/>
-          </a:xfrm>
-          <a:prstGeom prst="rect">
-            <a:avLst/>
-          </a:prstGeom>
-          <a:noFill/>
-        </p:spPr>
-        <p:txBody>
-          <a:bodyPr wrap="square">
-            <a:spAutoFit/>
-          </a:bodyPr>
-          <a:lstStyle/>
-          <a:p>
-            <a:pPr algn="ctr"/>
-            <a:r>
-              <a:rPr sz="2400" b="0" i="1">
-                <a:solidFill>
-                  <a:srgbClr val="B4B4B4"/>
-                </a:solidFill>
-                <a:latin typeface="Arial"/>
-              </a:rPr>
-              <a:t>Ichiman   nento Eienni</a:t>
-            </a:r>
-          </a:p>
-        </p:txBody>
-      </p:sp>
-      <p:sp>
-        <p:nvSpPr>
-          <p:cNvPr id="7" name="TextBox 6"/>
-          <p:cNvSpPr txBox="1"/>
-          <p:nvPr/>
-        </p:nvSpPr>
-        <p:spPr>
-          <a:xfrm>
-            <a:off x="594360" y="4672584"/>
-            <a:ext cx="11002975" cy="347472"/>
-          </a:xfrm>
-          <a:prstGeom prst="rect">
-            <a:avLst/>
-          </a:prstGeom>
-          <a:noFill/>
-        </p:spPr>
-        <p:txBody>
-          <a:bodyPr wrap="square">
-            <a:spAutoFit/>
-          </a:bodyPr>
-          <a:lstStyle/>
-          <a:p>
-            <a:pPr algn="ctr"/>
-            <a:r>
-              <a:rPr sz="2000" b="0" i="1">
-                <a:solidFill>
-                  <a:srgbClr val="8C8C8C"/>
-                </a:solidFill>
-                <a:latin typeface="Arial"/>
-              </a:rPr>
-              <a:t/>
+              <a:t>Quaisquer que sejam as perdas de amanhã</a:t>
             </a:r>
           </a:p>
         </p:txBody>
@@ -3755,28 +3487,98 @@
         </p:nvSpPr>
         <p:spPr>
           <a:xfrm>
-            <a:off x="594360" y="1837944"/>
-            <a:ext cx="11002975" cy="685800"/>
-          </a:xfrm>
-          <a:prstGeom prst="rect">
-            <a:avLst/>
-          </a:prstGeom>
-          <a:noFill/>
-        </p:spPr>
-        <p:txBody>
-          <a:bodyPr wrap="square">
-            <a:spAutoFit/>
-          </a:bodyPr>
-          <a:lstStyle/>
-          <a:p>
-            <a:pPr algn="ctr"/>
-            <a:r>
-              <a:rPr sz="4400" b="1" i="0">
+            <a:off x="640080" y="2052828"/>
+            <a:ext cx="10911535" cy="731520"/>
+          </a:xfrm>
+          <a:prstGeom prst="rect">
+            <a:avLst/>
+          </a:prstGeom>
+          <a:noFill/>
+        </p:spPr>
+        <p:txBody>
+          <a:bodyPr wrap="square">
+            <a:spAutoFit/>
+          </a:bodyPr>
+          <a:lstStyle/>
+          <a:p>
+            <a:pPr algn="ctr"/>
+            <a:r>
+              <a:rPr sz="4800" b="1" i="0">
                 <a:solidFill>
                   <a:srgbClr val="FFFFFF"/>
                 </a:solidFill>
                 <a:latin typeface="Arial"/>
               </a:rPr>
+              <a:t>Bendiga o Senhor, ó minha alma</a:t>
+            </a:r>
+          </a:p>
+        </p:txBody>
+      </p:sp>
+      <p:sp>
+        <p:nvSpPr>
+          <p:cNvPr id="3" name="TextBox 2"/>
+          <p:cNvSpPr txBox="1"/>
+          <p:nvPr/>
+        </p:nvSpPr>
+        <p:spPr>
+          <a:xfrm>
+            <a:off x="640080" y="2985516"/>
+            <a:ext cx="10911535" cy="731520"/>
+          </a:xfrm>
+          <a:prstGeom prst="rect">
+            <a:avLst/>
+          </a:prstGeom>
+          <a:noFill/>
+        </p:spPr>
+        <p:txBody>
+          <a:bodyPr wrap="square">
+            <a:spAutoFit/>
+          </a:bodyPr>
+          <a:lstStyle/>
+          <a:p>
+            <a:pPr algn="ctr"/>
+            <a:r>
+              <a:rPr sz="4800" b="1" i="0">
+                <a:solidFill>
+                  <a:srgbClr val="FFFFFF"/>
+                </a:solidFill>
+                <a:latin typeface="Arial"/>
+              </a:rPr>
+              <a:t>Ó minha alma</a:t>
+            </a:r>
+          </a:p>
+        </p:txBody>
+      </p:sp>
+      <p:sp>
+        <p:nvSpPr>
+          <p:cNvPr id="4" name="TextBox 3"/>
+          <p:cNvSpPr txBox="1"/>
+          <p:nvPr/>
+        </p:nvSpPr>
+        <p:spPr>
+          <a:xfrm>
+            <a:off x="640080" y="4128516"/>
+            <a:ext cx="10911535" cy="310896"/>
+          </a:xfrm>
+          <a:prstGeom prst="rect">
+            <a:avLst/>
+          </a:prstGeom>
+          <a:noFill/>
+        </p:spPr>
+        <p:txBody>
+          <a:bodyPr wrap="square">
+            <a:spAutoFit/>
+          </a:bodyPr>
+          <a:lstStyle/>
+          <a:p>
+            <a:pPr algn="ctr"/>
+            <a:r>
+              <a:rPr sz="2000" b="0" i="0">
+                <a:solidFill>
+                  <a:srgbClr val="828282"/>
+                </a:solidFill>
+                <a:latin typeface="Arial"/>
+              </a:rPr>
               <a:t>たましいよ   ほめ歌え   聖なる   主に</a:t>
             </a:r>
           </a:p>
@@ -3784,175 +3586,35 @@
       </p:sp>
       <p:sp>
         <p:nvSpPr>
-          <p:cNvPr id="3" name="TextBox 2"/>
-          <p:cNvSpPr txBox="1"/>
-          <p:nvPr/>
-        </p:nvSpPr>
-        <p:spPr>
-          <a:xfrm>
-            <a:off x="594360" y="2560320"/>
-            <a:ext cx="11002975" cy="384048"/>
-          </a:xfrm>
-          <a:prstGeom prst="rect">
-            <a:avLst/>
-          </a:prstGeom>
-          <a:noFill/>
-        </p:spPr>
-        <p:txBody>
-          <a:bodyPr wrap="square">
-            <a:spAutoFit/>
-          </a:bodyPr>
-          <a:lstStyle/>
-          <a:p>
-            <a:pPr algn="ctr"/>
-            <a:r>
-              <a:rPr sz="2400" b="0" i="1">
-                <a:solidFill>
-                  <a:srgbClr val="B4B4B4"/>
-                </a:solidFill>
-                <a:latin typeface="Arial"/>
-              </a:rPr>
-              <a:t>Tamashiiyo Homeutae Seinaru Shuni</a:t>
-            </a:r>
-          </a:p>
-        </p:txBody>
-      </p:sp>
-      <p:sp>
-        <p:nvSpPr>
-          <p:cNvPr id="4" name="TextBox 3"/>
-          <p:cNvSpPr txBox="1"/>
-          <p:nvPr/>
-        </p:nvSpPr>
-        <p:spPr>
-          <a:xfrm>
-            <a:off x="594360" y="2980944"/>
-            <a:ext cx="11002975" cy="347472"/>
-          </a:xfrm>
-          <a:prstGeom prst="rect">
-            <a:avLst/>
-          </a:prstGeom>
-          <a:noFill/>
-        </p:spPr>
-        <p:txBody>
-          <a:bodyPr wrap="square">
-            <a:spAutoFit/>
-          </a:bodyPr>
-          <a:lstStyle/>
-          <a:p>
-            <a:pPr algn="ctr"/>
-            <a:r>
-              <a:rPr sz="2000" b="0" i="1">
-                <a:solidFill>
-                  <a:srgbClr val="8C8C8C"/>
-                </a:solidFill>
-                <a:latin typeface="Arial"/>
-              </a:rPr>
-              <a:t/>
-            </a:r>
-          </a:p>
-        </p:txBody>
-      </p:sp>
-      <p:sp>
-        <p:nvSpPr>
           <p:cNvPr id="5" name="TextBox 4"/>
           <p:cNvSpPr txBox="1"/>
           <p:nvPr/>
         </p:nvSpPr>
         <p:spPr>
           <a:xfrm>
-            <a:off x="594360" y="3529584"/>
-            <a:ext cx="11002975" cy="685800"/>
-          </a:xfrm>
-          <a:prstGeom prst="rect">
-            <a:avLst/>
-          </a:prstGeom>
-          <a:noFill/>
-        </p:spPr>
-        <p:txBody>
-          <a:bodyPr wrap="square">
-            <a:spAutoFit/>
-          </a:bodyPr>
-          <a:lstStyle/>
-          <a:p>
-            <a:pPr algn="ctr"/>
-            <a:r>
-              <a:rPr sz="4400" b="1" i="0">
-                <a:solidFill>
-                  <a:srgbClr val="FFFFFF"/>
+            <a:off x="640080" y="4494276"/>
+            <a:ext cx="10911535" cy="310896"/>
+          </a:xfrm>
+          <a:prstGeom prst="rect">
+            <a:avLst/>
+          </a:prstGeom>
+          <a:noFill/>
+        </p:spPr>
+        <p:txBody>
+          <a:bodyPr wrap="square">
+            <a:spAutoFit/>
+          </a:bodyPr>
+          <a:lstStyle/>
+          <a:p>
+            <a:pPr algn="ctr"/>
+            <a:r>
+              <a:rPr sz="2000" b="0" i="0">
+                <a:solidFill>
+                  <a:srgbClr val="828282"/>
                 </a:solidFill>
                 <a:latin typeface="Arial"/>
               </a:rPr>
               <a:t>こころ   捧げ  うたえ 素晴らしい  主に</a:t>
-            </a:r>
-          </a:p>
-        </p:txBody>
-      </p:sp>
-      <p:sp>
-        <p:nvSpPr>
-          <p:cNvPr id="6" name="TextBox 5"/>
-          <p:cNvSpPr txBox="1"/>
-          <p:nvPr/>
-        </p:nvSpPr>
-        <p:spPr>
-          <a:xfrm>
-            <a:off x="594360" y="4251960"/>
-            <a:ext cx="11002975" cy="384048"/>
-          </a:xfrm>
-          <a:prstGeom prst="rect">
-            <a:avLst/>
-          </a:prstGeom>
-          <a:noFill/>
-        </p:spPr>
-        <p:txBody>
-          <a:bodyPr wrap="square">
-            <a:spAutoFit/>
-          </a:bodyPr>
-          <a:lstStyle/>
-          <a:p>
-            <a:pPr algn="ctr"/>
-            <a:r>
-              <a:rPr sz="2400" b="0" i="1">
-                <a:solidFill>
-                  <a:srgbClr val="B4B4B4"/>
-                </a:solidFill>
-                <a:latin typeface="Arial"/>
-              </a:rPr>
-              <a:t>Kokoro Sasage Utae Subarashii Shuni</a:t>
-            </a:r>
-          </a:p>
-        </p:txBody>
-      </p:sp>
-      <p:sp>
-        <p:nvSpPr>
-          <p:cNvPr id="7" name="TextBox 6"/>
-          <p:cNvSpPr txBox="1"/>
-          <p:nvPr/>
-        </p:nvSpPr>
-        <p:spPr>
-          <a:xfrm>
-            <a:off x="594360" y="4672584"/>
-            <a:ext cx="11002975" cy="347472"/>
-          </a:xfrm>
-          <a:prstGeom prst="rect">
-            <a:avLst/>
-          </a:prstGeom>
-          <a:noFill/>
-        </p:spPr>
-        <p:txBody>
-          <a:bodyPr wrap="square">
-            <a:spAutoFit/>
-          </a:bodyPr>
-          <a:lstStyle/>
-          <a:p>
-            <a:pPr algn="ctr"/>
-            <a:r>
-              <a:rPr sz="2000" b="0" i="1">
-                <a:solidFill>
-                  <a:srgbClr val="8C8C8C"/>
-                </a:solidFill>
-                <a:latin typeface="Arial"/>
-              </a:rPr>
-              <a:t/>
             </a:r>
           </a:p>
         </p:txBody>
@@ -3991,29 +3653,29 @@
         </p:nvSpPr>
         <p:spPr>
           <a:xfrm>
-            <a:off x="594360" y="2258568"/>
-            <a:ext cx="11002975" cy="685800"/>
-          </a:xfrm>
-          <a:prstGeom prst="rect">
-            <a:avLst/>
-          </a:prstGeom>
-          <a:noFill/>
-        </p:spPr>
-        <p:txBody>
-          <a:bodyPr wrap="square">
-            <a:spAutoFit/>
-          </a:bodyPr>
-          <a:lstStyle/>
-          <a:p>
-            <a:pPr algn="ctr"/>
-            <a:r>
-              <a:rPr sz="3520" b="1" i="0">
+            <a:off x="640080" y="2052828"/>
+            <a:ext cx="10911535" cy="731520"/>
+          </a:xfrm>
+          <a:prstGeom prst="rect">
+            <a:avLst/>
+          </a:prstGeom>
+          <a:noFill/>
+        </p:spPr>
+        <p:txBody>
+          <a:bodyPr wrap="square">
+            <a:spAutoFit/>
+          </a:bodyPr>
+          <a:lstStyle/>
+          <a:p>
+            <a:pPr algn="ctr"/>
+            <a:r>
+              <a:rPr sz="4800" b="1" i="0">
                 <a:solidFill>
                   <a:srgbClr val="FFFFFF"/>
                 </a:solidFill>
                 <a:latin typeface="Arial"/>
               </a:rPr>
-              <a:t>Dez mil razões pro meu coração encontrar</a:t>
+              <a:t>Adore Seu santo nome</a:t>
             </a:r>
           </a:p>
         </p:txBody>
@@ -4026,29 +3688,29 @@
         </p:nvSpPr>
         <p:spPr>
           <a:xfrm>
-            <a:off x="594360" y="2980944"/>
-            <a:ext cx="11002975" cy="347472"/>
-          </a:xfrm>
-          <a:prstGeom prst="rect">
-            <a:avLst/>
-          </a:prstGeom>
-          <a:noFill/>
-        </p:spPr>
-        <p:txBody>
-          <a:bodyPr wrap="square">
-            <a:spAutoFit/>
-          </a:bodyPr>
-          <a:lstStyle/>
-          <a:p>
-            <a:pPr algn="ctr"/>
-            <a:r>
-              <a:rPr sz="2200" b="0" i="1">
-                <a:solidFill>
-                  <a:srgbClr val="8C8C8C"/>
-                </a:solidFill>
-                <a:latin typeface="Arial"/>
-              </a:rPr>
-              <a:t/>
+            <a:off x="640080" y="2985516"/>
+            <a:ext cx="10911535" cy="731520"/>
+          </a:xfrm>
+          <a:prstGeom prst="rect">
+            <a:avLst/>
+          </a:prstGeom>
+          <a:noFill/>
+        </p:spPr>
+        <p:txBody>
+          <a:bodyPr wrap="square">
+            <a:spAutoFit/>
+          </a:bodyPr>
+          <a:lstStyle/>
+          <a:p>
+            <a:pPr algn="ctr"/>
+            <a:r>
+              <a:rPr sz="4800" b="1" i="0">
+                <a:solidFill>
+                  <a:srgbClr val="FFFFFF"/>
+                </a:solidFill>
+                <a:latin typeface="Arial"/>
+              </a:rPr>
+              <a:t>Cante como nunca antes</a:t>
             </a:r>
           </a:p>
         </p:txBody>
@@ -4061,29 +3723,29 @@
         </p:nvSpPr>
         <p:spPr>
           <a:xfrm>
-            <a:off x="594360" y="3529584"/>
-            <a:ext cx="11002975" cy="685800"/>
-          </a:xfrm>
-          <a:prstGeom prst="rect">
-            <a:avLst/>
-          </a:prstGeom>
-          <a:noFill/>
-        </p:spPr>
-        <p:txBody>
-          <a:bodyPr wrap="square">
-            <a:spAutoFit/>
-          </a:bodyPr>
-          <a:lstStyle/>
-          <a:p>
-            <a:pPr algn="ctr"/>
-            <a:r>
-              <a:rPr sz="4400" b="1" i="0">
-                <a:solidFill>
-                  <a:srgbClr val="FFFFFF"/>
-                </a:solidFill>
-                <a:latin typeface="Arial"/>
-              </a:rPr>
-              <a:t>Bendiga o Senhor</a:t>
+            <a:off x="640080" y="4128516"/>
+            <a:ext cx="10911535" cy="310896"/>
+          </a:xfrm>
+          <a:prstGeom prst="rect">
+            <a:avLst/>
+          </a:prstGeom>
+          <a:noFill/>
+        </p:spPr>
+        <p:txBody>
+          <a:bodyPr wrap="square">
+            <a:spAutoFit/>
+          </a:bodyPr>
+          <a:lstStyle/>
+          <a:p>
+            <a:pPr algn="ctr"/>
+            <a:r>
+              <a:rPr sz="2000" b="0" i="0">
+                <a:solidFill>
+                  <a:srgbClr val="828282"/>
+                </a:solidFill>
+                <a:latin typeface="Arial"/>
+              </a:rPr>
+              <a:t>たましいよ   ほめ歌え   聖なる   主に</a:t>
             </a:r>
           </a:p>
         </p:txBody>
@@ -4096,29 +3758,29 @@
         </p:nvSpPr>
         <p:spPr>
           <a:xfrm>
-            <a:off x="594360" y="4251960"/>
-            <a:ext cx="11002975" cy="347472"/>
-          </a:xfrm>
-          <a:prstGeom prst="rect">
-            <a:avLst/>
-          </a:prstGeom>
-          <a:noFill/>
-        </p:spPr>
-        <p:txBody>
-          <a:bodyPr wrap="square">
-            <a:spAutoFit/>
-          </a:bodyPr>
-          <a:lstStyle/>
-          <a:p>
-            <a:pPr algn="ctr"/>
-            <a:r>
-              <a:rPr sz="2200" b="0" i="1">
-                <a:solidFill>
-                  <a:srgbClr val="8C8C8C"/>
-                </a:solidFill>
-                <a:latin typeface="Arial"/>
-              </a:rPr>
-              <a:t/>
+            <a:off x="640080" y="4494276"/>
+            <a:ext cx="10911535" cy="310896"/>
+          </a:xfrm>
+          <a:prstGeom prst="rect">
+            <a:avLst/>
+          </a:prstGeom>
+          <a:noFill/>
+        </p:spPr>
+        <p:txBody>
+          <a:bodyPr wrap="square">
+            <a:spAutoFit/>
+          </a:bodyPr>
+          <a:lstStyle/>
+          <a:p>
+            <a:pPr algn="ctr"/>
+            <a:r>
+              <a:rPr sz="2000" b="0" i="0">
+                <a:solidFill>
+                  <a:srgbClr val="828282"/>
+                </a:solidFill>
+                <a:latin typeface="Arial"/>
+              </a:rPr>
+              <a:t>こころ   捧げ  うたえ 素晴らしい  主に</a:t>
             </a:r>
           </a:p>
         </p:txBody>
@@ -4157,28 +3819,316 @@
         </p:nvSpPr>
         <p:spPr>
           <a:xfrm>
-            <a:off x="594360" y="2258568"/>
-            <a:ext cx="11002975" cy="685800"/>
-          </a:xfrm>
-          <a:prstGeom prst="rect">
-            <a:avLst/>
-          </a:prstGeom>
-          <a:noFill/>
-        </p:spPr>
-        <p:txBody>
-          <a:bodyPr wrap="square">
-            <a:spAutoFit/>
-          </a:bodyPr>
-          <a:lstStyle/>
-          <a:p>
-            <a:pPr algn="ctr"/>
-            <a:r>
-              <a:rPr sz="4400" b="1" i="0">
+            <a:off x="640080" y="2052828"/>
+            <a:ext cx="10911535" cy="731520"/>
+          </a:xfrm>
+          <a:prstGeom prst="rect">
+            <a:avLst/>
+          </a:prstGeom>
+          <a:noFill/>
+        </p:spPr>
+        <p:txBody>
+          <a:bodyPr wrap="square">
+            <a:spAutoFit/>
+          </a:bodyPr>
+          <a:lstStyle/>
+          <a:p>
+            <a:pPr algn="ctr"/>
+            <a:r>
+              <a:rPr sz="4800" b="1" i="0">
                 <a:solidFill>
                   <a:srgbClr val="FFFFFF"/>
                 </a:solidFill>
                 <a:latin typeface="Arial"/>
               </a:rPr>
+              <a:t>Meu canto ainda assim será</a:t>
+            </a:r>
+          </a:p>
+        </p:txBody>
+      </p:sp>
+      <p:sp>
+        <p:nvSpPr>
+          <p:cNvPr id="3" name="TextBox 2"/>
+          <p:cNvSpPr txBox="1"/>
+          <p:nvPr/>
+        </p:nvSpPr>
+        <p:spPr>
+          <a:xfrm>
+            <a:off x="640080" y="2985516"/>
+            <a:ext cx="10911535" cy="731520"/>
+          </a:xfrm>
+          <a:prstGeom prst="rect">
+            <a:avLst/>
+          </a:prstGeom>
+          <a:noFill/>
+        </p:spPr>
+        <p:txBody>
+          <a:bodyPr wrap="square">
+            <a:spAutoFit/>
+          </a:bodyPr>
+          <a:lstStyle/>
+          <a:p>
+            <a:pPr algn="ctr"/>
+            <a:r>
+              <a:rPr sz="4800" b="1" i="0">
+                <a:solidFill>
+                  <a:srgbClr val="FFFFFF"/>
+                </a:solidFill>
+                <a:latin typeface="Arial"/>
+              </a:rPr>
+              <a:t>Bendiga o Senhor, ó minha alma</a:t>
+            </a:r>
+          </a:p>
+        </p:txBody>
+      </p:sp>
+    </p:spTree>
+  </p:cSld>
+  <p:clrMapOvr>
+    <a:masterClrMapping/>
+  </p:clrMapOvr>
+</p:sld>
+</file>
+
+<file path=ppt/slides/slide15.xml><?xml version="1.0" encoding="utf-8"?>
+<p:sld xmlns:a="http://schemas.openxmlformats.org/drawingml/2006/main" xmlns:p="http://schemas.openxmlformats.org/presentationml/2006/main" xmlns:r="http://schemas.openxmlformats.org/officeDocument/2006/relationships">
+  <p:cSld>
+    <p:bg>
+      <p:bgPr>
+        <a:solidFill>
+          <a:srgbClr val="000000"/>
+        </a:solidFill>
+        <a:effectLst/>
+      </p:bgPr>
+    </p:bg>
+    <p:spTree>
+      <p:nvGrpSpPr>
+        <p:cNvPr id="1" name=""/>
+        <p:cNvGrpSpPr/>
+        <p:nvPr/>
+      </p:nvGrpSpPr>
+      <p:grpSpPr/>
+      <p:sp>
+        <p:nvSpPr>
+          <p:cNvPr id="2" name="TextBox 1"/>
+          <p:cNvSpPr txBox="1"/>
+          <p:nvPr/>
+        </p:nvSpPr>
+        <p:spPr>
+          <a:xfrm>
+            <a:off x="640080" y="2052828"/>
+            <a:ext cx="10911535" cy="731520"/>
+          </a:xfrm>
+          <a:prstGeom prst="rect">
+            <a:avLst/>
+          </a:prstGeom>
+          <a:noFill/>
+        </p:spPr>
+        <p:txBody>
+          <a:bodyPr wrap="square">
+            <a:spAutoFit/>
+          </a:bodyPr>
+          <a:lstStyle/>
+          <a:p>
+            <a:pPr algn="ctr"/>
+            <a:r>
+              <a:rPr sz="4800" b="1" i="0">
+                <a:solidFill>
+                  <a:srgbClr val="FFFFFF"/>
+                </a:solidFill>
+                <a:latin typeface="Arial"/>
+              </a:rPr>
+              <a:t>Ó minha alma</a:t>
+            </a:r>
+          </a:p>
+        </p:txBody>
+      </p:sp>
+      <p:sp>
+        <p:nvSpPr>
+          <p:cNvPr id="3" name="TextBox 2"/>
+          <p:cNvSpPr txBox="1"/>
+          <p:nvPr/>
+        </p:nvSpPr>
+        <p:spPr>
+          <a:xfrm>
+            <a:off x="640080" y="2985516"/>
+            <a:ext cx="10911535" cy="731520"/>
+          </a:xfrm>
+          <a:prstGeom prst="rect">
+            <a:avLst/>
+          </a:prstGeom>
+          <a:noFill/>
+        </p:spPr>
+        <p:txBody>
+          <a:bodyPr wrap="square">
+            <a:spAutoFit/>
+          </a:bodyPr>
+          <a:lstStyle/>
+          <a:p>
+            <a:pPr algn="ctr"/>
+            <a:r>
+              <a:rPr sz="4800" b="1" i="0">
+                <a:solidFill>
+                  <a:srgbClr val="FFFFFF"/>
+                </a:solidFill>
+                <a:latin typeface="Arial"/>
+              </a:rPr>
+              <a:t>Adore Seu santo nome</a:t>
+            </a:r>
+          </a:p>
+        </p:txBody>
+      </p:sp>
+    </p:spTree>
+  </p:cSld>
+  <p:clrMapOvr>
+    <a:masterClrMapping/>
+  </p:clrMapOvr>
+</p:sld>
+</file>
+
+<file path=ppt/slides/slide16.xml><?xml version="1.0" encoding="utf-8"?>
+<p:sld xmlns:a="http://schemas.openxmlformats.org/drawingml/2006/main" xmlns:p="http://schemas.openxmlformats.org/presentationml/2006/main" xmlns:r="http://schemas.openxmlformats.org/officeDocument/2006/relationships">
+  <p:cSld>
+    <p:bg>
+      <p:bgPr>
+        <a:solidFill>
+          <a:srgbClr val="000000"/>
+        </a:solidFill>
+        <a:effectLst/>
+      </p:bgPr>
+    </p:bg>
+    <p:spTree>
+      <p:nvGrpSpPr>
+        <p:cNvPr id="1" name=""/>
+        <p:cNvGrpSpPr/>
+        <p:nvPr/>
+      </p:nvGrpSpPr>
+      <p:grpSpPr/>
+      <p:sp>
+        <p:nvSpPr>
+          <p:cNvPr id="2" name="TextBox 1"/>
+          <p:cNvSpPr txBox="1"/>
+          <p:nvPr/>
+        </p:nvSpPr>
+        <p:spPr>
+          <a:xfrm>
+            <a:off x="640080" y="2052828"/>
+            <a:ext cx="10911535" cy="731520"/>
+          </a:xfrm>
+          <a:prstGeom prst="rect">
+            <a:avLst/>
+          </a:prstGeom>
+          <a:noFill/>
+        </p:spPr>
+        <p:txBody>
+          <a:bodyPr wrap="square">
+            <a:spAutoFit/>
+          </a:bodyPr>
+          <a:lstStyle/>
+          <a:p>
+            <a:pPr algn="ctr"/>
+            <a:r>
+              <a:rPr sz="3800" b="1" i="0">
+                <a:solidFill>
+                  <a:srgbClr val="FFFFFF"/>
+                </a:solidFill>
+                <a:latin typeface="Arial"/>
+              </a:rPr>
+              <a:t>Dez mil razões pro meu coração encontrar</a:t>
+            </a:r>
+          </a:p>
+        </p:txBody>
+      </p:sp>
+      <p:sp>
+        <p:nvSpPr>
+          <p:cNvPr id="3" name="TextBox 2"/>
+          <p:cNvSpPr txBox="1"/>
+          <p:nvPr/>
+        </p:nvSpPr>
+        <p:spPr>
+          <a:xfrm>
+            <a:off x="640080" y="2985516"/>
+            <a:ext cx="10911535" cy="731520"/>
+          </a:xfrm>
+          <a:prstGeom prst="rect">
+            <a:avLst/>
+          </a:prstGeom>
+          <a:noFill/>
+        </p:spPr>
+        <p:txBody>
+          <a:bodyPr wrap="square">
+            <a:spAutoFit/>
+          </a:bodyPr>
+          <a:lstStyle/>
+          <a:p>
+            <a:pPr algn="ctr"/>
+            <a:r>
+              <a:rPr sz="4800" b="1" i="0">
+                <a:solidFill>
+                  <a:srgbClr val="FFFFFF"/>
+                </a:solidFill>
+                <a:latin typeface="Arial"/>
+              </a:rPr>
+              <a:t>Bendiga o Senhor</a:t>
+            </a:r>
+          </a:p>
+        </p:txBody>
+      </p:sp>
+    </p:spTree>
+  </p:cSld>
+  <p:clrMapOvr>
+    <a:masterClrMapping/>
+  </p:clrMapOvr>
+</p:sld>
+</file>
+
+<file path=ppt/slides/slide17.xml><?xml version="1.0" encoding="utf-8"?>
+<p:sld xmlns:a="http://schemas.openxmlformats.org/drawingml/2006/main" xmlns:p="http://schemas.openxmlformats.org/presentationml/2006/main" xmlns:r="http://schemas.openxmlformats.org/officeDocument/2006/relationships">
+  <p:cSld>
+    <p:bg>
+      <p:bgPr>
+        <a:solidFill>
+          <a:srgbClr val="000000"/>
+        </a:solidFill>
+        <a:effectLst/>
+      </p:bgPr>
+    </p:bg>
+    <p:spTree>
+      <p:nvGrpSpPr>
+        <p:cNvPr id="1" name=""/>
+        <p:cNvGrpSpPr/>
+        <p:nvPr/>
+      </p:nvGrpSpPr>
+      <p:grpSpPr/>
+      <p:sp>
+        <p:nvSpPr>
+          <p:cNvPr id="2" name="TextBox 1"/>
+          <p:cNvSpPr txBox="1"/>
+          <p:nvPr/>
+        </p:nvSpPr>
+        <p:spPr>
+          <a:xfrm>
+            <a:off x="640080" y="2052828"/>
+            <a:ext cx="10911535" cy="731520"/>
+          </a:xfrm>
+          <a:prstGeom prst="rect">
+            <a:avLst/>
+          </a:prstGeom>
+          <a:noFill/>
+        </p:spPr>
+        <p:txBody>
+          <a:bodyPr wrap="square">
+            <a:spAutoFit/>
+          </a:bodyPr>
+          <a:lstStyle/>
+          <a:p>
+            <a:pPr algn="ctr"/>
+            <a:r>
+              <a:rPr sz="4800" b="1" i="0">
+                <a:solidFill>
+                  <a:srgbClr val="FFFFFF"/>
+                </a:solidFill>
+                <a:latin typeface="Arial"/>
+              </a:rPr>
               <a:t>E no dia em que Sua força acabar</a:t>
             </a:r>
           </a:p>
@@ -4192,29 +4142,125 @@
         </p:nvSpPr>
         <p:spPr>
           <a:xfrm>
-            <a:off x="594360" y="2980944"/>
-            <a:ext cx="11002975" cy="347472"/>
-          </a:xfrm>
-          <a:prstGeom prst="rect">
-            <a:avLst/>
-          </a:prstGeom>
-          <a:noFill/>
-        </p:spPr>
-        <p:txBody>
-          <a:bodyPr wrap="square">
-            <a:spAutoFit/>
-          </a:bodyPr>
-          <a:lstStyle/>
-          <a:p>
-            <a:pPr algn="ctr"/>
-            <a:r>
-              <a:rPr sz="2200" b="0" i="1">
-                <a:solidFill>
-                  <a:srgbClr val="8C8C8C"/>
-                </a:solidFill>
-                <a:latin typeface="Arial"/>
-              </a:rPr>
-              <a:t/>
+            <a:off x="640080" y="2985516"/>
+            <a:ext cx="10911535" cy="731520"/>
+          </a:xfrm>
+          <a:prstGeom prst="rect">
+            <a:avLst/>
+          </a:prstGeom>
+          <a:noFill/>
+        </p:spPr>
+        <p:txBody>
+          <a:bodyPr wrap="square">
+            <a:spAutoFit/>
+          </a:bodyPr>
+          <a:lstStyle/>
+          <a:p>
+            <a:pPr algn="ctr"/>
+            <a:r>
+              <a:rPr sz="4800" b="1" i="0">
+                <a:solidFill>
+                  <a:srgbClr val="FFFFFF"/>
+                </a:solidFill>
+                <a:latin typeface="Arial"/>
+              </a:rPr>
+              <a:t>Quando o fim vem</a:t>
+            </a:r>
+          </a:p>
+        </p:txBody>
+      </p:sp>
+    </p:spTree>
+  </p:cSld>
+  <p:clrMapOvr>
+    <a:masterClrMapping/>
+  </p:clrMapOvr>
+</p:sld>
+</file>
+
+<file path=ppt/slides/slide18.xml><?xml version="1.0" encoding="utf-8"?>
+<p:sld xmlns:a="http://schemas.openxmlformats.org/drawingml/2006/main" xmlns:p="http://schemas.openxmlformats.org/presentationml/2006/main" xmlns:r="http://schemas.openxmlformats.org/officeDocument/2006/relationships">
+  <p:cSld>
+    <p:bg>
+      <p:bgPr>
+        <a:solidFill>
+          <a:srgbClr val="000000"/>
+        </a:solidFill>
+        <a:effectLst/>
+      </p:bgPr>
+    </p:bg>
+    <p:spTree>
+      <p:nvGrpSpPr>
+        <p:cNvPr id="1" name=""/>
+        <p:cNvGrpSpPr/>
+        <p:nvPr/>
+      </p:nvGrpSpPr>
+      <p:grpSpPr/>
+      <p:sp>
+        <p:nvSpPr>
+          <p:cNvPr id="2" name="TextBox 1"/>
+          <p:cNvSpPr txBox="1"/>
+          <p:nvPr/>
+        </p:nvSpPr>
+        <p:spPr>
+          <a:xfrm>
+            <a:off x="640080" y="1650492"/>
+            <a:ext cx="10911535" cy="731520"/>
+          </a:xfrm>
+          <a:prstGeom prst="rect">
+            <a:avLst/>
+          </a:prstGeom>
+          <a:noFill/>
+        </p:spPr>
+        <p:txBody>
+          <a:bodyPr wrap="square">
+            <a:spAutoFit/>
+          </a:bodyPr>
+          <a:lstStyle/>
+          <a:p>
+            <a:pPr algn="ctr"/>
+            <a:r>
+              <a:rPr sz="4800" b="1" i="0">
+                <a:solidFill>
+                  <a:srgbClr val="FFFFFF"/>
+                </a:solidFill>
+                <a:latin typeface="Arial"/>
+              </a:rPr>
+              <a:t>力    尽きる   ときも</a:t>
+            </a:r>
+          </a:p>
+        </p:txBody>
+      </p:sp>
+      <p:sp>
+        <p:nvSpPr>
+          <p:cNvPr id="3" name="TextBox 2"/>
+          <p:cNvSpPr txBox="1"/>
+          <p:nvPr/>
+        </p:nvSpPr>
+        <p:spPr>
+          <a:xfrm>
+            <a:off x="640080" y="2418588"/>
+            <a:ext cx="10911535" cy="365760"/>
+          </a:xfrm>
+          <a:prstGeom prst="rect">
+            <a:avLst/>
+          </a:prstGeom>
+          <a:noFill/>
+        </p:spPr>
+        <p:txBody>
+          <a:bodyPr wrap="square">
+            <a:spAutoFit/>
+          </a:bodyPr>
+          <a:lstStyle/>
+          <a:p>
+            <a:pPr algn="ctr"/>
+            <a:r>
+              <a:rPr sz="2400" b="0" i="1">
+                <a:solidFill>
+                  <a:srgbClr val="AAAAAA"/>
+                </a:solidFill>
+                <a:latin typeface="Arial"/>
+              </a:rPr>
+              <a:t>Chikara Tsukiru tokimo</a:t>
             </a:r>
           </a:p>
         </p:txBody>
@@ -4227,29 +4273,29 @@
         </p:nvSpPr>
         <p:spPr>
           <a:xfrm>
-            <a:off x="594360" y="3529584"/>
-            <a:ext cx="11002975" cy="685800"/>
-          </a:xfrm>
-          <a:prstGeom prst="rect">
-            <a:avLst/>
-          </a:prstGeom>
-          <a:noFill/>
-        </p:spPr>
-        <p:txBody>
-          <a:bodyPr wrap="square">
-            <a:spAutoFit/>
-          </a:bodyPr>
-          <a:lstStyle/>
-          <a:p>
-            <a:pPr algn="ctr"/>
-            <a:r>
-              <a:rPr sz="4400" b="1" i="0">
+            <a:off x="640080" y="2985516"/>
+            <a:ext cx="10911535" cy="731520"/>
+          </a:xfrm>
+          <a:prstGeom prst="rect">
+            <a:avLst/>
+          </a:prstGeom>
+          <a:noFill/>
+        </p:spPr>
+        <p:txBody>
+          <a:bodyPr wrap="square">
+            <a:spAutoFit/>
+          </a:bodyPr>
+          <a:lstStyle/>
+          <a:p>
+            <a:pPr algn="ctr"/>
+            <a:r>
+              <a:rPr sz="4800" b="1" i="0">
                 <a:solidFill>
                   <a:srgbClr val="FFFFFF"/>
                 </a:solidFill>
                 <a:latin typeface="Arial"/>
               </a:rPr>
-              <a:t>Quando o fim vem</a:t>
+              <a:t>終わりの  日にも  歌う</a:t>
             </a:r>
           </a:p>
         </p:txBody>
@@ -4262,29 +4308,335 @@
         </p:nvSpPr>
         <p:spPr>
           <a:xfrm>
-            <a:off x="594360" y="4251960"/>
-            <a:ext cx="11002975" cy="347472"/>
-          </a:xfrm>
-          <a:prstGeom prst="rect">
-            <a:avLst/>
-          </a:prstGeom>
-          <a:noFill/>
-        </p:spPr>
-        <p:txBody>
-          <a:bodyPr wrap="square">
-            <a:spAutoFit/>
-          </a:bodyPr>
-          <a:lstStyle/>
-          <a:p>
-            <a:pPr algn="ctr"/>
-            <a:r>
-              <a:rPr sz="2200" b="0" i="1">
-                <a:solidFill>
-                  <a:srgbClr val="8C8C8C"/>
-                </a:solidFill>
-                <a:latin typeface="Arial"/>
-              </a:rPr>
-              <a:t/>
+            <a:off x="640080" y="3753612"/>
+            <a:ext cx="10911535" cy="365760"/>
+          </a:xfrm>
+          <a:prstGeom prst="rect">
+            <a:avLst/>
+          </a:prstGeom>
+          <a:noFill/>
+        </p:spPr>
+        <p:txBody>
+          <a:bodyPr wrap="square">
+            <a:spAutoFit/>
+          </a:bodyPr>
+          <a:lstStyle/>
+          <a:p>
+            <a:pPr algn="ctr"/>
+            <a:r>
+              <a:rPr sz="2400" b="0" i="1">
+                <a:solidFill>
+                  <a:srgbClr val="AAAAAA"/>
+                </a:solidFill>
+                <a:latin typeface="Arial"/>
+              </a:rPr>
+              <a:t>Owarino Hinimo Utau</a:t>
+            </a:r>
+          </a:p>
+        </p:txBody>
+      </p:sp>
+      <p:sp>
+        <p:nvSpPr>
+          <p:cNvPr id="6" name="TextBox 5"/>
+          <p:cNvSpPr txBox="1"/>
+          <p:nvPr/>
+        </p:nvSpPr>
+        <p:spPr>
+          <a:xfrm>
+            <a:off x="640080" y="4530852"/>
+            <a:ext cx="10911535" cy="310896"/>
+          </a:xfrm>
+          <a:prstGeom prst="rect">
+            <a:avLst/>
+          </a:prstGeom>
+          <a:noFill/>
+        </p:spPr>
+        <p:txBody>
+          <a:bodyPr wrap="square">
+            <a:spAutoFit/>
+          </a:bodyPr>
+          <a:lstStyle/>
+          <a:p>
+            <a:pPr algn="ctr"/>
+            <a:r>
+              <a:rPr sz="2000" b="0" i="1">
+                <a:solidFill>
+                  <a:srgbClr val="828282"/>
+                </a:solidFill>
+                <a:latin typeface="Arial"/>
+              </a:rPr>
+              <a:t>Bendiga o Senhor</a:t>
+            </a:r>
+          </a:p>
+        </p:txBody>
+      </p:sp>
+      <p:sp>
+        <p:nvSpPr>
+          <p:cNvPr id="7" name="TextBox 6"/>
+          <p:cNvSpPr txBox="1"/>
+          <p:nvPr/>
+        </p:nvSpPr>
+        <p:spPr>
+          <a:xfrm>
+            <a:off x="640080" y="4896612"/>
+            <a:ext cx="10911535" cy="310896"/>
+          </a:xfrm>
+          <a:prstGeom prst="rect">
+            <a:avLst/>
+          </a:prstGeom>
+          <a:noFill/>
+        </p:spPr>
+        <p:txBody>
+          <a:bodyPr wrap="square">
+            <a:spAutoFit/>
+          </a:bodyPr>
+          <a:lstStyle/>
+          <a:p>
+            <a:pPr algn="ctr"/>
+            <a:r>
+              <a:rPr sz="2000" b="0" i="1">
+                <a:solidFill>
+                  <a:srgbClr val="828282"/>
+                </a:solidFill>
+                <a:latin typeface="Arial"/>
+              </a:rPr>
+              <a:t>O sol está se pondo e a madrugada vai cantar</a:t>
+            </a:r>
+          </a:p>
+        </p:txBody>
+      </p:sp>
+    </p:spTree>
+  </p:cSld>
+  <p:clrMapOvr>
+    <a:masterClrMapping/>
+  </p:clrMapOvr>
+</p:sld>
+</file>
+
+<file path=ppt/slides/slide19.xml><?xml version="1.0" encoding="utf-8"?>
+<p:sld xmlns:a="http://schemas.openxmlformats.org/drawingml/2006/main" xmlns:p="http://schemas.openxmlformats.org/presentationml/2006/main" xmlns:r="http://schemas.openxmlformats.org/officeDocument/2006/relationships">
+  <p:cSld>
+    <p:bg>
+      <p:bgPr>
+        <a:solidFill>
+          <a:srgbClr val="000000"/>
+        </a:solidFill>
+        <a:effectLst/>
+      </p:bgPr>
+    </p:bg>
+    <p:spTree>
+      <p:nvGrpSpPr>
+        <p:cNvPr id="1" name=""/>
+        <p:cNvGrpSpPr/>
+        <p:nvPr/>
+      </p:nvGrpSpPr>
+      <p:grpSpPr/>
+      <p:sp>
+        <p:nvSpPr>
+          <p:cNvPr id="2" name="TextBox 1"/>
+          <p:cNvSpPr txBox="1"/>
+          <p:nvPr/>
+        </p:nvSpPr>
+        <p:spPr>
+          <a:xfrm>
+            <a:off x="640080" y="1650492"/>
+            <a:ext cx="10911535" cy="731520"/>
+          </a:xfrm>
+          <a:prstGeom prst="rect">
+            <a:avLst/>
+          </a:prstGeom>
+          <a:noFill/>
+        </p:spPr>
+        <p:txBody>
+          <a:bodyPr wrap="square">
+            <a:spAutoFit/>
+          </a:bodyPr>
+          <a:lstStyle/>
+          <a:p>
+            <a:pPr algn="ctr"/>
+            <a:r>
+              <a:rPr sz="4800" b="1" i="0">
+                <a:solidFill>
+                  <a:srgbClr val="FFFFFF"/>
+                </a:solidFill>
+                <a:latin typeface="Arial"/>
+              </a:rPr>
+              <a:t>消え去ること  ない あなたの愛</a:t>
+            </a:r>
+          </a:p>
+        </p:txBody>
+      </p:sp>
+      <p:sp>
+        <p:nvSpPr>
+          <p:cNvPr id="3" name="TextBox 2"/>
+          <p:cNvSpPr txBox="1"/>
+          <p:nvPr/>
+        </p:nvSpPr>
+        <p:spPr>
+          <a:xfrm>
+            <a:off x="640080" y="2418588"/>
+            <a:ext cx="10911535" cy="365760"/>
+          </a:xfrm>
+          <a:prstGeom prst="rect">
+            <a:avLst/>
+          </a:prstGeom>
+          <a:noFill/>
+        </p:spPr>
+        <p:txBody>
+          <a:bodyPr wrap="square">
+            <a:spAutoFit/>
+          </a:bodyPr>
+          <a:lstStyle/>
+          <a:p>
+            <a:pPr algn="ctr"/>
+            <a:r>
+              <a:rPr sz="2400" b="0" i="1">
+                <a:solidFill>
+                  <a:srgbClr val="AAAAAA"/>
+                </a:solidFill>
+                <a:latin typeface="Arial"/>
+              </a:rPr>
+              <a:t>Kiesarukoto nai Anatano Ai</a:t>
+            </a:r>
+          </a:p>
+        </p:txBody>
+      </p:sp>
+      <p:sp>
+        <p:nvSpPr>
+          <p:cNvPr id="4" name="TextBox 3"/>
+          <p:cNvSpPr txBox="1"/>
+          <p:nvPr/>
+        </p:nvSpPr>
+        <p:spPr>
+          <a:xfrm>
+            <a:off x="640080" y="2985516"/>
+            <a:ext cx="10911535" cy="731520"/>
+          </a:xfrm>
+          <a:prstGeom prst="rect">
+            <a:avLst/>
+          </a:prstGeom>
+          <a:noFill/>
+        </p:spPr>
+        <p:txBody>
+          <a:bodyPr wrap="square">
+            <a:spAutoFit/>
+          </a:bodyPr>
+          <a:lstStyle/>
+          <a:p>
+            <a:pPr algn="ctr"/>
+            <a:r>
+              <a:rPr sz="4800" b="1" i="0">
+                <a:solidFill>
+                  <a:srgbClr val="FFFFFF"/>
+                </a:solidFill>
+                <a:latin typeface="Arial"/>
+              </a:rPr>
+              <a:t>(*)一万    年と   永遠に</a:t>
+            </a:r>
+          </a:p>
+        </p:txBody>
+      </p:sp>
+      <p:sp>
+        <p:nvSpPr>
+          <p:cNvPr id="5" name="TextBox 4"/>
+          <p:cNvSpPr txBox="1"/>
+          <p:nvPr/>
+        </p:nvSpPr>
+        <p:spPr>
+          <a:xfrm>
+            <a:off x="640080" y="3753612"/>
+            <a:ext cx="10911535" cy="365760"/>
+          </a:xfrm>
+          <a:prstGeom prst="rect">
+            <a:avLst/>
+          </a:prstGeom>
+          <a:noFill/>
+        </p:spPr>
+        <p:txBody>
+          <a:bodyPr wrap="square">
+            <a:spAutoFit/>
+          </a:bodyPr>
+          <a:lstStyle/>
+          <a:p>
+            <a:pPr algn="ctr"/>
+            <a:r>
+              <a:rPr sz="2400" b="0" i="1">
+                <a:solidFill>
+                  <a:srgbClr val="AAAAAA"/>
+                </a:solidFill>
+                <a:latin typeface="Arial"/>
+              </a:rPr>
+              <a:t>Ichiman   nento Eienni</a:t>
+            </a:r>
+          </a:p>
+        </p:txBody>
+      </p:sp>
+      <p:sp>
+        <p:nvSpPr>
+          <p:cNvPr id="6" name="TextBox 5"/>
+          <p:cNvSpPr txBox="1"/>
+          <p:nvPr/>
+        </p:nvSpPr>
+        <p:spPr>
+          <a:xfrm>
+            <a:off x="640080" y="4530852"/>
+            <a:ext cx="10911535" cy="310896"/>
+          </a:xfrm>
+          <a:prstGeom prst="rect">
+            <a:avLst/>
+          </a:prstGeom>
+          <a:noFill/>
+        </p:spPr>
+        <p:txBody>
+          <a:bodyPr wrap="square">
+            <a:spAutoFit/>
+          </a:bodyPr>
+          <a:lstStyle/>
+          <a:p>
+            <a:pPr algn="ctr"/>
+            <a:r>
+              <a:rPr sz="2000" b="0" i="1">
+                <a:solidFill>
+                  <a:srgbClr val="828282"/>
+                </a:solidFill>
+                <a:latin typeface="Arial"/>
+              </a:rPr>
+              <a:t>Quão bom é Ele, quão grande é Seu amor</a:t>
+            </a:r>
+          </a:p>
+        </p:txBody>
+      </p:sp>
+      <p:sp>
+        <p:nvSpPr>
+          <p:cNvPr id="7" name="TextBox 6"/>
+          <p:cNvSpPr txBox="1"/>
+          <p:nvPr/>
+        </p:nvSpPr>
+        <p:spPr>
+          <a:xfrm>
+            <a:off x="640080" y="4896612"/>
+            <a:ext cx="10911535" cy="310896"/>
+          </a:xfrm>
+          <a:prstGeom prst="rect">
+            <a:avLst/>
+          </a:prstGeom>
+          <a:noFill/>
+        </p:spPr>
+        <p:txBody>
+          <a:bodyPr wrap="square">
+            <a:spAutoFit/>
+          </a:bodyPr>
+          <a:lstStyle/>
+          <a:p>
+            <a:pPr algn="ctr"/>
+            <a:r>
+              <a:rPr sz="2000" b="0" i="1">
+                <a:solidFill>
+                  <a:srgbClr val="828282"/>
+                </a:solidFill>
+                <a:latin typeface="Arial"/>
+              </a:rPr>
+              <a:t>Quaisquer que sejam as perdas de amanhã</a:t>
             </a:r>
           </a:p>
         </p:txBody>
@@ -4323,23 +4675,23 @@
         </p:nvSpPr>
         <p:spPr>
           <a:xfrm>
-            <a:off x="594360" y="2258568"/>
-            <a:ext cx="11002975" cy="685800"/>
-          </a:xfrm>
-          <a:prstGeom prst="rect">
-            <a:avLst/>
-          </a:prstGeom>
-          <a:noFill/>
-        </p:spPr>
-        <p:txBody>
-          <a:bodyPr wrap="square">
-            <a:spAutoFit/>
-          </a:bodyPr>
-          <a:lstStyle/>
-          <a:p>
-            <a:pPr algn="ctr"/>
-            <a:r>
-              <a:rPr sz="4400" b="1" i="0">
+            <a:off x="640080" y="2052828"/>
+            <a:ext cx="10911535" cy="731520"/>
+          </a:xfrm>
+          <a:prstGeom prst="rect">
+            <a:avLst/>
+          </a:prstGeom>
+          <a:noFill/>
+        </p:spPr>
+        <p:txBody>
+          <a:bodyPr wrap="square">
+            <a:spAutoFit/>
+          </a:bodyPr>
+          <a:lstStyle/>
+          <a:p>
+            <a:pPr algn="ctr"/>
+            <a:r>
+              <a:rPr sz="4800" b="1" i="0">
                 <a:solidFill>
                   <a:srgbClr val="FFFFFF"/>
                 </a:solidFill>
@@ -4358,29 +4710,29 @@
         </p:nvSpPr>
         <p:spPr>
           <a:xfrm>
-            <a:off x="594360" y="2980944"/>
-            <a:ext cx="11002975" cy="347472"/>
-          </a:xfrm>
-          <a:prstGeom prst="rect">
-            <a:avLst/>
-          </a:prstGeom>
-          <a:noFill/>
-        </p:spPr>
-        <p:txBody>
-          <a:bodyPr wrap="square">
-            <a:spAutoFit/>
-          </a:bodyPr>
-          <a:lstStyle/>
-          <a:p>
-            <a:pPr algn="ctr"/>
-            <a:r>
-              <a:rPr sz="2200" b="0" i="1">
-                <a:solidFill>
-                  <a:srgbClr val="8C8C8C"/>
-                </a:solidFill>
-                <a:latin typeface="Arial"/>
-              </a:rPr>
-              <a:t/>
+            <a:off x="640080" y="2985516"/>
+            <a:ext cx="10911535" cy="731520"/>
+          </a:xfrm>
+          <a:prstGeom prst="rect">
+            <a:avLst/>
+          </a:prstGeom>
+          <a:noFill/>
+        </p:spPr>
+        <p:txBody>
+          <a:bodyPr wrap="square">
+            <a:spAutoFit/>
+          </a:bodyPr>
+          <a:lstStyle/>
+          <a:p>
+            <a:pPr algn="ctr"/>
+            <a:r>
+              <a:rPr sz="4800" b="1" i="0">
+                <a:solidFill>
+                  <a:srgbClr val="FFFFFF"/>
+                </a:solidFill>
+                <a:latin typeface="Arial"/>
+              </a:rPr>
+              <a:t>Cante como nunca antes</a:t>
             </a:r>
           </a:p>
         </p:txBody>
@@ -4393,28 +4745,561 @@
         </p:nvSpPr>
         <p:spPr>
           <a:xfrm>
-            <a:off x="594360" y="3529584"/>
-            <a:ext cx="11002975" cy="685800"/>
-          </a:xfrm>
-          <a:prstGeom prst="rect">
-            <a:avLst/>
-          </a:prstGeom>
-          <a:noFill/>
-        </p:spPr>
-        <p:txBody>
-          <a:bodyPr wrap="square">
-            <a:spAutoFit/>
-          </a:bodyPr>
-          <a:lstStyle/>
-          <a:p>
-            <a:pPr algn="ctr"/>
-            <a:r>
-              <a:rPr sz="4400" b="1" i="0">
+            <a:off x="640080" y="4128516"/>
+            <a:ext cx="10911535" cy="310896"/>
+          </a:xfrm>
+          <a:prstGeom prst="rect">
+            <a:avLst/>
+          </a:prstGeom>
+          <a:noFill/>
+        </p:spPr>
+        <p:txBody>
+          <a:bodyPr wrap="square">
+            <a:spAutoFit/>
+          </a:bodyPr>
+          <a:lstStyle/>
+          <a:p>
+            <a:pPr algn="ctr"/>
+            <a:r>
+              <a:rPr sz="2000" b="0" i="0">
+                <a:solidFill>
+                  <a:srgbClr val="828282"/>
+                </a:solidFill>
+                <a:latin typeface="Arial"/>
+              </a:rPr>
+              <a:t>たましいよ   ほめ歌え   聖なる   主に</a:t>
+            </a:r>
+          </a:p>
+        </p:txBody>
+      </p:sp>
+      <p:sp>
+        <p:nvSpPr>
+          <p:cNvPr id="5" name="TextBox 4"/>
+          <p:cNvSpPr txBox="1"/>
+          <p:nvPr/>
+        </p:nvSpPr>
+        <p:spPr>
+          <a:xfrm>
+            <a:off x="640080" y="4494276"/>
+            <a:ext cx="10911535" cy="310896"/>
+          </a:xfrm>
+          <a:prstGeom prst="rect">
+            <a:avLst/>
+          </a:prstGeom>
+          <a:noFill/>
+        </p:spPr>
+        <p:txBody>
+          <a:bodyPr wrap="square">
+            <a:spAutoFit/>
+          </a:bodyPr>
+          <a:lstStyle/>
+          <a:p>
+            <a:pPr algn="ctr"/>
+            <a:r>
+              <a:rPr sz="2000" b="0" i="0">
+                <a:solidFill>
+                  <a:srgbClr val="828282"/>
+                </a:solidFill>
+                <a:latin typeface="Arial"/>
+              </a:rPr>
+              <a:t>こころ   捧げ  うたえ 素晴らしい  主に</a:t>
+            </a:r>
+          </a:p>
+        </p:txBody>
+      </p:sp>
+    </p:spTree>
+  </p:cSld>
+  <p:clrMapOvr>
+    <a:masterClrMapping/>
+  </p:clrMapOvr>
+</p:sld>
+</file>
+
+<file path=ppt/slides/slide20.xml><?xml version="1.0" encoding="utf-8"?>
+<p:sld xmlns:a="http://schemas.openxmlformats.org/drawingml/2006/main" xmlns:p="http://schemas.openxmlformats.org/presentationml/2006/main" xmlns:r="http://schemas.openxmlformats.org/officeDocument/2006/relationships">
+  <p:cSld>
+    <p:bg>
+      <p:bgPr>
+        <a:solidFill>
+          <a:srgbClr val="000000"/>
+        </a:solidFill>
+        <a:effectLst/>
+      </p:bgPr>
+    </p:bg>
+    <p:spTree>
+      <p:nvGrpSpPr>
+        <p:cNvPr id="1" name=""/>
+        <p:cNvGrpSpPr/>
+        <p:nvPr/>
+      </p:nvGrpSpPr>
+      <p:grpSpPr/>
+      <p:sp>
+        <p:nvSpPr>
+          <p:cNvPr id="2" name="TextBox 1"/>
+          <p:cNvSpPr txBox="1"/>
+          <p:nvPr/>
+        </p:nvSpPr>
+        <p:spPr>
+          <a:xfrm>
+            <a:off x="640080" y="1650492"/>
+            <a:ext cx="10911535" cy="731520"/>
+          </a:xfrm>
+          <a:prstGeom prst="rect">
+            <a:avLst/>
+          </a:prstGeom>
+          <a:noFill/>
+        </p:spPr>
+        <p:txBody>
+          <a:bodyPr wrap="square">
+            <a:spAutoFit/>
+          </a:bodyPr>
+          <a:lstStyle/>
+          <a:p>
+            <a:pPr algn="ctr"/>
+            <a:r>
+              <a:rPr sz="4800" b="1" i="0">
                 <a:solidFill>
                   <a:srgbClr val="FFFFFF"/>
                 </a:solidFill>
                 <a:latin typeface="Arial"/>
               </a:rPr>
+              <a:t>たましいよ   ほめ歌え   聖なる   主に</a:t>
+            </a:r>
+          </a:p>
+        </p:txBody>
+      </p:sp>
+      <p:sp>
+        <p:nvSpPr>
+          <p:cNvPr id="3" name="TextBox 2"/>
+          <p:cNvSpPr txBox="1"/>
+          <p:nvPr/>
+        </p:nvSpPr>
+        <p:spPr>
+          <a:xfrm>
+            <a:off x="640080" y="2418588"/>
+            <a:ext cx="10911535" cy="365760"/>
+          </a:xfrm>
+          <a:prstGeom prst="rect">
+            <a:avLst/>
+          </a:prstGeom>
+          <a:noFill/>
+        </p:spPr>
+        <p:txBody>
+          <a:bodyPr wrap="square">
+            <a:spAutoFit/>
+          </a:bodyPr>
+          <a:lstStyle/>
+          <a:p>
+            <a:pPr algn="ctr"/>
+            <a:r>
+              <a:rPr sz="2400" b="0" i="1">
+                <a:solidFill>
+                  <a:srgbClr val="AAAAAA"/>
+                </a:solidFill>
+                <a:latin typeface="Arial"/>
+              </a:rPr>
+              <a:t>Tamashiiyo Homeutae Seinaru Shuni</a:t>
+            </a:r>
+          </a:p>
+        </p:txBody>
+      </p:sp>
+      <p:sp>
+        <p:nvSpPr>
+          <p:cNvPr id="4" name="TextBox 3"/>
+          <p:cNvSpPr txBox="1"/>
+          <p:nvPr/>
+        </p:nvSpPr>
+        <p:spPr>
+          <a:xfrm>
+            <a:off x="640080" y="2985516"/>
+            <a:ext cx="10911535" cy="731520"/>
+          </a:xfrm>
+          <a:prstGeom prst="rect">
+            <a:avLst/>
+          </a:prstGeom>
+          <a:noFill/>
+        </p:spPr>
+        <p:txBody>
+          <a:bodyPr wrap="square">
+            <a:spAutoFit/>
+          </a:bodyPr>
+          <a:lstStyle/>
+          <a:p>
+            <a:pPr algn="ctr"/>
+            <a:r>
+              <a:rPr sz="4800" b="1" i="0">
+                <a:solidFill>
+                  <a:srgbClr val="FFFFFF"/>
+                </a:solidFill>
+                <a:latin typeface="Arial"/>
+              </a:rPr>
+              <a:t>こころ   捧げ  うたえ 素晴らしい  主に</a:t>
+            </a:r>
+          </a:p>
+        </p:txBody>
+      </p:sp>
+      <p:sp>
+        <p:nvSpPr>
+          <p:cNvPr id="5" name="TextBox 4"/>
+          <p:cNvSpPr txBox="1"/>
+          <p:nvPr/>
+        </p:nvSpPr>
+        <p:spPr>
+          <a:xfrm>
+            <a:off x="640080" y="3753612"/>
+            <a:ext cx="10911535" cy="365760"/>
+          </a:xfrm>
+          <a:prstGeom prst="rect">
+            <a:avLst/>
+          </a:prstGeom>
+          <a:noFill/>
+        </p:spPr>
+        <p:txBody>
+          <a:bodyPr wrap="square">
+            <a:spAutoFit/>
+          </a:bodyPr>
+          <a:lstStyle/>
+          <a:p>
+            <a:pPr algn="ctr"/>
+            <a:r>
+              <a:rPr sz="2400" b="0" i="1">
+                <a:solidFill>
+                  <a:srgbClr val="AAAAAA"/>
+                </a:solidFill>
+                <a:latin typeface="Arial"/>
+              </a:rPr>
+              <a:t>Kokoro Sasage Utae Subarashii Shuni</a:t>
+            </a:r>
+          </a:p>
+        </p:txBody>
+      </p:sp>
+      <p:sp>
+        <p:nvSpPr>
+          <p:cNvPr id="6" name="TextBox 5"/>
+          <p:cNvSpPr txBox="1"/>
+          <p:nvPr/>
+        </p:nvSpPr>
+        <p:spPr>
+          <a:xfrm>
+            <a:off x="640080" y="4530852"/>
+            <a:ext cx="10911535" cy="310896"/>
+          </a:xfrm>
+          <a:prstGeom prst="rect">
+            <a:avLst/>
+          </a:prstGeom>
+          <a:noFill/>
+        </p:spPr>
+        <p:txBody>
+          <a:bodyPr wrap="square">
+            <a:spAutoFit/>
+          </a:bodyPr>
+          <a:lstStyle/>
+          <a:p>
+            <a:pPr algn="ctr"/>
+            <a:r>
+              <a:rPr sz="2000" b="0" i="1">
+                <a:solidFill>
+                  <a:srgbClr val="828282"/>
+                </a:solidFill>
+                <a:latin typeface="Arial"/>
+              </a:rPr>
+              <a:t>Bendiga o Senhor, ó minha alma</a:t>
+            </a:r>
+          </a:p>
+        </p:txBody>
+      </p:sp>
+      <p:sp>
+        <p:nvSpPr>
+          <p:cNvPr id="7" name="TextBox 6"/>
+          <p:cNvSpPr txBox="1"/>
+          <p:nvPr/>
+        </p:nvSpPr>
+        <p:spPr>
+          <a:xfrm>
+            <a:off x="640080" y="4896612"/>
+            <a:ext cx="10911535" cy="310896"/>
+          </a:xfrm>
+          <a:prstGeom prst="rect">
+            <a:avLst/>
+          </a:prstGeom>
+          <a:noFill/>
+        </p:spPr>
+        <p:txBody>
+          <a:bodyPr wrap="square">
+            <a:spAutoFit/>
+          </a:bodyPr>
+          <a:lstStyle/>
+          <a:p>
+            <a:pPr algn="ctr"/>
+            <a:r>
+              <a:rPr sz="2000" b="0" i="1">
+                <a:solidFill>
+                  <a:srgbClr val="828282"/>
+                </a:solidFill>
+                <a:latin typeface="Arial"/>
+              </a:rPr>
+              <a:t>Ó minha alma</a:t>
+            </a:r>
+          </a:p>
+        </p:txBody>
+      </p:sp>
+    </p:spTree>
+  </p:cSld>
+  <p:clrMapOvr>
+    <a:masterClrMapping/>
+  </p:clrMapOvr>
+</p:sld>
+</file>
+
+<file path=ppt/slides/slide21.xml><?xml version="1.0" encoding="utf-8"?>
+<p:sld xmlns:a="http://schemas.openxmlformats.org/drawingml/2006/main" xmlns:p="http://schemas.openxmlformats.org/presentationml/2006/main" xmlns:r="http://schemas.openxmlformats.org/officeDocument/2006/relationships">
+  <p:cSld>
+    <p:bg>
+      <p:bgPr>
+        <a:solidFill>
+          <a:srgbClr val="000000"/>
+        </a:solidFill>
+        <a:effectLst/>
+      </p:bgPr>
+    </p:bg>
+    <p:spTree>
+      <p:nvGrpSpPr>
+        <p:cNvPr id="1" name=""/>
+        <p:cNvGrpSpPr/>
+        <p:nvPr/>
+      </p:nvGrpSpPr>
+      <p:grpSpPr/>
+      <p:sp>
+        <p:nvSpPr>
+          <p:cNvPr id="2" name="TextBox 1"/>
+          <p:cNvSpPr txBox="1"/>
+          <p:nvPr/>
+        </p:nvSpPr>
+        <p:spPr>
+          <a:xfrm>
+            <a:off x="640080" y="2052828"/>
+            <a:ext cx="10911535" cy="731520"/>
+          </a:xfrm>
+          <a:prstGeom prst="rect">
+            <a:avLst/>
+          </a:prstGeom>
+          <a:noFill/>
+        </p:spPr>
+        <p:txBody>
+          <a:bodyPr wrap="square">
+            <a:spAutoFit/>
+          </a:bodyPr>
+          <a:lstStyle/>
+          <a:p>
+            <a:pPr algn="ctr"/>
+            <a:r>
+              <a:rPr sz="4800" b="1" i="0">
+                <a:solidFill>
+                  <a:srgbClr val="FFFFFF"/>
+                </a:solidFill>
+                <a:latin typeface="Arial"/>
+              </a:rPr>
+              <a:t>Bendiga o Senhor, ó minha alma</a:t>
+            </a:r>
+          </a:p>
+        </p:txBody>
+      </p:sp>
+      <p:sp>
+        <p:nvSpPr>
+          <p:cNvPr id="3" name="TextBox 2"/>
+          <p:cNvSpPr txBox="1"/>
+          <p:nvPr/>
+        </p:nvSpPr>
+        <p:spPr>
+          <a:xfrm>
+            <a:off x="640080" y="2985516"/>
+            <a:ext cx="10911535" cy="731520"/>
+          </a:xfrm>
+          <a:prstGeom prst="rect">
+            <a:avLst/>
+          </a:prstGeom>
+          <a:noFill/>
+        </p:spPr>
+        <p:txBody>
+          <a:bodyPr wrap="square">
+            <a:spAutoFit/>
+          </a:bodyPr>
+          <a:lstStyle/>
+          <a:p>
+            <a:pPr algn="ctr"/>
+            <a:r>
+              <a:rPr sz="4800" b="1" i="0">
+                <a:solidFill>
+                  <a:srgbClr val="FFFFFF"/>
+                </a:solidFill>
+                <a:latin typeface="Arial"/>
+              </a:rPr>
+              <a:t>Ó minha alma</a:t>
+            </a:r>
+          </a:p>
+        </p:txBody>
+      </p:sp>
+      <p:sp>
+        <p:nvSpPr>
+          <p:cNvPr id="4" name="TextBox 3"/>
+          <p:cNvSpPr txBox="1"/>
+          <p:nvPr/>
+        </p:nvSpPr>
+        <p:spPr>
+          <a:xfrm>
+            <a:off x="640080" y="4128516"/>
+            <a:ext cx="10911535" cy="310896"/>
+          </a:xfrm>
+          <a:prstGeom prst="rect">
+            <a:avLst/>
+          </a:prstGeom>
+          <a:noFill/>
+        </p:spPr>
+        <p:txBody>
+          <a:bodyPr wrap="square">
+            <a:spAutoFit/>
+          </a:bodyPr>
+          <a:lstStyle/>
+          <a:p>
+            <a:pPr algn="ctr"/>
+            <a:r>
+              <a:rPr sz="2000" b="0" i="0">
+                <a:solidFill>
+                  <a:srgbClr val="828282"/>
+                </a:solidFill>
+                <a:latin typeface="Arial"/>
+              </a:rPr>
+              <a:t>たましいよ   ほめ歌え   聖なる   主に</a:t>
+            </a:r>
+          </a:p>
+        </p:txBody>
+      </p:sp>
+      <p:sp>
+        <p:nvSpPr>
+          <p:cNvPr id="5" name="TextBox 4"/>
+          <p:cNvSpPr txBox="1"/>
+          <p:nvPr/>
+        </p:nvSpPr>
+        <p:spPr>
+          <a:xfrm>
+            <a:off x="640080" y="4494276"/>
+            <a:ext cx="10911535" cy="310896"/>
+          </a:xfrm>
+          <a:prstGeom prst="rect">
+            <a:avLst/>
+          </a:prstGeom>
+          <a:noFill/>
+        </p:spPr>
+        <p:txBody>
+          <a:bodyPr wrap="square">
+            <a:spAutoFit/>
+          </a:bodyPr>
+          <a:lstStyle/>
+          <a:p>
+            <a:pPr algn="ctr"/>
+            <a:r>
+              <a:rPr sz="2000" b="0" i="0">
+                <a:solidFill>
+                  <a:srgbClr val="828282"/>
+                </a:solidFill>
+                <a:latin typeface="Arial"/>
+              </a:rPr>
+              <a:t>こころ   捧げ  うたえ 素晴らしい  主に</a:t>
+            </a:r>
+          </a:p>
+        </p:txBody>
+      </p:sp>
+    </p:spTree>
+  </p:cSld>
+  <p:clrMapOvr>
+    <a:masterClrMapping/>
+  </p:clrMapOvr>
+</p:sld>
+</file>
+
+<file path=ppt/slides/slide22.xml><?xml version="1.0" encoding="utf-8"?>
+<p:sld xmlns:a="http://schemas.openxmlformats.org/drawingml/2006/main" xmlns:p="http://schemas.openxmlformats.org/presentationml/2006/main" xmlns:r="http://schemas.openxmlformats.org/officeDocument/2006/relationships">
+  <p:cSld>
+    <p:bg>
+      <p:bgPr>
+        <a:solidFill>
+          <a:srgbClr val="000000"/>
+        </a:solidFill>
+        <a:effectLst/>
+      </p:bgPr>
+    </p:bg>
+    <p:spTree>
+      <p:nvGrpSpPr>
+        <p:cNvPr id="1" name=""/>
+        <p:cNvGrpSpPr/>
+        <p:nvPr/>
+      </p:nvGrpSpPr>
+      <p:grpSpPr/>
+      <p:sp>
+        <p:nvSpPr>
+          <p:cNvPr id="2" name="TextBox 1"/>
+          <p:cNvSpPr txBox="1"/>
+          <p:nvPr/>
+        </p:nvSpPr>
+        <p:spPr>
+          <a:xfrm>
+            <a:off x="640080" y="2052828"/>
+            <a:ext cx="10911535" cy="731520"/>
+          </a:xfrm>
+          <a:prstGeom prst="rect">
+            <a:avLst/>
+          </a:prstGeom>
+          <a:noFill/>
+        </p:spPr>
+        <p:txBody>
+          <a:bodyPr wrap="square">
+            <a:spAutoFit/>
+          </a:bodyPr>
+          <a:lstStyle/>
+          <a:p>
+            <a:pPr algn="ctr"/>
+            <a:r>
+              <a:rPr sz="4800" b="1" i="0">
+                <a:solidFill>
+                  <a:srgbClr val="FFFFFF"/>
+                </a:solidFill>
+                <a:latin typeface="Arial"/>
+              </a:rPr>
+              <a:t>Adore Seu santo nome</a:t>
+            </a:r>
+          </a:p>
+        </p:txBody>
+      </p:sp>
+      <p:sp>
+        <p:nvSpPr>
+          <p:cNvPr id="3" name="TextBox 2"/>
+          <p:cNvSpPr txBox="1"/>
+          <p:nvPr/>
+        </p:nvSpPr>
+        <p:spPr>
+          <a:xfrm>
+            <a:off x="640080" y="2985516"/>
+            <a:ext cx="10911535" cy="731520"/>
+          </a:xfrm>
+          <a:prstGeom prst="rect">
+            <a:avLst/>
+          </a:prstGeom>
+          <a:noFill/>
+        </p:spPr>
+        <p:txBody>
+          <a:bodyPr wrap="square">
+            <a:spAutoFit/>
+          </a:bodyPr>
+          <a:lstStyle/>
+          <a:p>
+            <a:pPr algn="ctr"/>
+            <a:r>
+              <a:rPr sz="4800" b="1" i="0">
+                <a:solidFill>
+                  <a:srgbClr val="FFFFFF"/>
+                </a:solidFill>
+                <a:latin typeface="Arial"/>
+              </a:rPr>
               <a:t>Cante como nunca antes</a:t>
             </a:r>
           </a:p>
@@ -4422,35 +5307,454 @@
       </p:sp>
       <p:sp>
         <p:nvSpPr>
+          <p:cNvPr id="4" name="TextBox 3"/>
+          <p:cNvSpPr txBox="1"/>
+          <p:nvPr/>
+        </p:nvSpPr>
+        <p:spPr>
+          <a:xfrm>
+            <a:off x="640080" y="4128516"/>
+            <a:ext cx="10911535" cy="310896"/>
+          </a:xfrm>
+          <a:prstGeom prst="rect">
+            <a:avLst/>
+          </a:prstGeom>
+          <a:noFill/>
+        </p:spPr>
+        <p:txBody>
+          <a:bodyPr wrap="square">
+            <a:spAutoFit/>
+          </a:bodyPr>
+          <a:lstStyle/>
+          <a:p>
+            <a:pPr algn="ctr"/>
+            <a:r>
+              <a:rPr sz="2000" b="0" i="0">
+                <a:solidFill>
+                  <a:srgbClr val="828282"/>
+                </a:solidFill>
+                <a:latin typeface="Arial"/>
+              </a:rPr>
+              <a:t>たましいよ   ほめ歌え   聖なる   主に</a:t>
+            </a:r>
+          </a:p>
+        </p:txBody>
+      </p:sp>
+      <p:sp>
+        <p:nvSpPr>
           <p:cNvPr id="5" name="TextBox 4"/>
           <p:cNvSpPr txBox="1"/>
           <p:nvPr/>
         </p:nvSpPr>
         <p:spPr>
           <a:xfrm>
-            <a:off x="594360" y="4251960"/>
-            <a:ext cx="11002975" cy="347472"/>
-          </a:xfrm>
-          <a:prstGeom prst="rect">
-            <a:avLst/>
-          </a:prstGeom>
-          <a:noFill/>
-        </p:spPr>
-        <p:txBody>
-          <a:bodyPr wrap="square">
-            <a:spAutoFit/>
-          </a:bodyPr>
-          <a:lstStyle/>
-          <a:p>
-            <a:pPr algn="ctr"/>
-            <a:r>
-              <a:rPr sz="2200" b="0" i="1">
-                <a:solidFill>
-                  <a:srgbClr val="8C8C8C"/>
-                </a:solidFill>
-                <a:latin typeface="Arial"/>
-              </a:rPr>
-              <a:t/>
+            <a:off x="640080" y="4494276"/>
+            <a:ext cx="10911535" cy="310896"/>
+          </a:xfrm>
+          <a:prstGeom prst="rect">
+            <a:avLst/>
+          </a:prstGeom>
+          <a:noFill/>
+        </p:spPr>
+        <p:txBody>
+          <a:bodyPr wrap="square">
+            <a:spAutoFit/>
+          </a:bodyPr>
+          <a:lstStyle/>
+          <a:p>
+            <a:pPr algn="ctr"/>
+            <a:r>
+              <a:rPr sz="2000" b="0" i="0">
+                <a:solidFill>
+                  <a:srgbClr val="828282"/>
+                </a:solidFill>
+                <a:latin typeface="Arial"/>
+              </a:rPr>
+              <a:t>こころ   捧げ  うたえ 素晴らしい  主に</a:t>
+            </a:r>
+          </a:p>
+        </p:txBody>
+      </p:sp>
+    </p:spTree>
+  </p:cSld>
+  <p:clrMapOvr>
+    <a:masterClrMapping/>
+  </p:clrMapOvr>
+</p:sld>
+</file>
+
+<file path=ppt/slides/slide23.xml><?xml version="1.0" encoding="utf-8"?>
+<p:sld xmlns:a="http://schemas.openxmlformats.org/drawingml/2006/main" xmlns:p="http://schemas.openxmlformats.org/presentationml/2006/main" xmlns:r="http://schemas.openxmlformats.org/officeDocument/2006/relationships">
+  <p:cSld>
+    <p:bg>
+      <p:bgPr>
+        <a:solidFill>
+          <a:srgbClr val="000000"/>
+        </a:solidFill>
+        <a:effectLst/>
+      </p:bgPr>
+    </p:bg>
+    <p:spTree>
+      <p:nvGrpSpPr>
+        <p:cNvPr id="1" name=""/>
+        <p:cNvGrpSpPr/>
+        <p:nvPr/>
+      </p:nvGrpSpPr>
+      <p:grpSpPr/>
+      <p:sp>
+        <p:nvSpPr>
+          <p:cNvPr id="2" name="TextBox 1"/>
+          <p:cNvSpPr txBox="1"/>
+          <p:nvPr/>
+        </p:nvSpPr>
+        <p:spPr>
+          <a:xfrm>
+            <a:off x="640080" y="2052828"/>
+            <a:ext cx="10911535" cy="731520"/>
+          </a:xfrm>
+          <a:prstGeom prst="rect">
+            <a:avLst/>
+          </a:prstGeom>
+          <a:noFill/>
+        </p:spPr>
+        <p:txBody>
+          <a:bodyPr wrap="square">
+            <a:spAutoFit/>
+          </a:bodyPr>
+          <a:lstStyle/>
+          <a:p>
+            <a:pPr algn="ctr"/>
+            <a:r>
+              <a:rPr sz="4800" b="1" i="0">
+                <a:solidFill>
+                  <a:srgbClr val="FFFFFF"/>
+                </a:solidFill>
+                <a:latin typeface="Arial"/>
+              </a:rPr>
+              <a:t>Meu canto ainda assim será</a:t>
+            </a:r>
+          </a:p>
+        </p:txBody>
+      </p:sp>
+      <p:sp>
+        <p:nvSpPr>
+          <p:cNvPr id="3" name="TextBox 2"/>
+          <p:cNvSpPr txBox="1"/>
+          <p:nvPr/>
+        </p:nvSpPr>
+        <p:spPr>
+          <a:xfrm>
+            <a:off x="640080" y="2985516"/>
+            <a:ext cx="10911535" cy="731520"/>
+          </a:xfrm>
+          <a:prstGeom prst="rect">
+            <a:avLst/>
+          </a:prstGeom>
+          <a:noFill/>
+        </p:spPr>
+        <p:txBody>
+          <a:bodyPr wrap="square">
+            <a:spAutoFit/>
+          </a:bodyPr>
+          <a:lstStyle/>
+          <a:p>
+            <a:pPr algn="ctr"/>
+            <a:r>
+              <a:rPr sz="4800" b="1" i="0">
+                <a:solidFill>
+                  <a:srgbClr val="FFFFFF"/>
+                </a:solidFill>
+                <a:latin typeface="Arial"/>
+              </a:rPr>
+              <a:t>Bendiga o Senhor, ó minha alma</a:t>
+            </a:r>
+          </a:p>
+        </p:txBody>
+      </p:sp>
+    </p:spTree>
+  </p:cSld>
+  <p:clrMapOvr>
+    <a:masterClrMapping/>
+  </p:clrMapOvr>
+</p:sld>
+</file>
+
+<file path=ppt/slides/slide24.xml><?xml version="1.0" encoding="utf-8"?>
+<p:sld xmlns:a="http://schemas.openxmlformats.org/drawingml/2006/main" xmlns:p="http://schemas.openxmlformats.org/presentationml/2006/main" xmlns:r="http://schemas.openxmlformats.org/officeDocument/2006/relationships">
+  <p:cSld>
+    <p:bg>
+      <p:bgPr>
+        <a:solidFill>
+          <a:srgbClr val="000000"/>
+        </a:solidFill>
+        <a:effectLst/>
+      </p:bgPr>
+    </p:bg>
+    <p:spTree>
+      <p:nvGrpSpPr>
+        <p:cNvPr id="1" name=""/>
+        <p:cNvGrpSpPr/>
+        <p:nvPr/>
+      </p:nvGrpSpPr>
+      <p:grpSpPr/>
+      <p:sp>
+        <p:nvSpPr>
+          <p:cNvPr id="2" name="TextBox 1"/>
+          <p:cNvSpPr txBox="1"/>
+          <p:nvPr/>
+        </p:nvSpPr>
+        <p:spPr>
+          <a:xfrm>
+            <a:off x="640080" y="2052828"/>
+            <a:ext cx="10911535" cy="731520"/>
+          </a:xfrm>
+          <a:prstGeom prst="rect">
+            <a:avLst/>
+          </a:prstGeom>
+          <a:noFill/>
+        </p:spPr>
+        <p:txBody>
+          <a:bodyPr wrap="square">
+            <a:spAutoFit/>
+          </a:bodyPr>
+          <a:lstStyle/>
+          <a:p>
+            <a:pPr algn="ctr"/>
+            <a:r>
+              <a:rPr sz="4800" b="1" i="0">
+                <a:solidFill>
+                  <a:srgbClr val="FFFFFF"/>
+                </a:solidFill>
+                <a:latin typeface="Arial"/>
+              </a:rPr>
+              <a:t>Ó minha alma</a:t>
+            </a:r>
+          </a:p>
+        </p:txBody>
+      </p:sp>
+      <p:sp>
+        <p:nvSpPr>
+          <p:cNvPr id="3" name="TextBox 2"/>
+          <p:cNvSpPr txBox="1"/>
+          <p:nvPr/>
+        </p:nvSpPr>
+        <p:spPr>
+          <a:xfrm>
+            <a:off x="640080" y="2985516"/>
+            <a:ext cx="10911535" cy="731520"/>
+          </a:xfrm>
+          <a:prstGeom prst="rect">
+            <a:avLst/>
+          </a:prstGeom>
+          <a:noFill/>
+        </p:spPr>
+        <p:txBody>
+          <a:bodyPr wrap="square">
+            <a:spAutoFit/>
+          </a:bodyPr>
+          <a:lstStyle/>
+          <a:p>
+            <a:pPr algn="ctr"/>
+            <a:r>
+              <a:rPr sz="4800" b="1" i="0">
+                <a:solidFill>
+                  <a:srgbClr val="FFFFFF"/>
+                </a:solidFill>
+                <a:latin typeface="Arial"/>
+              </a:rPr>
+              <a:t>Adore Seu santo nome</a:t>
+            </a:r>
+          </a:p>
+        </p:txBody>
+      </p:sp>
+    </p:spTree>
+  </p:cSld>
+  <p:clrMapOvr>
+    <a:masterClrMapping/>
+  </p:clrMapOvr>
+</p:sld>
+</file>
+
+<file path=ppt/slides/slide25.xml><?xml version="1.0" encoding="utf-8"?>
+<p:sld xmlns:a="http://schemas.openxmlformats.org/drawingml/2006/main" xmlns:p="http://schemas.openxmlformats.org/presentationml/2006/main" xmlns:r="http://schemas.openxmlformats.org/officeDocument/2006/relationships">
+  <p:cSld>
+    <p:bg>
+      <p:bgPr>
+        <a:solidFill>
+          <a:srgbClr val="000000"/>
+        </a:solidFill>
+        <a:effectLst/>
+      </p:bgPr>
+    </p:bg>
+    <p:spTree>
+      <p:nvGrpSpPr>
+        <p:cNvPr id="1" name=""/>
+        <p:cNvGrpSpPr/>
+        <p:nvPr/>
+      </p:nvGrpSpPr>
+      <p:grpSpPr/>
+      <p:sp>
+        <p:nvSpPr>
+          <p:cNvPr id="2" name="TextBox 1"/>
+          <p:cNvSpPr txBox="1"/>
+          <p:nvPr/>
+        </p:nvSpPr>
+        <p:spPr>
+          <a:xfrm>
+            <a:off x="640080" y="2052828"/>
+            <a:ext cx="10911535" cy="731520"/>
+          </a:xfrm>
+          <a:prstGeom prst="rect">
+            <a:avLst/>
+          </a:prstGeom>
+          <a:noFill/>
+        </p:spPr>
+        <p:txBody>
+          <a:bodyPr wrap="square">
+            <a:spAutoFit/>
+          </a:bodyPr>
+          <a:lstStyle/>
+          <a:p>
+            <a:pPr algn="ctr"/>
+            <a:r>
+              <a:rPr sz="3800" b="1" i="0">
+                <a:solidFill>
+                  <a:srgbClr val="FFFFFF"/>
+                </a:solidFill>
+                <a:latin typeface="Arial"/>
+              </a:rPr>
+              <a:t>Dez mil razões pro meu coração encontrar</a:t>
+            </a:r>
+          </a:p>
+        </p:txBody>
+      </p:sp>
+      <p:sp>
+        <p:nvSpPr>
+          <p:cNvPr id="3" name="TextBox 2"/>
+          <p:cNvSpPr txBox="1"/>
+          <p:nvPr/>
+        </p:nvSpPr>
+        <p:spPr>
+          <a:xfrm>
+            <a:off x="640080" y="2985516"/>
+            <a:ext cx="10911535" cy="731520"/>
+          </a:xfrm>
+          <a:prstGeom prst="rect">
+            <a:avLst/>
+          </a:prstGeom>
+          <a:noFill/>
+        </p:spPr>
+        <p:txBody>
+          <a:bodyPr wrap="square">
+            <a:spAutoFit/>
+          </a:bodyPr>
+          <a:lstStyle/>
+          <a:p>
+            <a:pPr algn="ctr"/>
+            <a:r>
+              <a:rPr sz="4800" b="1" i="0">
+                <a:solidFill>
+                  <a:srgbClr val="FFFFFF"/>
+                </a:solidFill>
+                <a:latin typeface="Arial"/>
+              </a:rPr>
+              <a:t>Bendiga o Senhor</a:t>
+            </a:r>
+          </a:p>
+        </p:txBody>
+      </p:sp>
+    </p:spTree>
+  </p:cSld>
+  <p:clrMapOvr>
+    <a:masterClrMapping/>
+  </p:clrMapOvr>
+</p:sld>
+</file>
+
+<file path=ppt/slides/slide26.xml><?xml version="1.0" encoding="utf-8"?>
+<p:sld xmlns:a="http://schemas.openxmlformats.org/drawingml/2006/main" xmlns:p="http://schemas.openxmlformats.org/presentationml/2006/main" xmlns:r="http://schemas.openxmlformats.org/officeDocument/2006/relationships">
+  <p:cSld>
+    <p:bg>
+      <p:bgPr>
+        <a:solidFill>
+          <a:srgbClr val="000000"/>
+        </a:solidFill>
+        <a:effectLst/>
+      </p:bgPr>
+    </p:bg>
+    <p:spTree>
+      <p:nvGrpSpPr>
+        <p:cNvPr id="1" name=""/>
+        <p:cNvGrpSpPr/>
+        <p:nvPr/>
+      </p:nvGrpSpPr>
+      <p:grpSpPr/>
+      <p:sp>
+        <p:nvSpPr>
+          <p:cNvPr id="2" name="TextBox 1"/>
+          <p:cNvSpPr txBox="1"/>
+          <p:nvPr/>
+        </p:nvSpPr>
+        <p:spPr>
+          <a:xfrm>
+            <a:off x="640080" y="2052828"/>
+            <a:ext cx="10911535" cy="731520"/>
+          </a:xfrm>
+          <a:prstGeom prst="rect">
+            <a:avLst/>
+          </a:prstGeom>
+          <a:noFill/>
+        </p:spPr>
+        <p:txBody>
+          <a:bodyPr wrap="square">
+            <a:spAutoFit/>
+          </a:bodyPr>
+          <a:lstStyle/>
+          <a:p>
+            <a:pPr algn="ctr"/>
+            <a:r>
+              <a:rPr sz="4800" b="1" i="0">
+                <a:solidFill>
+                  <a:srgbClr val="FFFFFF"/>
+                </a:solidFill>
+                <a:latin typeface="Arial"/>
+              </a:rPr>
+              <a:t>E no dia em que Sua força acabar</a:t>
+            </a:r>
+          </a:p>
+        </p:txBody>
+      </p:sp>
+      <p:sp>
+        <p:nvSpPr>
+          <p:cNvPr id="3" name="TextBox 2"/>
+          <p:cNvSpPr txBox="1"/>
+          <p:nvPr/>
+        </p:nvSpPr>
+        <p:spPr>
+          <a:xfrm>
+            <a:off x="640080" y="2985516"/>
+            <a:ext cx="10911535" cy="731520"/>
+          </a:xfrm>
+          <a:prstGeom prst="rect">
+            <a:avLst/>
+          </a:prstGeom>
+          <a:noFill/>
+        </p:spPr>
+        <p:txBody>
+          <a:bodyPr wrap="square">
+            <a:spAutoFit/>
+          </a:bodyPr>
+          <a:lstStyle/>
+          <a:p>
+            <a:pPr algn="ctr"/>
+            <a:r>
+              <a:rPr sz="4800" b="1" i="0">
+                <a:solidFill>
+                  <a:srgbClr val="FFFFFF"/>
+                </a:solidFill>
+                <a:latin typeface="Arial"/>
+              </a:rPr>
+              <a:t>Quando o fim vem</a:t>
             </a:r>
           </a:p>
         </p:txBody>
@@ -4489,29 +5793,29 @@
         </p:nvSpPr>
         <p:spPr>
           <a:xfrm>
-            <a:off x="594360" y="1837944"/>
-            <a:ext cx="11002975" cy="685800"/>
-          </a:xfrm>
-          <a:prstGeom prst="rect">
-            <a:avLst/>
-          </a:prstGeom>
-          <a:noFill/>
-        </p:spPr>
-        <p:txBody>
-          <a:bodyPr wrap="square">
-            <a:spAutoFit/>
-          </a:bodyPr>
-          <a:lstStyle/>
-          <a:p>
-            <a:pPr algn="ctr"/>
-            <a:r>
-              <a:rPr sz="4400" b="1" i="0">
+            <a:off x="640080" y="2052828"/>
+            <a:ext cx="10911535" cy="731520"/>
+          </a:xfrm>
+          <a:prstGeom prst="rect">
+            <a:avLst/>
+          </a:prstGeom>
+          <a:noFill/>
+        </p:spPr>
+        <p:txBody>
+          <a:bodyPr wrap="square">
+            <a:spAutoFit/>
+          </a:bodyPr>
+          <a:lstStyle/>
+          <a:p>
+            <a:pPr algn="ctr"/>
+            <a:r>
+              <a:rPr sz="4800" b="1" i="0">
                 <a:solidFill>
                   <a:srgbClr val="FFFFFF"/>
                 </a:solidFill>
                 <a:latin typeface="Arial"/>
               </a:rPr>
-              <a:t>朝も   昼も    夜も</a:t>
+              <a:t>Meu canto ainda assim será</a:t>
             </a:r>
           </a:p>
         </p:txBody>
@@ -4524,169 +5828,29 @@
         </p:nvSpPr>
         <p:spPr>
           <a:xfrm>
-            <a:off x="594360" y="2560320"/>
-            <a:ext cx="11002975" cy="384048"/>
-          </a:xfrm>
-          <a:prstGeom prst="rect">
-            <a:avLst/>
-          </a:prstGeom>
-          <a:noFill/>
-        </p:spPr>
-        <p:txBody>
-          <a:bodyPr wrap="square">
-            <a:spAutoFit/>
-          </a:bodyPr>
-          <a:lstStyle/>
-          <a:p>
-            <a:pPr algn="ctr"/>
-            <a:r>
-              <a:rPr sz="2400" b="0" i="1">
-                <a:solidFill>
-                  <a:srgbClr val="B4B4B4"/>
-                </a:solidFill>
-                <a:latin typeface="Arial"/>
-              </a:rPr>
-              <a:t>Asamo Hirumo Yorumo</a:t>
-            </a:r>
-          </a:p>
-        </p:txBody>
-      </p:sp>
-      <p:sp>
-        <p:nvSpPr>
-          <p:cNvPr id="4" name="TextBox 3"/>
-          <p:cNvSpPr txBox="1"/>
-          <p:nvPr/>
-        </p:nvSpPr>
-        <p:spPr>
-          <a:xfrm>
-            <a:off x="594360" y="2980944"/>
-            <a:ext cx="11002975" cy="347472"/>
-          </a:xfrm>
-          <a:prstGeom prst="rect">
-            <a:avLst/>
-          </a:prstGeom>
-          <a:noFill/>
-        </p:spPr>
-        <p:txBody>
-          <a:bodyPr wrap="square">
-            <a:spAutoFit/>
-          </a:bodyPr>
-          <a:lstStyle/>
-          <a:p>
-            <a:pPr algn="ctr"/>
-            <a:r>
-              <a:rPr sz="2000" b="0" i="1">
-                <a:solidFill>
-                  <a:srgbClr val="8C8C8C"/>
-                </a:solidFill>
-                <a:latin typeface="Arial"/>
-              </a:rPr>
-              <a:t/>
-            </a:r>
-          </a:p>
-        </p:txBody>
-      </p:sp>
-      <p:sp>
-        <p:nvSpPr>
-          <p:cNvPr id="5" name="TextBox 4"/>
-          <p:cNvSpPr txBox="1"/>
-          <p:nvPr/>
-        </p:nvSpPr>
-        <p:spPr>
-          <a:xfrm>
-            <a:off x="594360" y="3529584"/>
-            <a:ext cx="11002975" cy="685800"/>
-          </a:xfrm>
-          <a:prstGeom prst="rect">
-            <a:avLst/>
-          </a:prstGeom>
-          <a:noFill/>
-        </p:spPr>
-        <p:txBody>
-          <a:bodyPr wrap="square">
-            <a:spAutoFit/>
-          </a:bodyPr>
-          <a:lstStyle/>
-          <a:p>
-            <a:pPr algn="ctr"/>
-            <a:r>
-              <a:rPr sz="4400" b="1" i="0">
+            <a:off x="640080" y="2985516"/>
+            <a:ext cx="10911535" cy="731520"/>
+          </a:xfrm>
+          <a:prstGeom prst="rect">
+            <a:avLst/>
+          </a:prstGeom>
+          <a:noFill/>
+        </p:spPr>
+        <p:txBody>
+          <a:bodyPr wrap="square">
+            <a:spAutoFit/>
+          </a:bodyPr>
+          <a:lstStyle/>
+          <a:p>
+            <a:pPr algn="ctr"/>
+            <a:r>
+              <a:rPr sz="4800" b="1" i="0">
                 <a:solidFill>
                   <a:srgbClr val="FFFFFF"/>
                 </a:solidFill>
                 <a:latin typeface="Arial"/>
               </a:rPr>
-              <a:t>変わらずに   歌う</a:t>
-            </a:r>
-          </a:p>
-        </p:txBody>
-      </p:sp>
-      <p:sp>
-        <p:nvSpPr>
-          <p:cNvPr id="6" name="TextBox 5"/>
-          <p:cNvSpPr txBox="1"/>
-          <p:nvPr/>
-        </p:nvSpPr>
-        <p:spPr>
-          <a:xfrm>
-            <a:off x="594360" y="4251960"/>
-            <a:ext cx="11002975" cy="384048"/>
-          </a:xfrm>
-          <a:prstGeom prst="rect">
-            <a:avLst/>
-          </a:prstGeom>
-          <a:noFill/>
-        </p:spPr>
-        <p:txBody>
-          <a:bodyPr wrap="square">
-            <a:spAutoFit/>
-          </a:bodyPr>
-          <a:lstStyle/>
-          <a:p>
-            <a:pPr algn="ctr"/>
-            <a:r>
-              <a:rPr sz="2400" b="0" i="1">
-                <a:solidFill>
-                  <a:srgbClr val="B4B4B4"/>
-                </a:solidFill>
-                <a:latin typeface="Arial"/>
-              </a:rPr>
-              <a:t>Kawarazuni Utau</a:t>
-            </a:r>
-          </a:p>
-        </p:txBody>
-      </p:sp>
-      <p:sp>
-        <p:nvSpPr>
-          <p:cNvPr id="7" name="TextBox 6"/>
-          <p:cNvSpPr txBox="1"/>
-          <p:nvPr/>
-        </p:nvSpPr>
-        <p:spPr>
-          <a:xfrm>
-            <a:off x="594360" y="4672584"/>
-            <a:ext cx="11002975" cy="347472"/>
-          </a:xfrm>
-          <a:prstGeom prst="rect">
-            <a:avLst/>
-          </a:prstGeom>
-          <a:noFill/>
-        </p:spPr>
-        <p:txBody>
-          <a:bodyPr wrap="square">
-            <a:spAutoFit/>
-          </a:bodyPr>
-          <a:lstStyle/>
-          <a:p>
-            <a:pPr algn="ctr"/>
-            <a:r>
-              <a:rPr sz="2000" b="0" i="1">
-                <a:solidFill>
-                  <a:srgbClr val="8C8C8C"/>
-                </a:solidFill>
-                <a:latin typeface="Arial"/>
-              </a:rPr>
-              <a:t/>
+              <a:t>Bendiga o Senhor, ó minha alma</a:t>
             </a:r>
           </a:p>
         </p:txBody>
@@ -4725,29 +5889,29 @@
         </p:nvSpPr>
         <p:spPr>
           <a:xfrm>
-            <a:off x="594360" y="1837944"/>
-            <a:ext cx="11002975" cy="685800"/>
-          </a:xfrm>
-          <a:prstGeom prst="rect">
-            <a:avLst/>
-          </a:prstGeom>
-          <a:noFill/>
-        </p:spPr>
-        <p:txBody>
-          <a:bodyPr wrap="square">
-            <a:spAutoFit/>
-          </a:bodyPr>
-          <a:lstStyle/>
-          <a:p>
-            <a:pPr algn="ctr"/>
-            <a:r>
-              <a:rPr sz="4400" b="1" i="0">
+            <a:off x="640080" y="2052828"/>
+            <a:ext cx="10911535" cy="731520"/>
+          </a:xfrm>
+          <a:prstGeom prst="rect">
+            <a:avLst/>
+          </a:prstGeom>
+          <a:noFill/>
+        </p:spPr>
+        <p:txBody>
+          <a:bodyPr wrap="square">
+            <a:spAutoFit/>
+          </a:bodyPr>
+          <a:lstStyle/>
+          <a:p>
+            <a:pPr algn="ctr"/>
+            <a:r>
+              <a:rPr sz="4800" b="1" i="0">
                 <a:solidFill>
                   <a:srgbClr val="FFFFFF"/>
                 </a:solidFill>
                 <a:latin typeface="Arial"/>
               </a:rPr>
-              <a:t>苦難  にも  揺るがない あなたの愛</a:t>
+              <a:t>Ó minha alma</a:t>
             </a:r>
           </a:p>
         </p:txBody>
@@ -4760,169 +5924,29 @@
         </p:nvSpPr>
         <p:spPr>
           <a:xfrm>
-            <a:off x="594360" y="2560320"/>
-            <a:ext cx="11002975" cy="384048"/>
-          </a:xfrm>
-          <a:prstGeom prst="rect">
-            <a:avLst/>
-          </a:prstGeom>
-          <a:noFill/>
-        </p:spPr>
-        <p:txBody>
-          <a:bodyPr wrap="square">
-            <a:spAutoFit/>
-          </a:bodyPr>
-          <a:lstStyle/>
-          <a:p>
-            <a:pPr algn="ctr"/>
-            <a:r>
-              <a:rPr sz="2400" b="0" i="1">
-                <a:solidFill>
-                  <a:srgbClr val="B4B4B4"/>
-                </a:solidFill>
-                <a:latin typeface="Arial"/>
-              </a:rPr>
-              <a:t>Kunan ni mo Yuruganai Anata no Ai</a:t>
-            </a:r>
-          </a:p>
-        </p:txBody>
-      </p:sp>
-      <p:sp>
-        <p:nvSpPr>
-          <p:cNvPr id="4" name="TextBox 3"/>
-          <p:cNvSpPr txBox="1"/>
-          <p:nvPr/>
-        </p:nvSpPr>
-        <p:spPr>
-          <a:xfrm>
-            <a:off x="594360" y="2980944"/>
-            <a:ext cx="11002975" cy="347472"/>
-          </a:xfrm>
-          <a:prstGeom prst="rect">
-            <a:avLst/>
-          </a:prstGeom>
-          <a:noFill/>
-        </p:spPr>
-        <p:txBody>
-          <a:bodyPr wrap="square">
-            <a:spAutoFit/>
-          </a:bodyPr>
-          <a:lstStyle/>
-          <a:p>
-            <a:pPr algn="ctr"/>
-            <a:r>
-              <a:rPr sz="2000" b="0" i="1">
-                <a:solidFill>
-                  <a:srgbClr val="8C8C8C"/>
-                </a:solidFill>
-                <a:latin typeface="Arial"/>
-              </a:rPr>
-              <a:t/>
-            </a:r>
-          </a:p>
-        </p:txBody>
-      </p:sp>
-      <p:sp>
-        <p:nvSpPr>
-          <p:cNvPr id="5" name="TextBox 4"/>
-          <p:cNvSpPr txBox="1"/>
-          <p:nvPr/>
-        </p:nvSpPr>
-        <p:spPr>
-          <a:xfrm>
-            <a:off x="594360" y="3529584"/>
-            <a:ext cx="11002975" cy="685800"/>
-          </a:xfrm>
-          <a:prstGeom prst="rect">
-            <a:avLst/>
-          </a:prstGeom>
-          <a:noFill/>
-        </p:spPr>
-        <p:txBody>
-          <a:bodyPr wrap="square">
-            <a:spAutoFit/>
-          </a:bodyPr>
-          <a:lstStyle/>
-          <a:p>
-            <a:pPr algn="ctr"/>
-            <a:r>
-              <a:rPr sz="4400" b="1" i="0">
+            <a:off x="640080" y="2985516"/>
+            <a:ext cx="10911535" cy="731520"/>
+          </a:xfrm>
+          <a:prstGeom prst="rect">
+            <a:avLst/>
+          </a:prstGeom>
+          <a:noFill/>
+        </p:spPr>
+        <p:txBody>
+          <a:bodyPr wrap="square">
+            <a:spAutoFit/>
+          </a:bodyPr>
+          <a:lstStyle/>
+          <a:p>
+            <a:pPr algn="ctr"/>
+            <a:r>
+              <a:rPr sz="4800" b="1" i="0">
                 <a:solidFill>
                   <a:srgbClr val="FFFFFF"/>
                 </a:solidFill>
                 <a:latin typeface="Arial"/>
               </a:rPr>
-              <a:t>勝てるもの   他に  ない</a:t>
-            </a:r>
-          </a:p>
-        </p:txBody>
-      </p:sp>
-      <p:sp>
-        <p:nvSpPr>
-          <p:cNvPr id="6" name="TextBox 5"/>
-          <p:cNvSpPr txBox="1"/>
-          <p:nvPr/>
-        </p:nvSpPr>
-        <p:spPr>
-          <a:xfrm>
-            <a:off x="594360" y="4251960"/>
-            <a:ext cx="11002975" cy="384048"/>
-          </a:xfrm>
-          <a:prstGeom prst="rect">
-            <a:avLst/>
-          </a:prstGeom>
-          <a:noFill/>
-        </p:spPr>
-        <p:txBody>
-          <a:bodyPr wrap="square">
-            <a:spAutoFit/>
-          </a:bodyPr>
-          <a:lstStyle/>
-          <a:p>
-            <a:pPr algn="ctr"/>
-            <a:r>
-              <a:rPr sz="2400" b="0" i="1">
-                <a:solidFill>
-                  <a:srgbClr val="B4B4B4"/>
-                </a:solidFill>
-                <a:latin typeface="Arial"/>
-              </a:rPr>
-              <a:t>Katerumono Hokani nai</a:t>
-            </a:r>
-          </a:p>
-        </p:txBody>
-      </p:sp>
-      <p:sp>
-        <p:nvSpPr>
-          <p:cNvPr id="7" name="TextBox 6"/>
-          <p:cNvSpPr txBox="1"/>
-          <p:nvPr/>
-        </p:nvSpPr>
-        <p:spPr>
-          <a:xfrm>
-            <a:off x="594360" y="4672584"/>
-            <a:ext cx="11002975" cy="347472"/>
-          </a:xfrm>
-          <a:prstGeom prst="rect">
-            <a:avLst/>
-          </a:prstGeom>
-          <a:noFill/>
-        </p:spPr>
-        <p:txBody>
-          <a:bodyPr wrap="square">
-            <a:spAutoFit/>
-          </a:bodyPr>
-          <a:lstStyle/>
-          <a:p>
-            <a:pPr algn="ctr"/>
-            <a:r>
-              <a:rPr sz="2000" b="0" i="1">
-                <a:solidFill>
-                  <a:srgbClr val="8C8C8C"/>
-                </a:solidFill>
-                <a:latin typeface="Arial"/>
-              </a:rPr>
-              <a:t/>
+              <a:t>Adore Seu santo nome</a:t>
             </a:r>
           </a:p>
         </p:txBody>
@@ -4961,29 +5985,29 @@
         </p:nvSpPr>
         <p:spPr>
           <a:xfrm>
-            <a:off x="594360" y="1837944"/>
-            <a:ext cx="11002975" cy="685800"/>
-          </a:xfrm>
-          <a:prstGeom prst="rect">
-            <a:avLst/>
-          </a:prstGeom>
-          <a:noFill/>
-        </p:spPr>
-        <p:txBody>
-          <a:bodyPr wrap="square">
-            <a:spAutoFit/>
-          </a:bodyPr>
-          <a:lstStyle/>
-          <a:p>
-            <a:pPr algn="ctr"/>
-            <a:r>
-              <a:rPr sz="4400" b="1" i="0">
+            <a:off x="640080" y="2052828"/>
+            <a:ext cx="10911535" cy="731520"/>
+          </a:xfrm>
+          <a:prstGeom prst="rect">
+            <a:avLst/>
+          </a:prstGeom>
+          <a:noFill/>
+        </p:spPr>
+        <p:txBody>
+          <a:bodyPr wrap="square">
+            <a:spAutoFit/>
+          </a:bodyPr>
+          <a:lstStyle/>
+          <a:p>
+            <a:pPr algn="ctr"/>
+            <a:r>
+              <a:rPr sz="3800" b="1" i="0">
                 <a:solidFill>
                   <a:srgbClr val="FFFFFF"/>
                 </a:solidFill>
                 <a:latin typeface="Arial"/>
               </a:rPr>
-              <a:t>たましいよ   ほめ歌え   聖なる   主に</a:t>
+              <a:t>Dez mil razões pro meu coração encontrar</a:t>
             </a:r>
           </a:p>
         </p:txBody>
@@ -4996,169 +6020,29 @@
         </p:nvSpPr>
         <p:spPr>
           <a:xfrm>
-            <a:off x="594360" y="2560320"/>
-            <a:ext cx="11002975" cy="384048"/>
-          </a:xfrm>
-          <a:prstGeom prst="rect">
-            <a:avLst/>
-          </a:prstGeom>
-          <a:noFill/>
-        </p:spPr>
-        <p:txBody>
-          <a:bodyPr wrap="square">
-            <a:spAutoFit/>
-          </a:bodyPr>
-          <a:lstStyle/>
-          <a:p>
-            <a:pPr algn="ctr"/>
-            <a:r>
-              <a:rPr sz="2400" b="0" i="1">
-                <a:solidFill>
-                  <a:srgbClr val="B4B4B4"/>
-                </a:solidFill>
-                <a:latin typeface="Arial"/>
-              </a:rPr>
-              <a:t>Tamashiiyo Homeutae Seinaru Shuni</a:t>
-            </a:r>
-          </a:p>
-        </p:txBody>
-      </p:sp>
-      <p:sp>
-        <p:nvSpPr>
-          <p:cNvPr id="4" name="TextBox 3"/>
-          <p:cNvSpPr txBox="1"/>
-          <p:nvPr/>
-        </p:nvSpPr>
-        <p:spPr>
-          <a:xfrm>
-            <a:off x="594360" y="2980944"/>
-            <a:ext cx="11002975" cy="347472"/>
-          </a:xfrm>
-          <a:prstGeom prst="rect">
-            <a:avLst/>
-          </a:prstGeom>
-          <a:noFill/>
-        </p:spPr>
-        <p:txBody>
-          <a:bodyPr wrap="square">
-            <a:spAutoFit/>
-          </a:bodyPr>
-          <a:lstStyle/>
-          <a:p>
-            <a:pPr algn="ctr"/>
-            <a:r>
-              <a:rPr sz="2000" b="0" i="1">
-                <a:solidFill>
-                  <a:srgbClr val="8C8C8C"/>
-                </a:solidFill>
-                <a:latin typeface="Arial"/>
-              </a:rPr>
-              <a:t/>
-            </a:r>
-          </a:p>
-        </p:txBody>
-      </p:sp>
-      <p:sp>
-        <p:nvSpPr>
-          <p:cNvPr id="5" name="TextBox 4"/>
-          <p:cNvSpPr txBox="1"/>
-          <p:nvPr/>
-        </p:nvSpPr>
-        <p:spPr>
-          <a:xfrm>
-            <a:off x="594360" y="3529584"/>
-            <a:ext cx="11002975" cy="685800"/>
-          </a:xfrm>
-          <a:prstGeom prst="rect">
-            <a:avLst/>
-          </a:prstGeom>
-          <a:noFill/>
-        </p:spPr>
-        <p:txBody>
-          <a:bodyPr wrap="square">
-            <a:spAutoFit/>
-          </a:bodyPr>
-          <a:lstStyle/>
-          <a:p>
-            <a:pPr algn="ctr"/>
-            <a:r>
-              <a:rPr sz="4400" b="1" i="0">
+            <a:off x="640080" y="2985516"/>
+            <a:ext cx="10911535" cy="731520"/>
+          </a:xfrm>
+          <a:prstGeom prst="rect">
+            <a:avLst/>
+          </a:prstGeom>
+          <a:noFill/>
+        </p:spPr>
+        <p:txBody>
+          <a:bodyPr wrap="square">
+            <a:spAutoFit/>
+          </a:bodyPr>
+          <a:lstStyle/>
+          <a:p>
+            <a:pPr algn="ctr"/>
+            <a:r>
+              <a:rPr sz="4800" b="1" i="0">
                 <a:solidFill>
                   <a:srgbClr val="FFFFFF"/>
                 </a:solidFill>
                 <a:latin typeface="Arial"/>
               </a:rPr>
-              <a:t>こころ   捧げ  うたえ 素晴らしい  主に</a:t>
-            </a:r>
-          </a:p>
-        </p:txBody>
-      </p:sp>
-      <p:sp>
-        <p:nvSpPr>
-          <p:cNvPr id="6" name="TextBox 5"/>
-          <p:cNvSpPr txBox="1"/>
-          <p:nvPr/>
-        </p:nvSpPr>
-        <p:spPr>
-          <a:xfrm>
-            <a:off x="594360" y="4251960"/>
-            <a:ext cx="11002975" cy="384048"/>
-          </a:xfrm>
-          <a:prstGeom prst="rect">
-            <a:avLst/>
-          </a:prstGeom>
-          <a:noFill/>
-        </p:spPr>
-        <p:txBody>
-          <a:bodyPr wrap="square">
-            <a:spAutoFit/>
-          </a:bodyPr>
-          <a:lstStyle/>
-          <a:p>
-            <a:pPr algn="ctr"/>
-            <a:r>
-              <a:rPr sz="2400" b="0" i="1">
-                <a:solidFill>
-                  <a:srgbClr val="B4B4B4"/>
-                </a:solidFill>
-                <a:latin typeface="Arial"/>
-              </a:rPr>
-              <a:t>Kokoro Sasage Utae Subarashii Shuni</a:t>
-            </a:r>
-          </a:p>
-        </p:txBody>
-      </p:sp>
-      <p:sp>
-        <p:nvSpPr>
-          <p:cNvPr id="7" name="TextBox 6"/>
-          <p:cNvSpPr txBox="1"/>
-          <p:nvPr/>
-        </p:nvSpPr>
-        <p:spPr>
-          <a:xfrm>
-            <a:off x="594360" y="4672584"/>
-            <a:ext cx="11002975" cy="347472"/>
-          </a:xfrm>
-          <a:prstGeom prst="rect">
-            <a:avLst/>
-          </a:prstGeom>
-          <a:noFill/>
-        </p:spPr>
-        <p:txBody>
-          <a:bodyPr wrap="square">
-            <a:spAutoFit/>
-          </a:bodyPr>
-          <a:lstStyle/>
-          <a:p>
-            <a:pPr algn="ctr"/>
-            <a:r>
-              <a:rPr sz="2000" b="0" i="1">
-                <a:solidFill>
-                  <a:srgbClr val="8C8C8C"/>
-                </a:solidFill>
-                <a:latin typeface="Arial"/>
-              </a:rPr>
-              <a:t/>
+              <a:t>Bendiga o Senhor</a:t>
             </a:r>
           </a:p>
         </p:txBody>
@@ -5197,29 +6081,29 @@
         </p:nvSpPr>
         <p:spPr>
           <a:xfrm>
-            <a:off x="594360" y="2258568"/>
-            <a:ext cx="11002975" cy="685800"/>
-          </a:xfrm>
-          <a:prstGeom prst="rect">
-            <a:avLst/>
-          </a:prstGeom>
-          <a:noFill/>
-        </p:spPr>
-        <p:txBody>
-          <a:bodyPr wrap="square">
-            <a:spAutoFit/>
-          </a:bodyPr>
-          <a:lstStyle/>
-          <a:p>
-            <a:pPr algn="ctr"/>
-            <a:r>
-              <a:rPr sz="4400" b="1" i="0">
+            <a:off x="640080" y="2052828"/>
+            <a:ext cx="10911535" cy="731520"/>
+          </a:xfrm>
+          <a:prstGeom prst="rect">
+            <a:avLst/>
+          </a:prstGeom>
+          <a:noFill/>
+        </p:spPr>
+        <p:txBody>
+          <a:bodyPr wrap="square">
+            <a:spAutoFit/>
+          </a:bodyPr>
+          <a:lstStyle/>
+          <a:p>
+            <a:pPr algn="ctr"/>
+            <a:r>
+              <a:rPr sz="4800" b="1" i="0">
                 <a:solidFill>
                   <a:srgbClr val="FFFFFF"/>
                 </a:solidFill>
                 <a:latin typeface="Arial"/>
               </a:rPr>
-              <a:t>Bendiga o Senhor</a:t>
+              <a:t>E no dia em que Sua força acabar</a:t>
             </a:r>
           </a:p>
         </p:txBody>
@@ -5232,99 +6116,29 @@
         </p:nvSpPr>
         <p:spPr>
           <a:xfrm>
-            <a:off x="594360" y="2980944"/>
-            <a:ext cx="11002975" cy="347472"/>
-          </a:xfrm>
-          <a:prstGeom prst="rect">
-            <a:avLst/>
-          </a:prstGeom>
-          <a:noFill/>
-        </p:spPr>
-        <p:txBody>
-          <a:bodyPr wrap="square">
-            <a:spAutoFit/>
-          </a:bodyPr>
-          <a:lstStyle/>
-          <a:p>
-            <a:pPr algn="ctr"/>
-            <a:r>
-              <a:rPr sz="2200" b="0" i="1">
-                <a:solidFill>
-                  <a:srgbClr val="8C8C8C"/>
-                </a:solidFill>
-                <a:latin typeface="Arial"/>
-              </a:rPr>
-              <a:t/>
-            </a:r>
-          </a:p>
-        </p:txBody>
-      </p:sp>
-      <p:sp>
-        <p:nvSpPr>
-          <p:cNvPr id="4" name="TextBox 3"/>
-          <p:cNvSpPr txBox="1"/>
-          <p:nvPr/>
-        </p:nvSpPr>
-        <p:spPr>
-          <a:xfrm>
-            <a:off x="594360" y="3529584"/>
-            <a:ext cx="11002975" cy="685800"/>
-          </a:xfrm>
-          <a:prstGeom prst="rect">
-            <a:avLst/>
-          </a:prstGeom>
-          <a:noFill/>
-        </p:spPr>
-        <p:txBody>
-          <a:bodyPr wrap="square">
-            <a:spAutoFit/>
-          </a:bodyPr>
-          <a:lstStyle/>
-          <a:p>
-            <a:pPr algn="ctr"/>
-            <a:r>
-              <a:rPr sz="3200" b="1" i="0">
+            <a:off x="640080" y="2985516"/>
+            <a:ext cx="10911535" cy="731520"/>
+          </a:xfrm>
+          <a:prstGeom prst="rect">
+            <a:avLst/>
+          </a:prstGeom>
+          <a:noFill/>
+        </p:spPr>
+        <p:txBody>
+          <a:bodyPr wrap="square">
+            <a:spAutoFit/>
+          </a:bodyPr>
+          <a:lstStyle/>
+          <a:p>
+            <a:pPr algn="ctr"/>
+            <a:r>
+              <a:rPr sz="4800" b="1" i="0">
                 <a:solidFill>
                   <a:srgbClr val="FFFFFF"/>
                 </a:solidFill>
                 <a:latin typeface="Arial"/>
               </a:rPr>
-              <a:t>O sol está se pondo e a madrugada vai cantar</a:t>
-            </a:r>
-          </a:p>
-        </p:txBody>
-      </p:sp>
-      <p:sp>
-        <p:nvSpPr>
-          <p:cNvPr id="5" name="TextBox 4"/>
-          <p:cNvSpPr txBox="1"/>
-          <p:nvPr/>
-        </p:nvSpPr>
-        <p:spPr>
-          <a:xfrm>
-            <a:off x="594360" y="4251960"/>
-            <a:ext cx="11002975" cy="347472"/>
-          </a:xfrm>
-          <a:prstGeom prst="rect">
-            <a:avLst/>
-          </a:prstGeom>
-          <a:noFill/>
-        </p:spPr>
-        <p:txBody>
-          <a:bodyPr wrap="square">
-            <a:spAutoFit/>
-          </a:bodyPr>
-          <a:lstStyle/>
-          <a:p>
-            <a:pPr algn="ctr"/>
-            <a:r>
-              <a:rPr sz="2200" b="0" i="1">
-                <a:solidFill>
-                  <a:srgbClr val="8C8C8C"/>
-                </a:solidFill>
-                <a:latin typeface="Arial"/>
-              </a:rPr>
-              <a:t/>
+              <a:t>Quando o fim vem</a:t>
             </a:r>
           </a:p>
         </p:txBody>
@@ -5363,29 +6177,29 @@
         </p:nvSpPr>
         <p:spPr>
           <a:xfrm>
-            <a:off x="594360" y="2258568"/>
-            <a:ext cx="11002975" cy="685800"/>
-          </a:xfrm>
-          <a:prstGeom prst="rect">
-            <a:avLst/>
-          </a:prstGeom>
-          <a:noFill/>
-        </p:spPr>
-        <p:txBody>
-          <a:bodyPr wrap="square">
-            <a:spAutoFit/>
-          </a:bodyPr>
-          <a:lstStyle/>
-          <a:p>
-            <a:pPr algn="ctr"/>
-            <a:r>
-              <a:rPr sz="3705" b="1" i="0">
+            <a:off x="640080" y="1650492"/>
+            <a:ext cx="10911535" cy="731520"/>
+          </a:xfrm>
+          <a:prstGeom prst="rect">
+            <a:avLst/>
+          </a:prstGeom>
+          <a:noFill/>
+        </p:spPr>
+        <p:txBody>
+          <a:bodyPr wrap="square">
+            <a:spAutoFit/>
+          </a:bodyPr>
+          <a:lstStyle/>
+          <a:p>
+            <a:pPr algn="ctr"/>
+            <a:r>
+              <a:rPr sz="4800" b="1" i="0">
                 <a:solidFill>
                   <a:srgbClr val="FFFFFF"/>
                 </a:solidFill>
                 <a:latin typeface="Arial"/>
               </a:rPr>
-              <a:t>Quão bom é Ele, quão grande é Seu amor</a:t>
+              <a:t>朝も   昼も    夜も</a:t>
             </a:r>
           </a:p>
         </p:txBody>
@@ -5398,29 +6212,29 @@
         </p:nvSpPr>
         <p:spPr>
           <a:xfrm>
-            <a:off x="594360" y="2980944"/>
-            <a:ext cx="11002975" cy="347472"/>
-          </a:xfrm>
-          <a:prstGeom prst="rect">
-            <a:avLst/>
-          </a:prstGeom>
-          <a:noFill/>
-        </p:spPr>
-        <p:txBody>
-          <a:bodyPr wrap="square">
-            <a:spAutoFit/>
-          </a:bodyPr>
-          <a:lstStyle/>
-          <a:p>
-            <a:pPr algn="ctr"/>
-            <a:r>
-              <a:rPr sz="2200" b="0" i="1">
-                <a:solidFill>
-                  <a:srgbClr val="8C8C8C"/>
-                </a:solidFill>
-                <a:latin typeface="Arial"/>
-              </a:rPr>
-              <a:t/>
+            <a:off x="640080" y="2418588"/>
+            <a:ext cx="10911535" cy="365760"/>
+          </a:xfrm>
+          <a:prstGeom prst="rect">
+            <a:avLst/>
+          </a:prstGeom>
+          <a:noFill/>
+        </p:spPr>
+        <p:txBody>
+          <a:bodyPr wrap="square">
+            <a:spAutoFit/>
+          </a:bodyPr>
+          <a:lstStyle/>
+          <a:p>
+            <a:pPr algn="ctr"/>
+            <a:r>
+              <a:rPr sz="2400" b="0" i="1">
+                <a:solidFill>
+                  <a:srgbClr val="AAAAAA"/>
+                </a:solidFill>
+                <a:latin typeface="Arial"/>
+              </a:rPr>
+              <a:t>Asamo Hirumo Yorumo</a:t>
             </a:r>
           </a:p>
         </p:txBody>
@@ -5433,29 +6247,29 @@
         </p:nvSpPr>
         <p:spPr>
           <a:xfrm>
-            <a:off x="594360" y="3529584"/>
-            <a:ext cx="11002975" cy="685800"/>
-          </a:xfrm>
-          <a:prstGeom prst="rect">
-            <a:avLst/>
-          </a:prstGeom>
-          <a:noFill/>
-        </p:spPr>
-        <p:txBody>
-          <a:bodyPr wrap="square">
-            <a:spAutoFit/>
-          </a:bodyPr>
-          <a:lstStyle/>
-          <a:p>
-            <a:pPr algn="ctr"/>
-            <a:r>
-              <a:rPr sz="3610" b="1" i="0">
+            <a:off x="640080" y="2985516"/>
+            <a:ext cx="10911535" cy="731520"/>
+          </a:xfrm>
+          <a:prstGeom prst="rect">
+            <a:avLst/>
+          </a:prstGeom>
+          <a:noFill/>
+        </p:spPr>
+        <p:txBody>
+          <a:bodyPr wrap="square">
+            <a:spAutoFit/>
+          </a:bodyPr>
+          <a:lstStyle/>
+          <a:p>
+            <a:pPr algn="ctr"/>
+            <a:r>
+              <a:rPr sz="4800" b="1" i="0">
                 <a:solidFill>
                   <a:srgbClr val="FFFFFF"/>
                 </a:solidFill>
                 <a:latin typeface="Arial"/>
               </a:rPr>
-              <a:t>Quaisquer que sejam as perdas de amanhã</a:t>
+              <a:t>変わらずに   歌う</a:t>
             </a:r>
           </a:p>
         </p:txBody>
@@ -5468,29 +6282,99 @@
         </p:nvSpPr>
         <p:spPr>
           <a:xfrm>
-            <a:off x="594360" y="4251960"/>
-            <a:ext cx="11002975" cy="347472"/>
-          </a:xfrm>
-          <a:prstGeom prst="rect">
-            <a:avLst/>
-          </a:prstGeom>
-          <a:noFill/>
-        </p:spPr>
-        <p:txBody>
-          <a:bodyPr wrap="square">
-            <a:spAutoFit/>
-          </a:bodyPr>
-          <a:lstStyle/>
-          <a:p>
-            <a:pPr algn="ctr"/>
-            <a:r>
-              <a:rPr sz="2200" b="0" i="1">
-                <a:solidFill>
-                  <a:srgbClr val="8C8C8C"/>
-                </a:solidFill>
-                <a:latin typeface="Arial"/>
-              </a:rPr>
-              <a:t/>
+            <a:off x="640080" y="3753612"/>
+            <a:ext cx="10911535" cy="365760"/>
+          </a:xfrm>
+          <a:prstGeom prst="rect">
+            <a:avLst/>
+          </a:prstGeom>
+          <a:noFill/>
+        </p:spPr>
+        <p:txBody>
+          <a:bodyPr wrap="square">
+            <a:spAutoFit/>
+          </a:bodyPr>
+          <a:lstStyle/>
+          <a:p>
+            <a:pPr algn="ctr"/>
+            <a:r>
+              <a:rPr sz="2400" b="0" i="1">
+                <a:solidFill>
+                  <a:srgbClr val="AAAAAA"/>
+                </a:solidFill>
+                <a:latin typeface="Arial"/>
+              </a:rPr>
+              <a:t>Kawarazuni Utau</a:t>
+            </a:r>
+          </a:p>
+        </p:txBody>
+      </p:sp>
+      <p:sp>
+        <p:nvSpPr>
+          <p:cNvPr id="6" name="TextBox 5"/>
+          <p:cNvSpPr txBox="1"/>
+          <p:nvPr/>
+        </p:nvSpPr>
+        <p:spPr>
+          <a:xfrm>
+            <a:off x="640080" y="4530852"/>
+            <a:ext cx="10911535" cy="310896"/>
+          </a:xfrm>
+          <a:prstGeom prst="rect">
+            <a:avLst/>
+          </a:prstGeom>
+          <a:noFill/>
+        </p:spPr>
+        <p:txBody>
+          <a:bodyPr wrap="square">
+            <a:spAutoFit/>
+          </a:bodyPr>
+          <a:lstStyle/>
+          <a:p>
+            <a:pPr algn="ctr"/>
+            <a:r>
+              <a:rPr sz="2000" b="0" i="1">
+                <a:solidFill>
+                  <a:srgbClr val="828282"/>
+                </a:solidFill>
+                <a:latin typeface="Arial"/>
+              </a:rPr>
+              <a:t>Bendiga o Senhor</a:t>
+            </a:r>
+          </a:p>
+        </p:txBody>
+      </p:sp>
+      <p:sp>
+        <p:nvSpPr>
+          <p:cNvPr id="7" name="TextBox 6"/>
+          <p:cNvSpPr txBox="1"/>
+          <p:nvPr/>
+        </p:nvSpPr>
+        <p:spPr>
+          <a:xfrm>
+            <a:off x="640080" y="4896612"/>
+            <a:ext cx="10911535" cy="310896"/>
+          </a:xfrm>
+          <a:prstGeom prst="rect">
+            <a:avLst/>
+          </a:prstGeom>
+          <a:noFill/>
+        </p:spPr>
+        <p:txBody>
+          <a:bodyPr wrap="square">
+            <a:spAutoFit/>
+          </a:bodyPr>
+          <a:lstStyle/>
+          <a:p>
+            <a:pPr algn="ctr"/>
+            <a:r>
+              <a:rPr sz="2000" b="0" i="1">
+                <a:solidFill>
+                  <a:srgbClr val="828282"/>
+                </a:solidFill>
+                <a:latin typeface="Arial"/>
+              </a:rPr>
+              <a:t>O sol está se pondo e a madrugada vai cantar</a:t>
             </a:r>
           </a:p>
         </p:txBody>
@@ -5529,29 +6413,29 @@
         </p:nvSpPr>
         <p:spPr>
           <a:xfrm>
-            <a:off x="594360" y="2258568"/>
-            <a:ext cx="11002975" cy="685800"/>
-          </a:xfrm>
-          <a:prstGeom prst="rect">
-            <a:avLst/>
-          </a:prstGeom>
-          <a:noFill/>
-        </p:spPr>
-        <p:txBody>
-          <a:bodyPr wrap="square">
-            <a:spAutoFit/>
-          </a:bodyPr>
-          <a:lstStyle/>
-          <a:p>
-            <a:pPr algn="ctr"/>
-            <a:r>
-              <a:rPr sz="4400" b="1" i="0">
+            <a:off x="640080" y="1650492"/>
+            <a:ext cx="10911535" cy="731520"/>
+          </a:xfrm>
+          <a:prstGeom prst="rect">
+            <a:avLst/>
+          </a:prstGeom>
+          <a:noFill/>
+        </p:spPr>
+        <p:txBody>
+          <a:bodyPr wrap="square">
+            <a:spAutoFit/>
+          </a:bodyPr>
+          <a:lstStyle/>
+          <a:p>
+            <a:pPr algn="ctr"/>
+            <a:r>
+              <a:rPr sz="4800" b="1" i="0">
                 <a:solidFill>
                   <a:srgbClr val="FFFFFF"/>
                 </a:solidFill>
                 <a:latin typeface="Arial"/>
               </a:rPr>
-              <a:t>Meu canto ainda assim será</a:t>
+              <a:t>苦難  にも  揺るがない あなたの愛</a:t>
             </a:r>
           </a:p>
         </p:txBody>
@@ -5564,29 +6448,29 @@
         </p:nvSpPr>
         <p:spPr>
           <a:xfrm>
-            <a:off x="594360" y="2980944"/>
-            <a:ext cx="11002975" cy="347472"/>
-          </a:xfrm>
-          <a:prstGeom prst="rect">
-            <a:avLst/>
-          </a:prstGeom>
-          <a:noFill/>
-        </p:spPr>
-        <p:txBody>
-          <a:bodyPr wrap="square">
-            <a:spAutoFit/>
-          </a:bodyPr>
-          <a:lstStyle/>
-          <a:p>
-            <a:pPr algn="ctr"/>
-            <a:r>
-              <a:rPr sz="2200" b="0" i="1">
-                <a:solidFill>
-                  <a:srgbClr val="8C8C8C"/>
-                </a:solidFill>
-                <a:latin typeface="Arial"/>
-              </a:rPr>
-              <a:t/>
+            <a:off x="640080" y="2418588"/>
+            <a:ext cx="10911535" cy="365760"/>
+          </a:xfrm>
+          <a:prstGeom prst="rect">
+            <a:avLst/>
+          </a:prstGeom>
+          <a:noFill/>
+        </p:spPr>
+        <p:txBody>
+          <a:bodyPr wrap="square">
+            <a:spAutoFit/>
+          </a:bodyPr>
+          <a:lstStyle/>
+          <a:p>
+            <a:pPr algn="ctr"/>
+            <a:r>
+              <a:rPr sz="2400" b="0" i="1">
+                <a:solidFill>
+                  <a:srgbClr val="AAAAAA"/>
+                </a:solidFill>
+                <a:latin typeface="Arial"/>
+              </a:rPr>
+              <a:t>Kunan ni mo Yuruganai Anata no Ai</a:t>
             </a:r>
           </a:p>
         </p:txBody>
@@ -5599,29 +6483,29 @@
         </p:nvSpPr>
         <p:spPr>
           <a:xfrm>
-            <a:off x="594360" y="3529584"/>
-            <a:ext cx="11002975" cy="685800"/>
-          </a:xfrm>
-          <a:prstGeom prst="rect">
-            <a:avLst/>
-          </a:prstGeom>
-          <a:noFill/>
-        </p:spPr>
-        <p:txBody>
-          <a:bodyPr wrap="square">
-            <a:spAutoFit/>
-          </a:bodyPr>
-          <a:lstStyle/>
-          <a:p>
-            <a:pPr algn="ctr"/>
-            <a:r>
-              <a:rPr sz="4400" b="1" i="0">
+            <a:off x="640080" y="2985516"/>
+            <a:ext cx="10911535" cy="731520"/>
+          </a:xfrm>
+          <a:prstGeom prst="rect">
+            <a:avLst/>
+          </a:prstGeom>
+          <a:noFill/>
+        </p:spPr>
+        <p:txBody>
+          <a:bodyPr wrap="square">
+            <a:spAutoFit/>
+          </a:bodyPr>
+          <a:lstStyle/>
+          <a:p>
+            <a:pPr algn="ctr"/>
+            <a:r>
+              <a:rPr sz="4800" b="1" i="0">
                 <a:solidFill>
                   <a:srgbClr val="FFFFFF"/>
                 </a:solidFill>
                 <a:latin typeface="Arial"/>
               </a:rPr>
-              <a:t>Bendiga o Senhor, ó minha alma</a:t>
+              <a:t>勝てるもの   他に  ない</a:t>
             </a:r>
           </a:p>
         </p:txBody>
@@ -5634,29 +6518,99 @@
         </p:nvSpPr>
         <p:spPr>
           <a:xfrm>
-            <a:off x="594360" y="4251960"/>
-            <a:ext cx="11002975" cy="347472"/>
-          </a:xfrm>
-          <a:prstGeom prst="rect">
-            <a:avLst/>
-          </a:prstGeom>
-          <a:noFill/>
-        </p:spPr>
-        <p:txBody>
-          <a:bodyPr wrap="square">
-            <a:spAutoFit/>
-          </a:bodyPr>
-          <a:lstStyle/>
-          <a:p>
-            <a:pPr algn="ctr"/>
-            <a:r>
-              <a:rPr sz="2200" b="0" i="1">
-                <a:solidFill>
-                  <a:srgbClr val="8C8C8C"/>
-                </a:solidFill>
-                <a:latin typeface="Arial"/>
-              </a:rPr>
-              <a:t/>
+            <a:off x="640080" y="3753612"/>
+            <a:ext cx="10911535" cy="365760"/>
+          </a:xfrm>
+          <a:prstGeom prst="rect">
+            <a:avLst/>
+          </a:prstGeom>
+          <a:noFill/>
+        </p:spPr>
+        <p:txBody>
+          <a:bodyPr wrap="square">
+            <a:spAutoFit/>
+          </a:bodyPr>
+          <a:lstStyle/>
+          <a:p>
+            <a:pPr algn="ctr"/>
+            <a:r>
+              <a:rPr sz="2400" b="0" i="1">
+                <a:solidFill>
+                  <a:srgbClr val="AAAAAA"/>
+                </a:solidFill>
+                <a:latin typeface="Arial"/>
+              </a:rPr>
+              <a:t>Katerumono Hokani nai</a:t>
+            </a:r>
+          </a:p>
+        </p:txBody>
+      </p:sp>
+      <p:sp>
+        <p:nvSpPr>
+          <p:cNvPr id="6" name="TextBox 5"/>
+          <p:cNvSpPr txBox="1"/>
+          <p:nvPr/>
+        </p:nvSpPr>
+        <p:spPr>
+          <a:xfrm>
+            <a:off x="640080" y="4530852"/>
+            <a:ext cx="10911535" cy="310896"/>
+          </a:xfrm>
+          <a:prstGeom prst="rect">
+            <a:avLst/>
+          </a:prstGeom>
+          <a:noFill/>
+        </p:spPr>
+        <p:txBody>
+          <a:bodyPr wrap="square">
+            <a:spAutoFit/>
+          </a:bodyPr>
+          <a:lstStyle/>
+          <a:p>
+            <a:pPr algn="ctr"/>
+            <a:r>
+              <a:rPr sz="2000" b="0" i="1">
+                <a:solidFill>
+                  <a:srgbClr val="828282"/>
+                </a:solidFill>
+                <a:latin typeface="Arial"/>
+              </a:rPr>
+              <a:t>Quão bom é Ele, quão grande é Seu amor</a:t>
+            </a:r>
+          </a:p>
+        </p:txBody>
+      </p:sp>
+      <p:sp>
+        <p:nvSpPr>
+          <p:cNvPr id="7" name="TextBox 6"/>
+          <p:cNvSpPr txBox="1"/>
+          <p:nvPr/>
+        </p:nvSpPr>
+        <p:spPr>
+          <a:xfrm>
+            <a:off x="640080" y="4896612"/>
+            <a:ext cx="10911535" cy="310896"/>
+          </a:xfrm>
+          <a:prstGeom prst="rect">
+            <a:avLst/>
+          </a:prstGeom>
+          <a:noFill/>
+        </p:spPr>
+        <p:txBody>
+          <a:bodyPr wrap="square">
+            <a:spAutoFit/>
+          </a:bodyPr>
+          <a:lstStyle/>
+          <a:p>
+            <a:pPr algn="ctr"/>
+            <a:r>
+              <a:rPr sz="2000" b="0" i="1">
+                <a:solidFill>
+                  <a:srgbClr val="828282"/>
+                </a:solidFill>
+                <a:latin typeface="Arial"/>
+              </a:rPr>
+              <a:t>Quaisquer que sejam as perdas de amanhã</a:t>
             </a:r>
           </a:p>
         </p:txBody>
@@ -5695,134 +6649,204 @@
         </p:nvSpPr>
         <p:spPr>
           <a:xfrm>
-            <a:off x="594360" y="2258568"/>
-            <a:ext cx="11002975" cy="685800"/>
-          </a:xfrm>
-          <a:prstGeom prst="rect">
-            <a:avLst/>
-          </a:prstGeom>
-          <a:noFill/>
-        </p:spPr>
-        <p:txBody>
-          <a:bodyPr wrap="square">
-            <a:spAutoFit/>
-          </a:bodyPr>
-          <a:lstStyle/>
-          <a:p>
-            <a:pPr algn="ctr"/>
-            <a:r>
-              <a:rPr sz="4400" b="1" i="0">
+            <a:off x="640080" y="1650492"/>
+            <a:ext cx="10911535" cy="731520"/>
+          </a:xfrm>
+          <a:prstGeom prst="rect">
+            <a:avLst/>
+          </a:prstGeom>
+          <a:noFill/>
+        </p:spPr>
+        <p:txBody>
+          <a:bodyPr wrap="square">
+            <a:spAutoFit/>
+          </a:bodyPr>
+          <a:lstStyle/>
+          <a:p>
+            <a:pPr algn="ctr"/>
+            <a:r>
+              <a:rPr sz="4800" b="1" i="0">
                 <a:solidFill>
                   <a:srgbClr val="FFFFFF"/>
                 </a:solidFill>
                 <a:latin typeface="Arial"/>
               </a:rPr>
+              <a:t>たましいよ   ほめ歌え   聖なる   主に</a:t>
+            </a:r>
+          </a:p>
+        </p:txBody>
+      </p:sp>
+      <p:sp>
+        <p:nvSpPr>
+          <p:cNvPr id="3" name="TextBox 2"/>
+          <p:cNvSpPr txBox="1"/>
+          <p:nvPr/>
+        </p:nvSpPr>
+        <p:spPr>
+          <a:xfrm>
+            <a:off x="640080" y="2418588"/>
+            <a:ext cx="10911535" cy="365760"/>
+          </a:xfrm>
+          <a:prstGeom prst="rect">
+            <a:avLst/>
+          </a:prstGeom>
+          <a:noFill/>
+        </p:spPr>
+        <p:txBody>
+          <a:bodyPr wrap="square">
+            <a:spAutoFit/>
+          </a:bodyPr>
+          <a:lstStyle/>
+          <a:p>
+            <a:pPr algn="ctr"/>
+            <a:r>
+              <a:rPr sz="2400" b="0" i="1">
+                <a:solidFill>
+                  <a:srgbClr val="AAAAAA"/>
+                </a:solidFill>
+                <a:latin typeface="Arial"/>
+              </a:rPr>
+              <a:t>Tamashiiyo Homeutae Seinaru Shuni</a:t>
+            </a:r>
+          </a:p>
+        </p:txBody>
+      </p:sp>
+      <p:sp>
+        <p:nvSpPr>
+          <p:cNvPr id="4" name="TextBox 3"/>
+          <p:cNvSpPr txBox="1"/>
+          <p:nvPr/>
+        </p:nvSpPr>
+        <p:spPr>
+          <a:xfrm>
+            <a:off x="640080" y="2985516"/>
+            <a:ext cx="10911535" cy="731520"/>
+          </a:xfrm>
+          <a:prstGeom prst="rect">
+            <a:avLst/>
+          </a:prstGeom>
+          <a:noFill/>
+        </p:spPr>
+        <p:txBody>
+          <a:bodyPr wrap="square">
+            <a:spAutoFit/>
+          </a:bodyPr>
+          <a:lstStyle/>
+          <a:p>
+            <a:pPr algn="ctr"/>
+            <a:r>
+              <a:rPr sz="4800" b="1" i="0">
+                <a:solidFill>
+                  <a:srgbClr val="FFFFFF"/>
+                </a:solidFill>
+                <a:latin typeface="Arial"/>
+              </a:rPr>
+              <a:t>こころ   捧げ  うたえ 素晴らしい  主に</a:t>
+            </a:r>
+          </a:p>
+        </p:txBody>
+      </p:sp>
+      <p:sp>
+        <p:nvSpPr>
+          <p:cNvPr id="5" name="TextBox 4"/>
+          <p:cNvSpPr txBox="1"/>
+          <p:nvPr/>
+        </p:nvSpPr>
+        <p:spPr>
+          <a:xfrm>
+            <a:off x="640080" y="3753612"/>
+            <a:ext cx="10911535" cy="365760"/>
+          </a:xfrm>
+          <a:prstGeom prst="rect">
+            <a:avLst/>
+          </a:prstGeom>
+          <a:noFill/>
+        </p:spPr>
+        <p:txBody>
+          <a:bodyPr wrap="square">
+            <a:spAutoFit/>
+          </a:bodyPr>
+          <a:lstStyle/>
+          <a:p>
+            <a:pPr algn="ctr"/>
+            <a:r>
+              <a:rPr sz="2400" b="0" i="1">
+                <a:solidFill>
+                  <a:srgbClr val="AAAAAA"/>
+                </a:solidFill>
+                <a:latin typeface="Arial"/>
+              </a:rPr>
+              <a:t>Kokoro Sasage Utae Subarashii Shuni</a:t>
+            </a:r>
+          </a:p>
+        </p:txBody>
+      </p:sp>
+      <p:sp>
+        <p:nvSpPr>
+          <p:cNvPr id="6" name="TextBox 5"/>
+          <p:cNvSpPr txBox="1"/>
+          <p:nvPr/>
+        </p:nvSpPr>
+        <p:spPr>
+          <a:xfrm>
+            <a:off x="640080" y="4530852"/>
+            <a:ext cx="10911535" cy="310896"/>
+          </a:xfrm>
+          <a:prstGeom prst="rect">
+            <a:avLst/>
+          </a:prstGeom>
+          <a:noFill/>
+        </p:spPr>
+        <p:txBody>
+          <a:bodyPr wrap="square">
+            <a:spAutoFit/>
+          </a:bodyPr>
+          <a:lstStyle/>
+          <a:p>
+            <a:pPr algn="ctr"/>
+            <a:r>
+              <a:rPr sz="2000" b="0" i="1">
+                <a:solidFill>
+                  <a:srgbClr val="828282"/>
+                </a:solidFill>
+                <a:latin typeface="Arial"/>
+              </a:rPr>
+              <a:t>Bendiga o Senhor, ó minha alma</a:t>
+            </a:r>
+          </a:p>
+        </p:txBody>
+      </p:sp>
+      <p:sp>
+        <p:nvSpPr>
+          <p:cNvPr id="7" name="TextBox 6"/>
+          <p:cNvSpPr txBox="1"/>
+          <p:nvPr/>
+        </p:nvSpPr>
+        <p:spPr>
+          <a:xfrm>
+            <a:off x="640080" y="4896612"/>
+            <a:ext cx="10911535" cy="310896"/>
+          </a:xfrm>
+          <a:prstGeom prst="rect">
+            <a:avLst/>
+          </a:prstGeom>
+          <a:noFill/>
+        </p:spPr>
+        <p:txBody>
+          <a:bodyPr wrap="square">
+            <a:spAutoFit/>
+          </a:bodyPr>
+          <a:lstStyle/>
+          <a:p>
+            <a:pPr algn="ctr"/>
+            <a:r>
+              <a:rPr sz="2000" b="0" i="1">
+                <a:solidFill>
+                  <a:srgbClr val="828282"/>
+                </a:solidFill>
+                <a:latin typeface="Arial"/>
+              </a:rPr>
               <a:t>Ó minha alma</a:t>
-            </a:r>
-          </a:p>
-        </p:txBody>
-      </p:sp>
-      <p:sp>
-        <p:nvSpPr>
-          <p:cNvPr id="3" name="TextBox 2"/>
-          <p:cNvSpPr txBox="1"/>
-          <p:nvPr/>
-        </p:nvSpPr>
-        <p:spPr>
-          <a:xfrm>
-            <a:off x="594360" y="2980944"/>
-            <a:ext cx="11002975" cy="347472"/>
-          </a:xfrm>
-          <a:prstGeom prst="rect">
-            <a:avLst/>
-          </a:prstGeom>
-          <a:noFill/>
-        </p:spPr>
-        <p:txBody>
-          <a:bodyPr wrap="square">
-            <a:spAutoFit/>
-          </a:bodyPr>
-          <a:lstStyle/>
-          <a:p>
-            <a:pPr algn="ctr"/>
-            <a:r>
-              <a:rPr sz="2200" b="0" i="1">
-                <a:solidFill>
-                  <a:srgbClr val="8C8C8C"/>
-                </a:solidFill>
-                <a:latin typeface="Arial"/>
-              </a:rPr>
-              <a:t/>
-            </a:r>
-          </a:p>
-        </p:txBody>
-      </p:sp>
-      <p:sp>
-        <p:nvSpPr>
-          <p:cNvPr id="4" name="TextBox 3"/>
-          <p:cNvSpPr txBox="1"/>
-          <p:nvPr/>
-        </p:nvSpPr>
-        <p:spPr>
-          <a:xfrm>
-            <a:off x="594360" y="3529584"/>
-            <a:ext cx="11002975" cy="685800"/>
-          </a:xfrm>
-          <a:prstGeom prst="rect">
-            <a:avLst/>
-          </a:prstGeom>
-          <a:noFill/>
-        </p:spPr>
-        <p:txBody>
-          <a:bodyPr wrap="square">
-            <a:spAutoFit/>
-          </a:bodyPr>
-          <a:lstStyle/>
-          <a:p>
-            <a:pPr algn="ctr"/>
-            <a:r>
-              <a:rPr sz="4400" b="1" i="0">
-                <a:solidFill>
-                  <a:srgbClr val="FFFFFF"/>
-                </a:solidFill>
-                <a:latin typeface="Arial"/>
-              </a:rPr>
-              <a:t>Adore Seu santo nome</a:t>
-            </a:r>
-          </a:p>
-        </p:txBody>
-      </p:sp>
-      <p:sp>
-        <p:nvSpPr>
-          <p:cNvPr id="5" name="TextBox 4"/>
-          <p:cNvSpPr txBox="1"/>
-          <p:nvPr/>
-        </p:nvSpPr>
-        <p:spPr>
-          <a:xfrm>
-            <a:off x="594360" y="4251960"/>
-            <a:ext cx="11002975" cy="347472"/>
-          </a:xfrm>
-          <a:prstGeom prst="rect">
-            <a:avLst/>
-          </a:prstGeom>
-          <a:noFill/>
-        </p:spPr>
-        <p:txBody>
-          <a:bodyPr wrap="square">
-            <a:spAutoFit/>
-          </a:bodyPr>
-          <a:lstStyle/>
-          <a:p>
-            <a:pPr algn="ctr"/>
-            <a:r>
-              <a:rPr sz="2200" b="0" i="1">
-                <a:solidFill>
-                  <a:srgbClr val="8C8C8C"/>
-                </a:solidFill>
-                <a:latin typeface="Arial"/>
-              </a:rPr>
-              <a:t/>
             </a:r>
           </a:p>
         </p:txBody>

</xml_diff>

<commit_message>
Add auto-translations to all 97 worship slide decks
All PT slides now have JP translations below, and all JP slides have PT
translations below — auto-generated via Claude API (haiku) for any lines
not covered by the bilingual chord charts. Translation cache of ~1000
entries stored in pptx_translation_cache.json.

Co-Authored-By: Claude Sonnet 4.6 <noreply@anthropic.com>
</commit_message>
<xml_diff>
--- a/output_pptx/10000_Reasons_Bless_The_Lord.pptx
+++ b/output_pptx/10000_Reasons_Bless_The_Lord.pptx
@@ -3357,6 +3357,76 @@
           </a:p>
         </p:txBody>
       </p:sp>
+      <p:sp>
+        <p:nvSpPr>
+          <p:cNvPr id="4" name="TextBox 3"/>
+          <p:cNvSpPr txBox="1"/>
+          <p:nvPr/>
+        </p:nvSpPr>
+        <p:spPr>
+          <a:xfrm>
+            <a:off x="640080" y="4128516"/>
+            <a:ext cx="10911535" cy="310896"/>
+          </a:xfrm>
+          <a:prstGeom prst="rect">
+            <a:avLst/>
+          </a:prstGeom>
+          <a:noFill/>
+        </p:spPr>
+        <p:txBody>
+          <a:bodyPr wrap="square">
+            <a:spAutoFit/>
+          </a:bodyPr>
+          <a:lstStyle/>
+          <a:p>
+            <a:pPr algn="ctr"/>
+            <a:r>
+              <a:rPr sz="2000" b="0" i="0">
+                <a:solidFill>
+                  <a:srgbClr val="828282"/>
+                </a:solidFill>
+                <a:latin typeface="Arial"/>
+              </a:rPr>
+              <a:t>主をほめたたえよ</a:t>
+            </a:r>
+          </a:p>
+        </p:txBody>
+      </p:sp>
+      <p:sp>
+        <p:nvSpPr>
+          <p:cNvPr id="5" name="TextBox 4"/>
+          <p:cNvSpPr txBox="1"/>
+          <p:nvPr/>
+        </p:nvSpPr>
+        <p:spPr>
+          <a:xfrm>
+            <a:off x="640080" y="4494276"/>
+            <a:ext cx="10911535" cy="310896"/>
+          </a:xfrm>
+          <a:prstGeom prst="rect">
+            <a:avLst/>
+          </a:prstGeom>
+          <a:noFill/>
+        </p:spPr>
+        <p:txBody>
+          <a:bodyPr wrap="square">
+            <a:spAutoFit/>
+          </a:bodyPr>
+          <a:lstStyle/>
+          <a:p>
+            <a:pPr algn="ctr"/>
+            <a:r>
+              <a:rPr sz="2000" b="0" i="0">
+                <a:solidFill>
+                  <a:srgbClr val="828282"/>
+                </a:solidFill>
+                <a:latin typeface="Arial"/>
+              </a:rPr>
+              <a:t>太陽は沈み、夜明けが歌う</a:t>
+            </a:r>
+          </a:p>
+        </p:txBody>
+      </p:sp>
     </p:spTree>
   </p:cSld>
   <p:clrMapOvr>
@@ -3453,6 +3523,76 @@
           </a:p>
         </p:txBody>
       </p:sp>
+      <p:sp>
+        <p:nvSpPr>
+          <p:cNvPr id="4" name="TextBox 3"/>
+          <p:cNvSpPr txBox="1"/>
+          <p:nvPr/>
+        </p:nvSpPr>
+        <p:spPr>
+          <a:xfrm>
+            <a:off x="640080" y="4128516"/>
+            <a:ext cx="10911535" cy="310896"/>
+          </a:xfrm>
+          <a:prstGeom prst="rect">
+            <a:avLst/>
+          </a:prstGeom>
+          <a:noFill/>
+        </p:spPr>
+        <p:txBody>
+          <a:bodyPr wrap="square">
+            <a:spAutoFit/>
+          </a:bodyPr>
+          <a:lstStyle/>
+          <a:p>
+            <a:pPr algn="ctr"/>
+            <a:r>
+              <a:rPr sz="2000" b="0" i="0">
+                <a:solidFill>
+                  <a:srgbClr val="828282"/>
+                </a:solidFill>
+                <a:latin typeface="Arial"/>
+              </a:rPr>
+              <a:t>主はなんと善く、その愛はなんと大きいか</a:t>
+            </a:r>
+          </a:p>
+        </p:txBody>
+      </p:sp>
+      <p:sp>
+        <p:nvSpPr>
+          <p:cNvPr id="5" name="TextBox 4"/>
+          <p:cNvSpPr txBox="1"/>
+          <p:nvPr/>
+        </p:nvSpPr>
+        <p:spPr>
+          <a:xfrm>
+            <a:off x="640080" y="4494276"/>
+            <a:ext cx="10911535" cy="310896"/>
+          </a:xfrm>
+          <a:prstGeom prst="rect">
+            <a:avLst/>
+          </a:prstGeom>
+          <a:noFill/>
+        </p:spPr>
+        <p:txBody>
+          <a:bodyPr wrap="square">
+            <a:spAutoFit/>
+          </a:bodyPr>
+          <a:lstStyle/>
+          <a:p>
+            <a:pPr algn="ctr"/>
+            <a:r>
+              <a:rPr sz="2000" b="0" i="0">
+                <a:solidFill>
+                  <a:srgbClr val="828282"/>
+                </a:solidFill>
+                <a:latin typeface="Arial"/>
+              </a:rPr>
+              <a:t>明日がどのような喪失をもたらそうとも</a:t>
+            </a:r>
+          </a:p>
+        </p:txBody>
+      </p:sp>
     </p:spTree>
   </p:cSld>
   <p:clrMapOvr>
@@ -3881,6 +4021,76 @@
           </a:p>
         </p:txBody>
       </p:sp>
+      <p:sp>
+        <p:nvSpPr>
+          <p:cNvPr id="4" name="TextBox 3"/>
+          <p:cNvSpPr txBox="1"/>
+          <p:nvPr/>
+        </p:nvSpPr>
+        <p:spPr>
+          <a:xfrm>
+            <a:off x="640080" y="4128516"/>
+            <a:ext cx="10911535" cy="310896"/>
+          </a:xfrm>
+          <a:prstGeom prst="rect">
+            <a:avLst/>
+          </a:prstGeom>
+          <a:noFill/>
+        </p:spPr>
+        <p:txBody>
+          <a:bodyPr wrap="square">
+            <a:spAutoFit/>
+          </a:bodyPr>
+          <a:lstStyle/>
+          <a:p>
+            <a:pPr algn="ctr"/>
+            <a:r>
+              <a:rPr sz="2000" b="0" i="0">
+                <a:solidFill>
+                  <a:srgbClr val="828282"/>
+                </a:solidFill>
+                <a:latin typeface="Arial"/>
+              </a:rPr>
+              <a:t>わたしの歌はなおも歌われるでしょう</a:t>
+            </a:r>
+          </a:p>
+        </p:txBody>
+      </p:sp>
+      <p:sp>
+        <p:nvSpPr>
+          <p:cNvPr id="5" name="TextBox 4"/>
+          <p:cNvSpPr txBox="1"/>
+          <p:nvPr/>
+        </p:nvSpPr>
+        <p:spPr>
+          <a:xfrm>
+            <a:off x="640080" y="4494276"/>
+            <a:ext cx="10911535" cy="310896"/>
+          </a:xfrm>
+          <a:prstGeom prst="rect">
+            <a:avLst/>
+          </a:prstGeom>
+          <a:noFill/>
+        </p:spPr>
+        <p:txBody>
+          <a:bodyPr wrap="square">
+            <a:spAutoFit/>
+          </a:bodyPr>
+          <a:lstStyle/>
+          <a:p>
+            <a:pPr algn="ctr"/>
+            <a:r>
+              <a:rPr sz="2000" b="0" i="0">
+                <a:solidFill>
+                  <a:srgbClr val="828282"/>
+                </a:solidFill>
+                <a:latin typeface="Arial"/>
+              </a:rPr>
+              <a:t>わが魂よ、主をほめたたえよ</a:t>
+            </a:r>
+          </a:p>
+        </p:txBody>
+      </p:sp>
     </p:spTree>
   </p:cSld>
   <p:clrMapOvr>
@@ -3977,6 +4187,76 @@
           </a:p>
         </p:txBody>
       </p:sp>
+      <p:sp>
+        <p:nvSpPr>
+          <p:cNvPr id="4" name="TextBox 3"/>
+          <p:cNvSpPr txBox="1"/>
+          <p:nvPr/>
+        </p:nvSpPr>
+        <p:spPr>
+          <a:xfrm>
+            <a:off x="640080" y="4128516"/>
+            <a:ext cx="10911535" cy="310896"/>
+          </a:xfrm>
+          <a:prstGeom prst="rect">
+            <a:avLst/>
+          </a:prstGeom>
+          <a:noFill/>
+        </p:spPr>
+        <p:txBody>
+          <a:bodyPr wrap="square">
+            <a:spAutoFit/>
+          </a:bodyPr>
+          <a:lstStyle/>
+          <a:p>
+            <a:pPr algn="ctr"/>
+            <a:r>
+              <a:rPr sz="2000" b="0" i="0">
+                <a:solidFill>
+                  <a:srgbClr val="828282"/>
+                </a:solidFill>
+                <a:latin typeface="Arial"/>
+              </a:rPr>
+              <a:t>わが魂よ</a:t>
+            </a:r>
+          </a:p>
+        </p:txBody>
+      </p:sp>
+      <p:sp>
+        <p:nvSpPr>
+          <p:cNvPr id="5" name="TextBox 4"/>
+          <p:cNvSpPr txBox="1"/>
+          <p:nvPr/>
+        </p:nvSpPr>
+        <p:spPr>
+          <a:xfrm>
+            <a:off x="640080" y="4494276"/>
+            <a:ext cx="10911535" cy="310896"/>
+          </a:xfrm>
+          <a:prstGeom prst="rect">
+            <a:avLst/>
+          </a:prstGeom>
+          <a:noFill/>
+        </p:spPr>
+        <p:txBody>
+          <a:bodyPr wrap="square">
+            <a:spAutoFit/>
+          </a:bodyPr>
+          <a:lstStyle/>
+          <a:p>
+            <a:pPr algn="ctr"/>
+            <a:r>
+              <a:rPr sz="2000" b="0" i="0">
+                <a:solidFill>
+                  <a:srgbClr val="828282"/>
+                </a:solidFill>
+                <a:latin typeface="Arial"/>
+              </a:rPr>
+              <a:t>主の聖なる御名をあがめよ</a:t>
+            </a:r>
+          </a:p>
+        </p:txBody>
+      </p:sp>
     </p:spTree>
   </p:cSld>
   <p:clrMapOvr>
@@ -4073,6 +4353,76 @@
           </a:p>
         </p:txBody>
       </p:sp>
+      <p:sp>
+        <p:nvSpPr>
+          <p:cNvPr id="4" name="TextBox 3"/>
+          <p:cNvSpPr txBox="1"/>
+          <p:nvPr/>
+        </p:nvSpPr>
+        <p:spPr>
+          <a:xfrm>
+            <a:off x="640080" y="4128516"/>
+            <a:ext cx="10911535" cy="310896"/>
+          </a:xfrm>
+          <a:prstGeom prst="rect">
+            <a:avLst/>
+          </a:prstGeom>
+          <a:noFill/>
+        </p:spPr>
+        <p:txBody>
+          <a:bodyPr wrap="square">
+            <a:spAutoFit/>
+          </a:bodyPr>
+          <a:lstStyle/>
+          <a:p>
+            <a:pPr algn="ctr"/>
+            <a:r>
+              <a:rPr sz="2000" b="0" i="0">
+                <a:solidFill>
+                  <a:srgbClr val="828282"/>
+                </a:solidFill>
+                <a:latin typeface="Arial"/>
+              </a:rPr>
+              <a:t>わたしの心が見出す万の理由</a:t>
+            </a:r>
+          </a:p>
+        </p:txBody>
+      </p:sp>
+      <p:sp>
+        <p:nvSpPr>
+          <p:cNvPr id="5" name="TextBox 4"/>
+          <p:cNvSpPr txBox="1"/>
+          <p:nvPr/>
+        </p:nvSpPr>
+        <p:spPr>
+          <a:xfrm>
+            <a:off x="640080" y="4494276"/>
+            <a:ext cx="10911535" cy="310896"/>
+          </a:xfrm>
+          <a:prstGeom prst="rect">
+            <a:avLst/>
+          </a:prstGeom>
+          <a:noFill/>
+        </p:spPr>
+        <p:txBody>
+          <a:bodyPr wrap="square">
+            <a:spAutoFit/>
+          </a:bodyPr>
+          <a:lstStyle/>
+          <a:p>
+            <a:pPr algn="ctr"/>
+            <a:r>
+              <a:rPr sz="2000" b="0" i="0">
+                <a:solidFill>
+                  <a:srgbClr val="828282"/>
+                </a:solidFill>
+                <a:latin typeface="Arial"/>
+              </a:rPr>
+              <a:t>主をほめたたえよ</a:t>
+            </a:r>
+          </a:p>
+        </p:txBody>
+      </p:sp>
     </p:spTree>
   </p:cSld>
   <p:clrMapOvr>
@@ -4169,6 +4519,76 @@
           </a:p>
         </p:txBody>
       </p:sp>
+      <p:sp>
+        <p:nvSpPr>
+          <p:cNvPr id="4" name="TextBox 3"/>
+          <p:cNvSpPr txBox="1"/>
+          <p:nvPr/>
+        </p:nvSpPr>
+        <p:spPr>
+          <a:xfrm>
+            <a:off x="640080" y="4128516"/>
+            <a:ext cx="10911535" cy="310896"/>
+          </a:xfrm>
+          <a:prstGeom prst="rect">
+            <a:avLst/>
+          </a:prstGeom>
+          <a:noFill/>
+        </p:spPr>
+        <p:txBody>
+          <a:bodyPr wrap="square">
+            <a:spAutoFit/>
+          </a:bodyPr>
+          <a:lstStyle/>
+          <a:p>
+            <a:pPr algn="ctr"/>
+            <a:r>
+              <a:rPr sz="2000" b="0" i="0">
+                <a:solidFill>
+                  <a:srgbClr val="828282"/>
+                </a:solidFill>
+                <a:latin typeface="Arial"/>
+              </a:rPr>
+              <a:t>主の力が尽きる日にも</a:t>
+            </a:r>
+          </a:p>
+        </p:txBody>
+      </p:sp>
+      <p:sp>
+        <p:nvSpPr>
+          <p:cNvPr id="5" name="TextBox 4"/>
+          <p:cNvSpPr txBox="1"/>
+          <p:nvPr/>
+        </p:nvSpPr>
+        <p:spPr>
+          <a:xfrm>
+            <a:off x="640080" y="4494276"/>
+            <a:ext cx="10911535" cy="310896"/>
+          </a:xfrm>
+          <a:prstGeom prst="rect">
+            <a:avLst/>
+          </a:prstGeom>
+          <a:noFill/>
+        </p:spPr>
+        <p:txBody>
+          <a:bodyPr wrap="square">
+            <a:spAutoFit/>
+          </a:bodyPr>
+          <a:lstStyle/>
+          <a:p>
+            <a:pPr algn="ctr"/>
+            <a:r>
+              <a:rPr sz="2000" b="0" i="0">
+                <a:solidFill>
+                  <a:srgbClr val="828282"/>
+                </a:solidFill>
+                <a:latin typeface="Arial"/>
+              </a:rPr>
+              <a:t>終わりが来るとき</a:t>
+            </a:r>
+          </a:p>
+        </p:txBody>
+      </p:sp>
     </p:spTree>
   </p:cSld>
   <p:clrMapOvr>
@@ -5471,6 +5891,76 @@
           </a:p>
         </p:txBody>
       </p:sp>
+      <p:sp>
+        <p:nvSpPr>
+          <p:cNvPr id="4" name="TextBox 3"/>
+          <p:cNvSpPr txBox="1"/>
+          <p:nvPr/>
+        </p:nvSpPr>
+        <p:spPr>
+          <a:xfrm>
+            <a:off x="640080" y="4128516"/>
+            <a:ext cx="10911535" cy="310896"/>
+          </a:xfrm>
+          <a:prstGeom prst="rect">
+            <a:avLst/>
+          </a:prstGeom>
+          <a:noFill/>
+        </p:spPr>
+        <p:txBody>
+          <a:bodyPr wrap="square">
+            <a:spAutoFit/>
+          </a:bodyPr>
+          <a:lstStyle/>
+          <a:p>
+            <a:pPr algn="ctr"/>
+            <a:r>
+              <a:rPr sz="2000" b="0" i="0">
+                <a:solidFill>
+                  <a:srgbClr val="828282"/>
+                </a:solidFill>
+                <a:latin typeface="Arial"/>
+              </a:rPr>
+              <a:t>わたしの歌はなおも歌われるでしょう</a:t>
+            </a:r>
+          </a:p>
+        </p:txBody>
+      </p:sp>
+      <p:sp>
+        <p:nvSpPr>
+          <p:cNvPr id="5" name="TextBox 4"/>
+          <p:cNvSpPr txBox="1"/>
+          <p:nvPr/>
+        </p:nvSpPr>
+        <p:spPr>
+          <a:xfrm>
+            <a:off x="640080" y="4494276"/>
+            <a:ext cx="10911535" cy="310896"/>
+          </a:xfrm>
+          <a:prstGeom prst="rect">
+            <a:avLst/>
+          </a:prstGeom>
+          <a:noFill/>
+        </p:spPr>
+        <p:txBody>
+          <a:bodyPr wrap="square">
+            <a:spAutoFit/>
+          </a:bodyPr>
+          <a:lstStyle/>
+          <a:p>
+            <a:pPr algn="ctr"/>
+            <a:r>
+              <a:rPr sz="2000" b="0" i="0">
+                <a:solidFill>
+                  <a:srgbClr val="828282"/>
+                </a:solidFill>
+                <a:latin typeface="Arial"/>
+              </a:rPr>
+              <a:t>わが魂よ、主をほめたたえよ</a:t>
+            </a:r>
+          </a:p>
+        </p:txBody>
+      </p:sp>
     </p:spTree>
   </p:cSld>
   <p:clrMapOvr>
@@ -5567,6 +6057,76 @@
           </a:p>
         </p:txBody>
       </p:sp>
+      <p:sp>
+        <p:nvSpPr>
+          <p:cNvPr id="4" name="TextBox 3"/>
+          <p:cNvSpPr txBox="1"/>
+          <p:nvPr/>
+        </p:nvSpPr>
+        <p:spPr>
+          <a:xfrm>
+            <a:off x="640080" y="4128516"/>
+            <a:ext cx="10911535" cy="310896"/>
+          </a:xfrm>
+          <a:prstGeom prst="rect">
+            <a:avLst/>
+          </a:prstGeom>
+          <a:noFill/>
+        </p:spPr>
+        <p:txBody>
+          <a:bodyPr wrap="square">
+            <a:spAutoFit/>
+          </a:bodyPr>
+          <a:lstStyle/>
+          <a:p>
+            <a:pPr algn="ctr"/>
+            <a:r>
+              <a:rPr sz="2000" b="0" i="0">
+                <a:solidFill>
+                  <a:srgbClr val="828282"/>
+                </a:solidFill>
+                <a:latin typeface="Arial"/>
+              </a:rPr>
+              <a:t>わが魂よ</a:t>
+            </a:r>
+          </a:p>
+        </p:txBody>
+      </p:sp>
+      <p:sp>
+        <p:nvSpPr>
+          <p:cNvPr id="5" name="TextBox 4"/>
+          <p:cNvSpPr txBox="1"/>
+          <p:nvPr/>
+        </p:nvSpPr>
+        <p:spPr>
+          <a:xfrm>
+            <a:off x="640080" y="4494276"/>
+            <a:ext cx="10911535" cy="310896"/>
+          </a:xfrm>
+          <a:prstGeom prst="rect">
+            <a:avLst/>
+          </a:prstGeom>
+          <a:noFill/>
+        </p:spPr>
+        <p:txBody>
+          <a:bodyPr wrap="square">
+            <a:spAutoFit/>
+          </a:bodyPr>
+          <a:lstStyle/>
+          <a:p>
+            <a:pPr algn="ctr"/>
+            <a:r>
+              <a:rPr sz="2000" b="0" i="0">
+                <a:solidFill>
+                  <a:srgbClr val="828282"/>
+                </a:solidFill>
+                <a:latin typeface="Arial"/>
+              </a:rPr>
+              <a:t>主の聖なる御名をあがめよ</a:t>
+            </a:r>
+          </a:p>
+        </p:txBody>
+      </p:sp>
     </p:spTree>
   </p:cSld>
   <p:clrMapOvr>
@@ -5663,6 +6223,76 @@
           </a:p>
         </p:txBody>
       </p:sp>
+      <p:sp>
+        <p:nvSpPr>
+          <p:cNvPr id="4" name="TextBox 3"/>
+          <p:cNvSpPr txBox="1"/>
+          <p:nvPr/>
+        </p:nvSpPr>
+        <p:spPr>
+          <a:xfrm>
+            <a:off x="640080" y="4128516"/>
+            <a:ext cx="10911535" cy="310896"/>
+          </a:xfrm>
+          <a:prstGeom prst="rect">
+            <a:avLst/>
+          </a:prstGeom>
+          <a:noFill/>
+        </p:spPr>
+        <p:txBody>
+          <a:bodyPr wrap="square">
+            <a:spAutoFit/>
+          </a:bodyPr>
+          <a:lstStyle/>
+          <a:p>
+            <a:pPr algn="ctr"/>
+            <a:r>
+              <a:rPr sz="2000" b="0" i="0">
+                <a:solidFill>
+                  <a:srgbClr val="828282"/>
+                </a:solidFill>
+                <a:latin typeface="Arial"/>
+              </a:rPr>
+              <a:t>わたしの心が見出す万の理由</a:t>
+            </a:r>
+          </a:p>
+        </p:txBody>
+      </p:sp>
+      <p:sp>
+        <p:nvSpPr>
+          <p:cNvPr id="5" name="TextBox 4"/>
+          <p:cNvSpPr txBox="1"/>
+          <p:nvPr/>
+        </p:nvSpPr>
+        <p:spPr>
+          <a:xfrm>
+            <a:off x="640080" y="4494276"/>
+            <a:ext cx="10911535" cy="310896"/>
+          </a:xfrm>
+          <a:prstGeom prst="rect">
+            <a:avLst/>
+          </a:prstGeom>
+          <a:noFill/>
+        </p:spPr>
+        <p:txBody>
+          <a:bodyPr wrap="square">
+            <a:spAutoFit/>
+          </a:bodyPr>
+          <a:lstStyle/>
+          <a:p>
+            <a:pPr algn="ctr"/>
+            <a:r>
+              <a:rPr sz="2000" b="0" i="0">
+                <a:solidFill>
+                  <a:srgbClr val="828282"/>
+                </a:solidFill>
+                <a:latin typeface="Arial"/>
+              </a:rPr>
+              <a:t>主をほめたたえよ</a:t>
+            </a:r>
+          </a:p>
+        </p:txBody>
+      </p:sp>
     </p:spTree>
   </p:cSld>
   <p:clrMapOvr>
@@ -5759,6 +6389,76 @@
           </a:p>
         </p:txBody>
       </p:sp>
+      <p:sp>
+        <p:nvSpPr>
+          <p:cNvPr id="4" name="TextBox 3"/>
+          <p:cNvSpPr txBox="1"/>
+          <p:nvPr/>
+        </p:nvSpPr>
+        <p:spPr>
+          <a:xfrm>
+            <a:off x="640080" y="4128516"/>
+            <a:ext cx="10911535" cy="310896"/>
+          </a:xfrm>
+          <a:prstGeom prst="rect">
+            <a:avLst/>
+          </a:prstGeom>
+          <a:noFill/>
+        </p:spPr>
+        <p:txBody>
+          <a:bodyPr wrap="square">
+            <a:spAutoFit/>
+          </a:bodyPr>
+          <a:lstStyle/>
+          <a:p>
+            <a:pPr algn="ctr"/>
+            <a:r>
+              <a:rPr sz="2000" b="0" i="0">
+                <a:solidFill>
+                  <a:srgbClr val="828282"/>
+                </a:solidFill>
+                <a:latin typeface="Arial"/>
+              </a:rPr>
+              <a:t>主の力が尽きる日にも</a:t>
+            </a:r>
+          </a:p>
+        </p:txBody>
+      </p:sp>
+      <p:sp>
+        <p:nvSpPr>
+          <p:cNvPr id="5" name="TextBox 4"/>
+          <p:cNvSpPr txBox="1"/>
+          <p:nvPr/>
+        </p:nvSpPr>
+        <p:spPr>
+          <a:xfrm>
+            <a:off x="640080" y="4494276"/>
+            <a:ext cx="10911535" cy="310896"/>
+          </a:xfrm>
+          <a:prstGeom prst="rect">
+            <a:avLst/>
+          </a:prstGeom>
+          <a:noFill/>
+        </p:spPr>
+        <p:txBody>
+          <a:bodyPr wrap="square">
+            <a:spAutoFit/>
+          </a:bodyPr>
+          <a:lstStyle/>
+          <a:p>
+            <a:pPr algn="ctr"/>
+            <a:r>
+              <a:rPr sz="2000" b="0" i="0">
+                <a:solidFill>
+                  <a:srgbClr val="828282"/>
+                </a:solidFill>
+                <a:latin typeface="Arial"/>
+              </a:rPr>
+              <a:t>終わりが来るとき</a:t>
+            </a:r>
+          </a:p>
+        </p:txBody>
+      </p:sp>
     </p:spTree>
   </p:cSld>
   <p:clrMapOvr>
@@ -5855,6 +6555,76 @@
           </a:p>
         </p:txBody>
       </p:sp>
+      <p:sp>
+        <p:nvSpPr>
+          <p:cNvPr id="4" name="TextBox 3"/>
+          <p:cNvSpPr txBox="1"/>
+          <p:nvPr/>
+        </p:nvSpPr>
+        <p:spPr>
+          <a:xfrm>
+            <a:off x="640080" y="4128516"/>
+            <a:ext cx="10911535" cy="310896"/>
+          </a:xfrm>
+          <a:prstGeom prst="rect">
+            <a:avLst/>
+          </a:prstGeom>
+          <a:noFill/>
+        </p:spPr>
+        <p:txBody>
+          <a:bodyPr wrap="square">
+            <a:spAutoFit/>
+          </a:bodyPr>
+          <a:lstStyle/>
+          <a:p>
+            <a:pPr algn="ctr"/>
+            <a:r>
+              <a:rPr sz="2000" b="0" i="0">
+                <a:solidFill>
+                  <a:srgbClr val="828282"/>
+                </a:solidFill>
+                <a:latin typeface="Arial"/>
+              </a:rPr>
+              <a:t>わたしの歌はなおも歌われるでしょう</a:t>
+            </a:r>
+          </a:p>
+        </p:txBody>
+      </p:sp>
+      <p:sp>
+        <p:nvSpPr>
+          <p:cNvPr id="5" name="TextBox 4"/>
+          <p:cNvSpPr txBox="1"/>
+          <p:nvPr/>
+        </p:nvSpPr>
+        <p:spPr>
+          <a:xfrm>
+            <a:off x="640080" y="4494276"/>
+            <a:ext cx="10911535" cy="310896"/>
+          </a:xfrm>
+          <a:prstGeom prst="rect">
+            <a:avLst/>
+          </a:prstGeom>
+          <a:noFill/>
+        </p:spPr>
+        <p:txBody>
+          <a:bodyPr wrap="square">
+            <a:spAutoFit/>
+          </a:bodyPr>
+          <a:lstStyle/>
+          <a:p>
+            <a:pPr algn="ctr"/>
+            <a:r>
+              <a:rPr sz="2000" b="0" i="0">
+                <a:solidFill>
+                  <a:srgbClr val="828282"/>
+                </a:solidFill>
+                <a:latin typeface="Arial"/>
+              </a:rPr>
+              <a:t>わが魂よ、主をほめたたえよ</a:t>
+            </a:r>
+          </a:p>
+        </p:txBody>
+      </p:sp>
     </p:spTree>
   </p:cSld>
   <p:clrMapOvr>
@@ -5951,6 +6721,76 @@
           </a:p>
         </p:txBody>
       </p:sp>
+      <p:sp>
+        <p:nvSpPr>
+          <p:cNvPr id="4" name="TextBox 3"/>
+          <p:cNvSpPr txBox="1"/>
+          <p:nvPr/>
+        </p:nvSpPr>
+        <p:spPr>
+          <a:xfrm>
+            <a:off x="640080" y="4128516"/>
+            <a:ext cx="10911535" cy="310896"/>
+          </a:xfrm>
+          <a:prstGeom prst="rect">
+            <a:avLst/>
+          </a:prstGeom>
+          <a:noFill/>
+        </p:spPr>
+        <p:txBody>
+          <a:bodyPr wrap="square">
+            <a:spAutoFit/>
+          </a:bodyPr>
+          <a:lstStyle/>
+          <a:p>
+            <a:pPr algn="ctr"/>
+            <a:r>
+              <a:rPr sz="2000" b="0" i="0">
+                <a:solidFill>
+                  <a:srgbClr val="828282"/>
+                </a:solidFill>
+                <a:latin typeface="Arial"/>
+              </a:rPr>
+              <a:t>わが魂よ</a:t>
+            </a:r>
+          </a:p>
+        </p:txBody>
+      </p:sp>
+      <p:sp>
+        <p:nvSpPr>
+          <p:cNvPr id="5" name="TextBox 4"/>
+          <p:cNvSpPr txBox="1"/>
+          <p:nvPr/>
+        </p:nvSpPr>
+        <p:spPr>
+          <a:xfrm>
+            <a:off x="640080" y="4494276"/>
+            <a:ext cx="10911535" cy="310896"/>
+          </a:xfrm>
+          <a:prstGeom prst="rect">
+            <a:avLst/>
+          </a:prstGeom>
+          <a:noFill/>
+        </p:spPr>
+        <p:txBody>
+          <a:bodyPr wrap="square">
+            <a:spAutoFit/>
+          </a:bodyPr>
+          <a:lstStyle/>
+          <a:p>
+            <a:pPr algn="ctr"/>
+            <a:r>
+              <a:rPr sz="2000" b="0" i="0">
+                <a:solidFill>
+                  <a:srgbClr val="828282"/>
+                </a:solidFill>
+                <a:latin typeface="Arial"/>
+              </a:rPr>
+              <a:t>主の聖なる御名をあがめよ</a:t>
+            </a:r>
+          </a:p>
+        </p:txBody>
+      </p:sp>
     </p:spTree>
   </p:cSld>
   <p:clrMapOvr>
@@ -6047,6 +6887,76 @@
           </a:p>
         </p:txBody>
       </p:sp>
+      <p:sp>
+        <p:nvSpPr>
+          <p:cNvPr id="4" name="TextBox 3"/>
+          <p:cNvSpPr txBox="1"/>
+          <p:nvPr/>
+        </p:nvSpPr>
+        <p:spPr>
+          <a:xfrm>
+            <a:off x="640080" y="4128516"/>
+            <a:ext cx="10911535" cy="310896"/>
+          </a:xfrm>
+          <a:prstGeom prst="rect">
+            <a:avLst/>
+          </a:prstGeom>
+          <a:noFill/>
+        </p:spPr>
+        <p:txBody>
+          <a:bodyPr wrap="square">
+            <a:spAutoFit/>
+          </a:bodyPr>
+          <a:lstStyle/>
+          <a:p>
+            <a:pPr algn="ctr"/>
+            <a:r>
+              <a:rPr sz="2000" b="0" i="0">
+                <a:solidFill>
+                  <a:srgbClr val="828282"/>
+                </a:solidFill>
+                <a:latin typeface="Arial"/>
+              </a:rPr>
+              <a:t>わたしの心が見出す万の理由</a:t>
+            </a:r>
+          </a:p>
+        </p:txBody>
+      </p:sp>
+      <p:sp>
+        <p:nvSpPr>
+          <p:cNvPr id="5" name="TextBox 4"/>
+          <p:cNvSpPr txBox="1"/>
+          <p:nvPr/>
+        </p:nvSpPr>
+        <p:spPr>
+          <a:xfrm>
+            <a:off x="640080" y="4494276"/>
+            <a:ext cx="10911535" cy="310896"/>
+          </a:xfrm>
+          <a:prstGeom prst="rect">
+            <a:avLst/>
+          </a:prstGeom>
+          <a:noFill/>
+        </p:spPr>
+        <p:txBody>
+          <a:bodyPr wrap="square">
+            <a:spAutoFit/>
+          </a:bodyPr>
+          <a:lstStyle/>
+          <a:p>
+            <a:pPr algn="ctr"/>
+            <a:r>
+              <a:rPr sz="2000" b="0" i="0">
+                <a:solidFill>
+                  <a:srgbClr val="828282"/>
+                </a:solidFill>
+                <a:latin typeface="Arial"/>
+              </a:rPr>
+              <a:t>主をほめたたえよ</a:t>
+            </a:r>
+          </a:p>
+        </p:txBody>
+      </p:sp>
     </p:spTree>
   </p:cSld>
   <p:clrMapOvr>
@@ -6139,6 +7049,76 @@
                 <a:latin typeface="Arial"/>
               </a:rPr>
               <a:t>Quando o fim vem</a:t>
+            </a:r>
+          </a:p>
+        </p:txBody>
+      </p:sp>
+      <p:sp>
+        <p:nvSpPr>
+          <p:cNvPr id="4" name="TextBox 3"/>
+          <p:cNvSpPr txBox="1"/>
+          <p:nvPr/>
+        </p:nvSpPr>
+        <p:spPr>
+          <a:xfrm>
+            <a:off x="640080" y="4128516"/>
+            <a:ext cx="10911535" cy="310896"/>
+          </a:xfrm>
+          <a:prstGeom prst="rect">
+            <a:avLst/>
+          </a:prstGeom>
+          <a:noFill/>
+        </p:spPr>
+        <p:txBody>
+          <a:bodyPr wrap="square">
+            <a:spAutoFit/>
+          </a:bodyPr>
+          <a:lstStyle/>
+          <a:p>
+            <a:pPr algn="ctr"/>
+            <a:r>
+              <a:rPr sz="2000" b="0" i="0">
+                <a:solidFill>
+                  <a:srgbClr val="828282"/>
+                </a:solidFill>
+                <a:latin typeface="Arial"/>
+              </a:rPr>
+              <a:t>主の力が尽きる日にも</a:t>
+            </a:r>
+          </a:p>
+        </p:txBody>
+      </p:sp>
+      <p:sp>
+        <p:nvSpPr>
+          <p:cNvPr id="5" name="TextBox 4"/>
+          <p:cNvSpPr txBox="1"/>
+          <p:nvPr/>
+        </p:nvSpPr>
+        <p:spPr>
+          <a:xfrm>
+            <a:off x="640080" y="4494276"/>
+            <a:ext cx="10911535" cy="310896"/>
+          </a:xfrm>
+          <a:prstGeom prst="rect">
+            <a:avLst/>
+          </a:prstGeom>
+          <a:noFill/>
+        </p:spPr>
+        <p:txBody>
+          <a:bodyPr wrap="square">
+            <a:spAutoFit/>
+          </a:bodyPr>
+          <a:lstStyle/>
+          <a:p>
+            <a:pPr algn="ctr"/>
+            <a:r>
+              <a:rPr sz="2000" b="0" i="0">
+                <a:solidFill>
+                  <a:srgbClr val="828282"/>
+                </a:solidFill>
+                <a:latin typeface="Arial"/>
+              </a:rPr>
+              <a:t>終わりが来るとき</a:t>
             </a:r>
           </a:p>
         </p:txBody>

</xml_diff>